<commit_message>
a ppt szerintem jó (Ádám)
</commit_message>
<xml_diff>
--- a/doc/CrossCountryWebshop_Premium (1).pptx
+++ b/doc/CrossCountryWebshop_Premium (1).pptx
@@ -2,24 +2,24 @@
 <file path=ppt/presentation.xml><?xml version="1.0" encoding="utf-8"?>
 <p:presentation xmlns:a="http://schemas.openxmlformats.org/drawingml/2006/main" xmlns:r="http://schemas.openxmlformats.org/officeDocument/2006/relationships" xmlns:p="http://schemas.openxmlformats.org/presentationml/2006/main" saveSubsetFonts="1" autoCompressPictures="0">
   <p:sldMasterIdLst>
-    <p:sldMasterId id="2147483648" r:id="rId1"/>
+    <p:sldMasterId id="2147483648" r:id="rId4"/>
   </p:sldMasterIdLst>
   <p:notesMasterIdLst>
-    <p:notesMasterId r:id="rId14"/>
+    <p:notesMasterId r:id="rId17"/>
   </p:notesMasterIdLst>
   <p:sldIdLst>
-    <p:sldId id="256" r:id="rId2"/>
-    <p:sldId id="257" r:id="rId3"/>
-    <p:sldId id="258" r:id="rId4"/>
-    <p:sldId id="259" r:id="rId5"/>
-    <p:sldId id="260" r:id="rId6"/>
-    <p:sldId id="261" r:id="rId7"/>
-    <p:sldId id="262" r:id="rId8"/>
-    <p:sldId id="263" r:id="rId9"/>
-    <p:sldId id="264" r:id="rId10"/>
-    <p:sldId id="265" r:id="rId11"/>
-    <p:sldId id="266" r:id="rId12"/>
-    <p:sldId id="267" r:id="rId13"/>
+    <p:sldId id="256" r:id="rId5"/>
+    <p:sldId id="257" r:id="rId6"/>
+    <p:sldId id="258" r:id="rId7"/>
+    <p:sldId id="259" r:id="rId8"/>
+    <p:sldId id="260" r:id="rId9"/>
+    <p:sldId id="261" r:id="rId10"/>
+    <p:sldId id="262" r:id="rId11"/>
+    <p:sldId id="263" r:id="rId12"/>
+    <p:sldId id="264" r:id="rId13"/>
+    <p:sldId id="265" r:id="rId14"/>
+    <p:sldId id="266" r:id="rId15"/>
+    <p:sldId id="267" r:id="rId16"/>
   </p:sldIdLst>
   <p:sldSz cx="9144000" cy="5143500" type="screen16x9"/>
   <p:notesSz cx="5143500" cy="9144000"/>
@@ -1595,24 +1595,28 @@
       </p:grpSpPr>
       <p:pic>
         <p:nvPicPr>
-          <p:cNvPr id="2" name="Image 0" descr="/home/claude/unpacked_clean/ppt/media/image1.jpeg"/>
+          <p:cNvPr id="15" name="Kép 14">
+            <a:extLst>
+              <a:ext uri="{FF2B5EF4-FFF2-40B4-BE49-F238E27FC236}">
+                <a16:creationId xmlns:a16="http://schemas.microsoft.com/office/drawing/2014/main" id="{87BB9D71-BF6E-613D-69E6-EFC477C694B2}"/>
+              </a:ext>
+            </a:extLst>
+          </p:cNvPr>
           <p:cNvPicPr>
             <a:picLocks noChangeAspect="1"/>
           </p:cNvPicPr>
           <p:nvPr/>
         </p:nvPicPr>
         <p:blipFill>
-          <a:blip r:embed="rId3">
-            <a:alphaModFix amt="62000"/>
-          </a:blip>
+          <a:blip r:embed="rId3"/>
           <a:stretch>
             <a:fillRect/>
           </a:stretch>
         </p:blipFill>
         <p:spPr>
           <a:xfrm>
-            <a:off x="0" y="0"/>
-            <a:ext cx="9144000" cy="5143500"/>
+            <a:off x="4000500" y="41148"/>
+            <a:ext cx="5143500" cy="5042916"/>
           </a:xfrm>
           <a:prstGeom prst="rect">
             <a:avLst/>
@@ -1742,7 +1746,7 @@
               <a:buNone/>
             </a:pPr>
             <a:r>
-              <a:rPr lang="en-US" sz="900" b="1" kern="0" spc="300" dirty="0">
+              <a:rPr lang="en-US" sz="1200" b="1" kern="0" spc="300" dirty="0">
                 <a:solidFill>
                   <a:srgbClr val="E9A227"/>
                 </a:solidFill>
@@ -1752,7 +1756,7 @@
               </a:rPr>
               <a:t>PROJEKT BEMUTATÓ</a:t>
             </a:r>
-            <a:endParaRPr lang="en-US" sz="900" dirty="0"/>
+            <a:endParaRPr lang="en-US" sz="1200" dirty="0"/>
           </a:p>
         </p:txBody>
       </p:sp>
@@ -1858,8 +1862,8 @@
         </p:nvSpPr>
         <p:spPr>
           <a:xfrm>
-            <a:off x="207498" y="3504262"/>
-            <a:ext cx="6144065" cy="868680"/>
+            <a:off x="98473" y="3145536"/>
+            <a:ext cx="5451231" cy="629530"/>
           </a:xfrm>
           <a:prstGeom prst="rect">
             <a:avLst/>
@@ -1871,14 +1875,13 @@
           <a:bodyPr wrap="square" lIns="0" tIns="0" rIns="0" bIns="0" rtlCol="0" anchor="ctr"/>
           <a:lstStyle/>
           <a:p>
-            <a:pPr marL="0" indent="0">
+            <a:pPr>
               <a:lnSpc>
                 <a:spcPct val="155000"/>
               </a:lnSpc>
-              <a:buNone/>
             </a:pPr>
             <a:r>
-              <a:rPr lang="en-US" sz="1400" dirty="0">
+              <a:rPr lang="en-US" sz="1200" i="1" dirty="0">
                 <a:solidFill>
                   <a:srgbClr val="C5D5E8"/>
                 </a:solidFill>
@@ -1889,7 +1892,7 @@
               <a:t>Architektúra  ·  Funkciók  ·  </a:t>
             </a:r>
             <a:r>
-              <a:rPr lang="en-US" sz="1400" dirty="0" err="1">
+              <a:rPr lang="en-US" sz="1200" i="1" dirty="0" err="1">
                 <a:solidFill>
                   <a:srgbClr val="C5D5E8"/>
                 </a:solidFill>
@@ -1897,30 +1900,10 @@
                 <a:ea typeface="Trebuchet MS" pitchFamily="34" charset="-122"/>
                 <a:cs typeface="Trebuchet MS" pitchFamily="34" charset="-120"/>
               </a:rPr>
-              <a:t>Tokenizáció</a:t>
-            </a:r>
-            <a:endParaRPr lang="hu-HU" sz="1400" dirty="0">
-              <a:solidFill>
-                <a:srgbClr val="C5D5E8"/>
-              </a:solidFill>
-              <a:latin typeface="Trebuchet MS" pitchFamily="34" charset="0"/>
-              <a:ea typeface="Trebuchet MS" pitchFamily="34" charset="-122"/>
-              <a:cs typeface="Trebuchet MS" pitchFamily="34" charset="-120"/>
-            </a:endParaRPr>
-          </a:p>
-          <a:p>
-            <a:pPr marL="0" indent="0">
-              <a:lnSpc>
-                <a:spcPct val="155000"/>
-              </a:lnSpc>
-              <a:buNone/>
-            </a:pPr>
-            <a:r>
-              <a:rPr lang="hu-HU" sz="1400" dirty="0"/>
-              <a:t> </a:t>
-            </a:r>
-            <a:r>
-              <a:rPr lang="en-US" sz="1400" dirty="0" err="1">
+              <a:t>Tokenizáci</a:t>
+            </a:r>
+            <a:r>
+              <a:rPr lang="hu-HU" sz="1200" i="1" dirty="0">
                 <a:solidFill>
                   <a:srgbClr val="C5D5E8"/>
                 </a:solidFill>
@@ -1928,10 +1911,10 @@
                 <a:ea typeface="Trebuchet MS" pitchFamily="34" charset="-122"/>
                 <a:cs typeface="Trebuchet MS" pitchFamily="34" charset="-120"/>
               </a:rPr>
-              <a:t>Végponthívás</a:t>
-            </a:r>
-            <a:r>
-              <a:rPr lang="en-US" sz="1400" dirty="0">
+              <a:t>ó</a:t>
+            </a:r>
+            <a:r>
+              <a:rPr lang="en-US" sz="1200" i="1" dirty="0">
                 <a:solidFill>
                   <a:srgbClr val="C5D5E8"/>
                 </a:solidFill>
@@ -1939,80 +1922,74 @@
                 <a:ea typeface="Trebuchet MS" pitchFamily="34" charset="-122"/>
                 <a:cs typeface="Trebuchet MS" pitchFamily="34" charset="-120"/>
               </a:rPr>
-              <a:t>  ·  Munkamegosztás</a:t>
-            </a:r>
-            <a:endParaRPr lang="en-US" sz="1400" dirty="0"/>
-          </a:p>
-        </p:txBody>
-      </p:sp>
-      <p:sp>
-        <p:nvSpPr>
-          <p:cNvPr id="10" name="Shape 7"/>
-          <p:cNvSpPr/>
-          <p:nvPr/>
-        </p:nvSpPr>
-        <p:spPr>
-          <a:xfrm>
-            <a:off x="0" y="5102352"/>
-            <a:ext cx="9144000" cy="41148"/>
-          </a:xfrm>
-          <a:prstGeom prst="rect">
-            <a:avLst/>
-          </a:prstGeom>
-          <a:solidFill>
-            <a:srgbClr val="1F3050"/>
-          </a:solidFill>
-          <a:ln w="12700">
-            <a:solidFill>
-              <a:srgbClr val="1F3050"/>
-            </a:solidFill>
-            <a:prstDash val="solid"/>
-          </a:ln>
-        </p:spPr>
-        <p:txBody>
-          <a:bodyPr/>
-          <a:lstStyle/>
-          <a:p>
-            <a:endParaRPr lang="hu-HU"/>
-          </a:p>
-        </p:txBody>
-      </p:sp>
-      <p:sp>
-        <p:nvSpPr>
-          <p:cNvPr id="11" name="Text 8"/>
-          <p:cNvSpPr/>
-          <p:nvPr/>
-        </p:nvSpPr>
-        <p:spPr>
-          <a:xfrm>
-            <a:off x="8503920" y="4882896"/>
-            <a:ext cx="502920" cy="201168"/>
-          </a:xfrm>
-          <a:prstGeom prst="rect">
-            <a:avLst/>
-          </a:prstGeom>
-          <a:noFill/>
-          <a:ln/>
-        </p:spPr>
-        <p:txBody>
-          <a:bodyPr wrap="square" lIns="0" tIns="0" rIns="0" bIns="0" rtlCol="0" anchor="ctr"/>
-          <a:lstStyle/>
-          <a:p>
-            <a:pPr marL="0" indent="0" algn="r">
-              <a:buNone/>
-            </a:pPr>
-            <a:r>
-              <a:rPr lang="en-US" sz="900" dirty="0">
-                <a:solidFill>
-                  <a:srgbClr val="5C7A9B"/>
+              <a:t> ·</a:t>
+            </a:r>
+            <a:r>
+              <a:rPr lang="hu-HU" sz="1200" i="1" dirty="0">
+                <a:solidFill>
+                  <a:srgbClr val="C5D5E8"/>
                 </a:solidFill>
                 <a:latin typeface="Trebuchet MS" pitchFamily="34" charset="0"/>
                 <a:ea typeface="Trebuchet MS" pitchFamily="34" charset="-122"/>
                 <a:cs typeface="Trebuchet MS" pitchFamily="34" charset="-120"/>
               </a:rPr>
-              <a:t>01</a:t>
-            </a:r>
-            <a:endParaRPr lang="en-US" sz="900" dirty="0"/>
+              <a:t> API </a:t>
+            </a:r>
+            <a:r>
+              <a:rPr lang="hu-HU" sz="1200" i="1" dirty="0" err="1">
+                <a:solidFill>
+                  <a:srgbClr val="C5D5E8"/>
+                </a:solidFill>
+                <a:latin typeface="Trebuchet MS" pitchFamily="34" charset="0"/>
+                <a:ea typeface="Trebuchet MS" pitchFamily="34" charset="-122"/>
+                <a:cs typeface="Trebuchet MS" pitchFamily="34" charset="-120"/>
+              </a:rPr>
+              <a:t>endpointok</a:t>
+            </a:r>
+            <a:r>
+              <a:rPr lang="en-US" sz="1200" i="1" dirty="0">
+                <a:solidFill>
+                  <a:srgbClr val="C5D5E8"/>
+                </a:solidFill>
+                <a:latin typeface="Trebuchet MS" pitchFamily="34" charset="0"/>
+                <a:ea typeface="Trebuchet MS" pitchFamily="34" charset="-122"/>
+                <a:cs typeface="Trebuchet MS" pitchFamily="34" charset="-120"/>
+              </a:rPr>
+              <a:t>  ·  Munkamegosztás</a:t>
+            </a:r>
+            <a:endParaRPr lang="en-US" sz="1200" i="1" dirty="0"/>
+          </a:p>
+        </p:txBody>
+      </p:sp>
+      <p:sp>
+        <p:nvSpPr>
+          <p:cNvPr id="10" name="Shape 7"/>
+          <p:cNvSpPr/>
+          <p:nvPr/>
+        </p:nvSpPr>
+        <p:spPr>
+          <a:xfrm>
+            <a:off x="0" y="5102352"/>
+            <a:ext cx="9144000" cy="41148"/>
+          </a:xfrm>
+          <a:prstGeom prst="rect">
+            <a:avLst/>
+          </a:prstGeom>
+          <a:solidFill>
+            <a:srgbClr val="1F3050"/>
+          </a:solidFill>
+          <a:ln w="12700">
+            <a:solidFill>
+              <a:srgbClr val="1F3050"/>
+            </a:solidFill>
+            <a:prstDash val="solid"/>
+          </a:ln>
+        </p:spPr>
+        <p:txBody>
+          <a:bodyPr/>
+          <a:lstStyle/>
+          <a:p>
+            <a:endParaRPr lang="hu-HU"/>
           </a:p>
         </p:txBody>
       </p:sp>
@@ -2280,7 +2257,7 @@
               <a:buNone/>
             </a:pPr>
             <a:r>
-              <a:rPr lang="en-US" sz="1500" b="1" dirty="0">
+              <a:rPr lang="en-US" sz="2000" b="1" dirty="0">
                 <a:solidFill>
                   <a:srgbClr val="0B1628"/>
                 </a:solidFill>
@@ -2290,7 +2267,7 @@
               </a:rPr>
               <a:t>Ádám</a:t>
             </a:r>
-            <a:endParaRPr lang="en-US" sz="1500" dirty="0"/>
+            <a:endParaRPr lang="en-US" sz="2000" dirty="0"/>
           </a:p>
         </p:txBody>
       </p:sp>
@@ -2319,7 +2296,7 @@
               <a:buNone/>
             </a:pPr>
             <a:r>
-              <a:rPr lang="en-US" sz="900" dirty="0">
+              <a:rPr lang="en-US" sz="1400" dirty="0">
                 <a:solidFill>
                   <a:srgbClr val="0B1628"/>
                 </a:solidFill>
@@ -2329,39 +2306,7 @@
               </a:rPr>
               <a:t>Frontend Developer</a:t>
             </a:r>
-            <a:endParaRPr lang="en-US" sz="900" dirty="0"/>
-          </a:p>
-        </p:txBody>
-      </p:sp>
-      <p:sp>
-        <p:nvSpPr>
-          <p:cNvPr id="11" name="Shape 9"/>
-          <p:cNvSpPr/>
-          <p:nvPr/>
-        </p:nvSpPr>
-        <p:spPr>
-          <a:xfrm>
-            <a:off x="530352" y="2084832"/>
-            <a:ext cx="82296" cy="82296"/>
-          </a:xfrm>
-          <a:prstGeom prst="rect">
-            <a:avLst/>
-          </a:prstGeom>
-          <a:solidFill>
-            <a:srgbClr val="E9A227"/>
-          </a:solidFill>
-          <a:ln w="12700">
-            <a:solidFill>
-              <a:srgbClr val="E9A227"/>
-            </a:solidFill>
-            <a:prstDash val="solid"/>
-          </a:ln>
-        </p:spPr>
-        <p:txBody>
-          <a:bodyPr/>
-          <a:lstStyle/>
-          <a:p>
-            <a:endParaRPr lang="hu-HU"/>
+            <a:endParaRPr lang="en-US" sz="1400" dirty="0"/>
           </a:p>
         </p:txBody>
       </p:sp>
@@ -2373,8 +2318,8 @@
         </p:nvSpPr>
         <p:spPr>
           <a:xfrm>
-            <a:off x="694944" y="1947672"/>
-            <a:ext cx="2231136" cy="438912"/>
+            <a:off x="514174" y="1896325"/>
+            <a:ext cx="2512490" cy="438912"/>
           </a:xfrm>
           <a:prstGeom prst="rect">
             <a:avLst/>
@@ -2390,7 +2335,7 @@
               <a:buNone/>
             </a:pPr>
             <a:r>
-              <a:rPr lang="en-US" sz="1150" dirty="0">
+              <a:rPr lang="en-US" sz="1600" dirty="0">
                 <a:solidFill>
                   <a:srgbClr val="C5D5E8"/>
                 </a:solidFill>
@@ -2400,39 +2345,7 @@
               </a:rPr>
               <a:t>Frontend fejlesztés (React)</a:t>
             </a:r>
-            <a:endParaRPr lang="en-US" sz="1150" dirty="0"/>
-          </a:p>
-        </p:txBody>
-      </p:sp>
-      <p:sp>
-        <p:nvSpPr>
-          <p:cNvPr id="13" name="Shape 11"/>
-          <p:cNvSpPr/>
-          <p:nvPr/>
-        </p:nvSpPr>
-        <p:spPr>
-          <a:xfrm>
-            <a:off x="530352" y="2560320"/>
-            <a:ext cx="82296" cy="82296"/>
-          </a:xfrm>
-          <a:prstGeom prst="rect">
-            <a:avLst/>
-          </a:prstGeom>
-          <a:solidFill>
-            <a:srgbClr val="E9A227"/>
-          </a:solidFill>
-          <a:ln w="12700">
-            <a:solidFill>
-              <a:srgbClr val="E9A227"/>
-            </a:solidFill>
-            <a:prstDash val="solid"/>
-          </a:ln>
-        </p:spPr>
-        <p:txBody>
-          <a:bodyPr/>
-          <a:lstStyle/>
-          <a:p>
-            <a:endParaRPr lang="hu-HU"/>
+            <a:endParaRPr lang="en-US" sz="1600" dirty="0"/>
           </a:p>
         </p:txBody>
       </p:sp>
@@ -2444,8 +2357,8 @@
         </p:nvSpPr>
         <p:spPr>
           <a:xfrm>
-            <a:off x="694944" y="2423160"/>
-            <a:ext cx="2231136" cy="438912"/>
+            <a:off x="512064" y="2347722"/>
+            <a:ext cx="2329610" cy="438912"/>
           </a:xfrm>
           <a:prstGeom prst="rect">
             <a:avLst/>
@@ -2461,7 +2374,7 @@
               <a:buNone/>
             </a:pPr>
             <a:r>
-              <a:rPr lang="en-US" sz="1150" dirty="0">
+              <a:rPr lang="en-US" sz="1600" dirty="0">
                 <a:solidFill>
                   <a:srgbClr val="C5D5E8"/>
                 </a:solidFill>
@@ -2471,39 +2384,7 @@
               </a:rPr>
               <a:t>API integráció</a:t>
             </a:r>
-            <a:endParaRPr lang="en-US" sz="1150" dirty="0"/>
-          </a:p>
-        </p:txBody>
-      </p:sp>
-      <p:sp>
-        <p:nvSpPr>
-          <p:cNvPr id="15" name="Shape 13"/>
-          <p:cNvSpPr/>
-          <p:nvPr/>
-        </p:nvSpPr>
-        <p:spPr>
-          <a:xfrm>
-            <a:off x="530352" y="3035808"/>
-            <a:ext cx="82296" cy="82296"/>
-          </a:xfrm>
-          <a:prstGeom prst="rect">
-            <a:avLst/>
-          </a:prstGeom>
-          <a:solidFill>
-            <a:srgbClr val="E9A227"/>
-          </a:solidFill>
-          <a:ln w="12700">
-            <a:solidFill>
-              <a:srgbClr val="E9A227"/>
-            </a:solidFill>
-            <a:prstDash val="solid"/>
-          </a:ln>
-        </p:spPr>
-        <p:txBody>
-          <a:bodyPr/>
-          <a:lstStyle/>
-          <a:p>
-            <a:endParaRPr lang="hu-HU"/>
+            <a:endParaRPr lang="en-US" sz="1600" dirty="0"/>
           </a:p>
         </p:txBody>
       </p:sp>
@@ -2515,8 +2396,8 @@
         </p:nvSpPr>
         <p:spPr>
           <a:xfrm>
-            <a:off x="694944" y="2898648"/>
-            <a:ext cx="2231136" cy="438912"/>
+            <a:off x="514174" y="2805836"/>
+            <a:ext cx="2329610" cy="438912"/>
           </a:xfrm>
           <a:prstGeom prst="rect">
             <a:avLst/>
@@ -2532,7 +2413,7 @@
               <a:buNone/>
             </a:pPr>
             <a:r>
-              <a:rPr lang="en-US" sz="1150" dirty="0">
+              <a:rPr lang="en-US" sz="1600" dirty="0" err="1">
                 <a:solidFill>
                   <a:srgbClr val="C5D5E8"/>
                 </a:solidFill>
@@ -2540,41 +2421,31 @@
                 <a:ea typeface="Trebuchet MS" pitchFamily="34" charset="-122"/>
                 <a:cs typeface="Trebuchet MS" pitchFamily="34" charset="-120"/>
               </a:rPr>
-              <a:t>Reszponzív (mobile-ready) design</a:t>
-            </a:r>
-            <a:endParaRPr lang="en-US" sz="1150" dirty="0"/>
-          </a:p>
-        </p:txBody>
-      </p:sp>
-      <p:sp>
-        <p:nvSpPr>
-          <p:cNvPr id="17" name="Shape 15"/>
-          <p:cNvSpPr/>
-          <p:nvPr/>
-        </p:nvSpPr>
-        <p:spPr>
-          <a:xfrm>
-            <a:off x="530352" y="3511296"/>
-            <a:ext cx="82296" cy="82296"/>
-          </a:xfrm>
-          <a:prstGeom prst="rect">
-            <a:avLst/>
-          </a:prstGeom>
-          <a:solidFill>
-            <a:srgbClr val="E9A227"/>
-          </a:solidFill>
-          <a:ln w="12700">
-            <a:solidFill>
-              <a:srgbClr val="E9A227"/>
-            </a:solidFill>
-            <a:prstDash val="solid"/>
-          </a:ln>
-        </p:spPr>
-        <p:txBody>
-          <a:bodyPr/>
-          <a:lstStyle/>
-          <a:p>
-            <a:endParaRPr lang="hu-HU"/>
+              <a:t>Reszponzív</a:t>
+            </a:r>
+            <a:r>
+              <a:rPr lang="hu-HU" sz="1600" dirty="0">
+                <a:solidFill>
+                  <a:srgbClr val="C5D5E8"/>
+                </a:solidFill>
+                <a:latin typeface="Trebuchet MS" pitchFamily="34" charset="0"/>
+                <a:ea typeface="Trebuchet MS" pitchFamily="34" charset="-122"/>
+                <a:cs typeface="Trebuchet MS" pitchFamily="34" charset="-120"/>
+              </a:rPr>
+              <a:t> </a:t>
+            </a:r>
+            <a:r>
+              <a:rPr lang="en-US" sz="1600" dirty="0">
+                <a:solidFill>
+                  <a:srgbClr val="C5D5E8"/>
+                </a:solidFill>
+                <a:latin typeface="Trebuchet MS" pitchFamily="34" charset="0"/>
+                <a:ea typeface="Trebuchet MS" pitchFamily="34" charset="-122"/>
+                <a:cs typeface="Trebuchet MS" pitchFamily="34" charset="-120"/>
+              </a:rPr>
+              <a:t>design</a:t>
+            </a:r>
+            <a:endParaRPr lang="en-US" sz="1600" dirty="0"/>
           </a:p>
         </p:txBody>
       </p:sp>
@@ -2586,8 +2457,8 @@
         </p:nvSpPr>
         <p:spPr>
           <a:xfrm>
-            <a:off x="694944" y="3374136"/>
-            <a:ext cx="2231136" cy="438912"/>
+            <a:off x="512064" y="3281324"/>
+            <a:ext cx="2329610" cy="438912"/>
           </a:xfrm>
           <a:prstGeom prst="rect">
             <a:avLst/>
@@ -2603,7 +2474,7 @@
               <a:buNone/>
             </a:pPr>
             <a:r>
-              <a:rPr lang="en-US" sz="1150" dirty="0">
+              <a:rPr lang="en-US" sz="1600" dirty="0">
                 <a:solidFill>
                   <a:srgbClr val="C5D5E8"/>
                 </a:solidFill>
@@ -2613,39 +2484,7 @@
               </a:rPr>
               <a:t>UI / UX</a:t>
             </a:r>
-            <a:endParaRPr lang="en-US" sz="1150" dirty="0"/>
-          </a:p>
-        </p:txBody>
-      </p:sp>
-      <p:sp>
-        <p:nvSpPr>
-          <p:cNvPr id="19" name="Shape 17"/>
-          <p:cNvSpPr/>
-          <p:nvPr/>
-        </p:nvSpPr>
-        <p:spPr>
-          <a:xfrm>
-            <a:off x="530352" y="3986784"/>
-            <a:ext cx="82296" cy="82296"/>
-          </a:xfrm>
-          <a:prstGeom prst="rect">
-            <a:avLst/>
-          </a:prstGeom>
-          <a:solidFill>
-            <a:srgbClr val="E9A227"/>
-          </a:solidFill>
-          <a:ln w="12700">
-            <a:solidFill>
-              <a:srgbClr val="E9A227"/>
-            </a:solidFill>
-            <a:prstDash val="solid"/>
-          </a:ln>
-        </p:spPr>
-        <p:txBody>
-          <a:bodyPr/>
-          <a:lstStyle/>
-          <a:p>
-            <a:endParaRPr lang="hu-HU"/>
+            <a:endParaRPr lang="en-US" sz="1600" dirty="0"/>
           </a:p>
         </p:txBody>
       </p:sp>
@@ -2657,8 +2496,8 @@
         </p:nvSpPr>
         <p:spPr>
           <a:xfrm>
-            <a:off x="694944" y="3849624"/>
-            <a:ext cx="2231136" cy="438912"/>
+            <a:off x="514174" y="3713072"/>
+            <a:ext cx="2512490" cy="438912"/>
           </a:xfrm>
           <a:prstGeom prst="rect">
             <a:avLst/>
@@ -2670,21 +2509,48 @@
           <a:bodyPr wrap="square" lIns="0" tIns="0" rIns="0" bIns="0" rtlCol="0" anchor="ctr"/>
           <a:lstStyle/>
           <a:p>
-            <a:pPr marL="0" indent="0">
-              <a:buNone/>
-            </a:pPr>
-            <a:r>
-              <a:rPr lang="en-US" sz="1150" dirty="0">
+            <a:r>
+              <a:rPr lang="hu-HU" sz="1600" dirty="0" err="1">
                 <a:solidFill>
                   <a:srgbClr val="C5D5E8"/>
                 </a:solidFill>
                 <a:latin typeface="Trebuchet MS" pitchFamily="34" charset="0"/>
-                <a:ea typeface="Trebuchet MS" pitchFamily="34" charset="-122"/>
-                <a:cs typeface="Trebuchet MS" pitchFamily="34" charset="-120"/>
-              </a:rPr>
-              <a:t>Token és role kezelés a kliens oldalon</a:t>
-            </a:r>
-            <a:endParaRPr lang="en-US" sz="1150" dirty="0"/>
+              </a:rPr>
+              <a:t>Token</a:t>
+            </a:r>
+            <a:r>
+              <a:rPr lang="hu-HU" sz="1600" dirty="0">
+                <a:solidFill>
+                  <a:srgbClr val="C5D5E8"/>
+                </a:solidFill>
+                <a:latin typeface="Trebuchet MS" pitchFamily="34" charset="0"/>
+              </a:rPr>
+              <a:t> / </a:t>
+            </a:r>
+            <a:r>
+              <a:rPr lang="hu-HU" sz="1600" dirty="0" err="1">
+                <a:solidFill>
+                  <a:srgbClr val="C5D5E8"/>
+                </a:solidFill>
+                <a:latin typeface="Trebuchet MS" pitchFamily="34" charset="0"/>
+              </a:rPr>
+              <a:t>role</a:t>
+            </a:r>
+            <a:r>
+              <a:rPr lang="hu-HU" sz="1600" dirty="0">
+                <a:solidFill>
+                  <a:srgbClr val="C5D5E8"/>
+                </a:solidFill>
+                <a:latin typeface="Trebuchet MS" pitchFamily="34" charset="0"/>
+              </a:rPr>
+              <a:t> kezelés</a:t>
+            </a:r>
+            <a:endParaRPr lang="en-US" sz="1600" dirty="0">
+              <a:solidFill>
+                <a:srgbClr val="C5D5E8"/>
+              </a:solidFill>
+              <a:latin typeface="Trebuchet MS" pitchFamily="34" charset="0"/>
+            </a:endParaRPr>
           </a:p>
         </p:txBody>
       </p:sp>
@@ -2784,7 +2650,7 @@
               <a:buNone/>
             </a:pPr>
             <a:r>
-              <a:rPr lang="en-US" sz="1500" b="1" dirty="0">
+              <a:rPr lang="en-US" sz="2000" b="1" dirty="0">
                 <a:solidFill>
                   <a:srgbClr val="0B1628"/>
                 </a:solidFill>
@@ -2794,7 +2660,7 @@
               </a:rPr>
               <a:t>Github &amp; Discord</a:t>
             </a:r>
-            <a:endParaRPr lang="en-US" sz="1500" dirty="0"/>
+            <a:endParaRPr lang="en-US" sz="2000" dirty="0"/>
           </a:p>
         </p:txBody>
       </p:sp>
@@ -2806,8 +2672,8 @@
         </p:nvSpPr>
         <p:spPr>
           <a:xfrm>
-            <a:off x="3364992" y="1581912"/>
-            <a:ext cx="2441448" cy="182880"/>
+            <a:off x="3364991" y="1581912"/>
+            <a:ext cx="2519993" cy="182880"/>
           </a:xfrm>
           <a:prstGeom prst="rect">
             <a:avLst/>
@@ -2823,7 +2689,7 @@
               <a:buNone/>
             </a:pPr>
             <a:r>
-              <a:rPr lang="en-US" sz="900" dirty="0">
+              <a:rPr lang="en-US" sz="1400" dirty="0" err="1">
                 <a:solidFill>
                   <a:srgbClr val="0B1628"/>
                 </a:solidFill>
@@ -2831,41 +2697,42 @@
                 <a:ea typeface="Trebuchet MS" pitchFamily="34" charset="-122"/>
                 <a:cs typeface="Trebuchet MS" pitchFamily="34" charset="-120"/>
               </a:rPr>
-              <a:t>Verziókezelés &amp; Kommunikáció</a:t>
-            </a:r>
-            <a:endParaRPr lang="en-US" sz="900" dirty="0"/>
-          </a:p>
-        </p:txBody>
-      </p:sp>
-      <p:sp>
-        <p:nvSpPr>
-          <p:cNvPr id="25" name="Shape 23"/>
-          <p:cNvSpPr/>
-          <p:nvPr/>
-        </p:nvSpPr>
-        <p:spPr>
-          <a:xfrm>
-            <a:off x="3383280" y="2084832"/>
-            <a:ext cx="82296" cy="82296"/>
-          </a:xfrm>
-          <a:prstGeom prst="rect">
-            <a:avLst/>
-          </a:prstGeom>
-          <a:solidFill>
-            <a:srgbClr val="E9A227"/>
-          </a:solidFill>
-          <a:ln w="12700">
-            <a:solidFill>
-              <a:srgbClr val="E9A227"/>
-            </a:solidFill>
-            <a:prstDash val="solid"/>
-          </a:ln>
-        </p:spPr>
-        <p:txBody>
-          <a:bodyPr/>
-          <a:lstStyle/>
-          <a:p>
-            <a:endParaRPr lang="hu-HU"/>
+              <a:t>Verziókezelés</a:t>
+            </a:r>
+            <a:r>
+              <a:rPr lang="en-US" sz="1400" dirty="0">
+                <a:solidFill>
+                  <a:srgbClr val="0B1628"/>
+                </a:solidFill>
+                <a:latin typeface="Trebuchet MS" pitchFamily="34" charset="0"/>
+                <a:ea typeface="Trebuchet MS" pitchFamily="34" charset="-122"/>
+                <a:cs typeface="Trebuchet MS" pitchFamily="34" charset="-120"/>
+              </a:rPr>
+              <a:t> </a:t>
+            </a:r>
+            <a:r>
+              <a:rPr lang="hu-HU" sz="1400" dirty="0">
+                <a:solidFill>
+                  <a:srgbClr val="0B1628"/>
+                </a:solidFill>
+                <a:latin typeface="Trebuchet MS" pitchFamily="34" charset="0"/>
+                <a:ea typeface="Trebuchet MS" pitchFamily="34" charset="-122"/>
+                <a:cs typeface="Trebuchet MS" pitchFamily="34" charset="-120"/>
+              </a:rPr>
+              <a:t>&amp;</a:t>
+            </a:r>
+            <a:r>
+              <a:rPr lang="en-US" sz="1400" dirty="0">
+                <a:solidFill>
+                  <a:srgbClr val="0B1628"/>
+                </a:solidFill>
+                <a:latin typeface="Trebuchet MS" pitchFamily="34" charset="0"/>
+                <a:ea typeface="Trebuchet MS" pitchFamily="34" charset="-122"/>
+                <a:cs typeface="Trebuchet MS" pitchFamily="34" charset="-120"/>
+              </a:rPr>
+              <a:t> Kommunikáció</a:t>
+            </a:r>
+            <a:endParaRPr lang="en-US" sz="1400" dirty="0"/>
           </a:p>
         </p:txBody>
       </p:sp>
@@ -2877,7 +2744,7 @@
         </p:nvSpPr>
         <p:spPr>
           <a:xfrm>
-            <a:off x="3547872" y="1947672"/>
+            <a:off x="3364992" y="1896325"/>
             <a:ext cx="2231136" cy="438912"/>
           </a:xfrm>
           <a:prstGeom prst="rect">
@@ -2894,7 +2761,7 @@
               <a:buNone/>
             </a:pPr>
             <a:r>
-              <a:rPr lang="en-US" sz="1150" dirty="0">
+              <a:rPr lang="en-US" sz="1600" dirty="0">
                 <a:solidFill>
                   <a:srgbClr val="C5D5E8"/>
                 </a:solidFill>
@@ -2904,39 +2771,7 @@
               </a:rPr>
               <a:t>Feladatok megbeszélése</a:t>
             </a:r>
-            <a:endParaRPr lang="en-US" sz="1150" dirty="0"/>
-          </a:p>
-        </p:txBody>
-      </p:sp>
-      <p:sp>
-        <p:nvSpPr>
-          <p:cNvPr id="27" name="Shape 25"/>
-          <p:cNvSpPr/>
-          <p:nvPr/>
-        </p:nvSpPr>
-        <p:spPr>
-          <a:xfrm>
-            <a:off x="3383280" y="2560320"/>
-            <a:ext cx="82296" cy="82296"/>
-          </a:xfrm>
-          <a:prstGeom prst="rect">
-            <a:avLst/>
-          </a:prstGeom>
-          <a:solidFill>
-            <a:srgbClr val="E9A227"/>
-          </a:solidFill>
-          <a:ln w="12700">
-            <a:solidFill>
-              <a:srgbClr val="E9A227"/>
-            </a:solidFill>
-            <a:prstDash val="solid"/>
-          </a:ln>
-        </p:spPr>
-        <p:txBody>
-          <a:bodyPr/>
-          <a:lstStyle/>
-          <a:p>
-            <a:endParaRPr lang="hu-HU"/>
+            <a:endParaRPr lang="en-US" sz="1600" dirty="0"/>
           </a:p>
         </p:txBody>
       </p:sp>
@@ -2948,7 +2783,7 @@
         </p:nvSpPr>
         <p:spPr>
           <a:xfrm>
-            <a:off x="3547872" y="2423160"/>
+            <a:off x="3364992" y="2347722"/>
             <a:ext cx="2231136" cy="438912"/>
           </a:xfrm>
           <a:prstGeom prst="rect">
@@ -2965,7 +2800,7 @@
               <a:buNone/>
             </a:pPr>
             <a:r>
-              <a:rPr lang="en-US" sz="1150" dirty="0">
+              <a:rPr lang="en-US" sz="1600" dirty="0">
                 <a:solidFill>
                   <a:srgbClr val="C5D5E8"/>
                 </a:solidFill>
@@ -2975,7 +2810,7 @@
               </a:rPr>
               <a:t>Verziókezelés</a:t>
             </a:r>
-            <a:endParaRPr lang="en-US" sz="1150" dirty="0"/>
+            <a:endParaRPr lang="en-US" sz="1600" dirty="0"/>
           </a:p>
         </p:txBody>
       </p:sp>
@@ -3075,7 +2910,7 @@
               <a:buNone/>
             </a:pPr>
             <a:r>
-              <a:rPr lang="en-US" sz="1500" b="1" dirty="0">
+              <a:rPr lang="en-US" sz="2000" b="1" dirty="0">
                 <a:solidFill>
                   <a:srgbClr val="0B1628"/>
                 </a:solidFill>
@@ -3085,7 +2920,7 @@
               </a:rPr>
               <a:t>Matyi</a:t>
             </a:r>
-            <a:endParaRPr lang="en-US" sz="1500" dirty="0"/>
+            <a:endParaRPr lang="en-US" sz="2000" dirty="0"/>
           </a:p>
         </p:txBody>
       </p:sp>
@@ -3114,7 +2949,7 @@
               <a:buNone/>
             </a:pPr>
             <a:r>
-              <a:rPr lang="en-US" sz="900" dirty="0">
+              <a:rPr lang="en-US" sz="1400" dirty="0">
                 <a:solidFill>
                   <a:srgbClr val="0B1628"/>
                 </a:solidFill>
@@ -3124,39 +2959,7 @@
               </a:rPr>
               <a:t>Backend Developer</a:t>
             </a:r>
-            <a:endParaRPr lang="en-US" sz="900" dirty="0"/>
-          </a:p>
-        </p:txBody>
-      </p:sp>
-      <p:sp>
-        <p:nvSpPr>
-          <p:cNvPr id="33" name="Shape 31"/>
-          <p:cNvSpPr/>
-          <p:nvPr/>
-        </p:nvSpPr>
-        <p:spPr>
-          <a:xfrm>
-            <a:off x="6236208" y="2084832"/>
-            <a:ext cx="82296" cy="82296"/>
-          </a:xfrm>
-          <a:prstGeom prst="rect">
-            <a:avLst/>
-          </a:prstGeom>
-          <a:solidFill>
-            <a:srgbClr val="E9A227"/>
-          </a:solidFill>
-          <a:ln w="12700">
-            <a:solidFill>
-              <a:srgbClr val="E9A227"/>
-            </a:solidFill>
-            <a:prstDash val="solid"/>
-          </a:ln>
-        </p:spPr>
-        <p:txBody>
-          <a:bodyPr/>
-          <a:lstStyle/>
-          <a:p>
-            <a:endParaRPr lang="hu-HU"/>
+            <a:endParaRPr lang="en-US" sz="1400" dirty="0"/>
           </a:p>
         </p:txBody>
       </p:sp>
@@ -3168,8 +2971,8 @@
         </p:nvSpPr>
         <p:spPr>
           <a:xfrm>
-            <a:off x="6400800" y="1947672"/>
-            <a:ext cx="2231136" cy="438912"/>
+            <a:off x="6217920" y="1911096"/>
+            <a:ext cx="2414016" cy="438912"/>
           </a:xfrm>
           <a:prstGeom prst="rect">
             <a:avLst/>
@@ -3185,7 +2988,7 @@
               <a:buNone/>
             </a:pPr>
             <a:r>
-              <a:rPr lang="en-US" sz="1150" dirty="0">
+              <a:rPr lang="en-US" sz="1600" dirty="0">
                 <a:solidFill>
                   <a:srgbClr val="C5D5E8"/>
                 </a:solidFill>
@@ -3195,39 +2998,7 @@
               </a:rPr>
               <a:t>Backend fejlesztés (Odin)</a:t>
             </a:r>
-            <a:endParaRPr lang="en-US" sz="1150" dirty="0"/>
-          </a:p>
-        </p:txBody>
-      </p:sp>
-      <p:sp>
-        <p:nvSpPr>
-          <p:cNvPr id="35" name="Shape 33"/>
-          <p:cNvSpPr/>
-          <p:nvPr/>
-        </p:nvSpPr>
-        <p:spPr>
-          <a:xfrm>
-            <a:off x="6236208" y="2560320"/>
-            <a:ext cx="82296" cy="82296"/>
-          </a:xfrm>
-          <a:prstGeom prst="rect">
-            <a:avLst/>
-          </a:prstGeom>
-          <a:solidFill>
-            <a:srgbClr val="E9A227"/>
-          </a:solidFill>
-          <a:ln w="12700">
-            <a:solidFill>
-              <a:srgbClr val="E9A227"/>
-            </a:solidFill>
-            <a:prstDash val="solid"/>
-          </a:ln>
-        </p:spPr>
-        <p:txBody>
-          <a:bodyPr/>
-          <a:lstStyle/>
-          <a:p>
-            <a:endParaRPr lang="hu-HU"/>
+            <a:endParaRPr lang="en-US" sz="1600" dirty="0"/>
           </a:p>
         </p:txBody>
       </p:sp>
@@ -3239,8 +3010,8 @@
         </p:nvSpPr>
         <p:spPr>
           <a:xfrm>
-            <a:off x="6400800" y="2423160"/>
-            <a:ext cx="2231136" cy="438912"/>
+            <a:off x="6217920" y="2375506"/>
+            <a:ext cx="2414016" cy="438912"/>
           </a:xfrm>
           <a:prstGeom prst="rect">
             <a:avLst/>
@@ -3256,7 +3027,7 @@
               <a:buNone/>
             </a:pPr>
             <a:r>
-              <a:rPr lang="en-US" sz="1150" dirty="0">
+              <a:rPr lang="en-US" sz="1600" dirty="0" err="1">
                 <a:solidFill>
                   <a:srgbClr val="C5D5E8"/>
                 </a:solidFill>
@@ -3264,41 +3035,20 @@
                 <a:ea typeface="Trebuchet MS" pitchFamily="34" charset="-122"/>
                 <a:cs typeface="Trebuchet MS" pitchFamily="34" charset="-120"/>
               </a:rPr>
-              <a:t>Adatbázis megtervezése</a:t>
-            </a:r>
-            <a:endParaRPr lang="en-US" sz="1150" dirty="0"/>
-          </a:p>
-        </p:txBody>
-      </p:sp>
-      <p:sp>
-        <p:nvSpPr>
-          <p:cNvPr id="37" name="Shape 35"/>
-          <p:cNvSpPr/>
-          <p:nvPr/>
-        </p:nvSpPr>
-        <p:spPr>
-          <a:xfrm>
-            <a:off x="6236208" y="3035808"/>
-            <a:ext cx="82296" cy="82296"/>
-          </a:xfrm>
-          <a:prstGeom prst="rect">
-            <a:avLst/>
-          </a:prstGeom>
-          <a:solidFill>
-            <a:srgbClr val="E9A227"/>
-          </a:solidFill>
-          <a:ln w="12700">
-            <a:solidFill>
-              <a:srgbClr val="E9A227"/>
-            </a:solidFill>
-            <a:prstDash val="solid"/>
-          </a:ln>
-        </p:spPr>
-        <p:txBody>
-          <a:bodyPr/>
-          <a:lstStyle/>
-          <a:p>
-            <a:endParaRPr lang="hu-HU"/>
+              <a:t>Adatbázis</a:t>
+            </a:r>
+            <a:r>
+              <a:rPr lang="hu-HU" sz="1600" dirty="0">
+                <a:solidFill>
+                  <a:srgbClr val="C5D5E8"/>
+                </a:solidFill>
+                <a:latin typeface="Trebuchet MS" pitchFamily="34" charset="0"/>
+                <a:ea typeface="Trebuchet MS" pitchFamily="34" charset="-122"/>
+                <a:cs typeface="Trebuchet MS" pitchFamily="34" charset="-120"/>
+              </a:rPr>
+              <a:t> létrehozása</a:t>
+            </a:r>
+            <a:endParaRPr lang="en-US" sz="1600" dirty="0"/>
           </a:p>
         </p:txBody>
       </p:sp>
@@ -3310,8 +3060,8 @@
         </p:nvSpPr>
         <p:spPr>
           <a:xfrm>
-            <a:off x="6400800" y="2898648"/>
-            <a:ext cx="2231136" cy="438912"/>
+            <a:off x="6215671" y="2898648"/>
+            <a:ext cx="2443698" cy="438912"/>
           </a:xfrm>
           <a:prstGeom prst="rect">
             <a:avLst/>
@@ -3327,7 +3077,7 @@
               <a:buNone/>
             </a:pPr>
             <a:r>
-              <a:rPr lang="en-US" sz="1150" dirty="0">
+              <a:rPr lang="en-US" sz="1600" dirty="0">
                 <a:solidFill>
                   <a:srgbClr val="C5D5E8"/>
                 </a:solidFill>
@@ -3335,41 +3085,16 @@
                 <a:ea typeface="Trebuchet MS" pitchFamily="34" charset="-122"/>
                 <a:cs typeface="Trebuchet MS" pitchFamily="34" charset="-120"/>
               </a:rPr>
-              <a:t>Admin middleware és végpontok</a:t>
-            </a:r>
-            <a:endParaRPr lang="en-US" sz="1150" dirty="0"/>
-          </a:p>
-        </p:txBody>
-      </p:sp>
-      <p:sp>
-        <p:nvSpPr>
-          <p:cNvPr id="39" name="Shape 37"/>
-          <p:cNvSpPr/>
-          <p:nvPr/>
-        </p:nvSpPr>
-        <p:spPr>
-          <a:xfrm>
-            <a:off x="6236208" y="3511296"/>
-            <a:ext cx="82296" cy="82296"/>
-          </a:xfrm>
-          <a:prstGeom prst="rect">
-            <a:avLst/>
-          </a:prstGeom>
-          <a:solidFill>
-            <a:srgbClr val="E9A227"/>
-          </a:solidFill>
-          <a:ln w="12700">
-            <a:solidFill>
-              <a:srgbClr val="E9A227"/>
-            </a:solidFill>
-            <a:prstDash val="solid"/>
-          </a:ln>
-        </p:spPr>
-        <p:txBody>
-          <a:bodyPr/>
-          <a:lstStyle/>
-          <a:p>
-            <a:endParaRPr lang="hu-HU"/>
+              <a:t>Admin middleware </a:t>
+            </a:r>
+            <a:endParaRPr lang="hu-HU" sz="1600" dirty="0">
+              <a:solidFill>
+                <a:srgbClr val="C5D5E8"/>
+              </a:solidFill>
+              <a:latin typeface="Trebuchet MS" pitchFamily="34" charset="0"/>
+              <a:ea typeface="Trebuchet MS" pitchFamily="34" charset="-122"/>
+              <a:cs typeface="Trebuchet MS" pitchFamily="34" charset="-120"/>
+            </a:endParaRPr>
           </a:p>
         </p:txBody>
       </p:sp>
@@ -3381,8 +3106,8 @@
         </p:nvSpPr>
         <p:spPr>
           <a:xfrm>
-            <a:off x="6400800" y="3374136"/>
-            <a:ext cx="2231136" cy="438912"/>
+            <a:off x="6217920" y="3374136"/>
+            <a:ext cx="2414016" cy="438912"/>
           </a:xfrm>
           <a:prstGeom prst="rect">
             <a:avLst/>
@@ -3398,7 +3123,7 @@
               <a:buNone/>
             </a:pPr>
             <a:r>
-              <a:rPr lang="en-US" sz="1150" dirty="0">
+              <a:rPr lang="en-US" sz="1600" dirty="0">
                 <a:solidFill>
                   <a:srgbClr val="C5D5E8"/>
                 </a:solidFill>
@@ -3408,7 +3133,7 @@
               </a:rPr>
               <a:t>Autentikáció</a:t>
             </a:r>
-            <a:endParaRPr lang="en-US" sz="1150" dirty="0"/>
+            <a:endParaRPr lang="en-US" sz="1600" dirty="0"/>
           </a:p>
         </p:txBody>
       </p:sp>
@@ -3737,7 +3462,7 @@
               <a:buNone/>
             </a:pPr>
             <a:r>
-              <a:rPr lang="en-US" sz="1500" i="1" dirty="0">
+              <a:rPr lang="hu-HU" sz="1500" i="1" dirty="0">
                 <a:solidFill>
                   <a:srgbClr val="E9A227"/>
                 </a:solidFill>
@@ -3745,7 +3470,29 @@
                 <a:ea typeface="Trebuchet MS" pitchFamily="34" charset="-122"/>
                 <a:cs typeface="Trebuchet MS" pitchFamily="34" charset="-120"/>
               </a:rPr>
-              <a:t>Live demo következik →</a:t>
+              <a:t>Élő </a:t>
+            </a:r>
+            <a:r>
+              <a:rPr lang="hu-HU" sz="1500" i="1" dirty="0" err="1">
+                <a:solidFill>
+                  <a:srgbClr val="E9A227"/>
+                </a:solidFill>
+                <a:latin typeface="Trebuchet MS" pitchFamily="34" charset="0"/>
+                <a:ea typeface="Trebuchet MS" pitchFamily="34" charset="-122"/>
+                <a:cs typeface="Trebuchet MS" pitchFamily="34" charset="-120"/>
+              </a:rPr>
+              <a:t>demo</a:t>
+            </a:r>
+            <a:r>
+              <a:rPr lang="en-US" sz="1500" i="1" dirty="0">
+                <a:solidFill>
+                  <a:srgbClr val="E9A227"/>
+                </a:solidFill>
+                <a:latin typeface="Trebuchet MS" pitchFamily="34" charset="0"/>
+                <a:ea typeface="Trebuchet MS" pitchFamily="34" charset="-122"/>
+                <a:cs typeface="Trebuchet MS" pitchFamily="34" charset="-120"/>
+              </a:rPr>
+              <a:t> következik →</a:t>
             </a:r>
             <a:endParaRPr lang="en-US" sz="1500" dirty="0"/>
           </a:p>
@@ -4080,7 +3827,7 @@
               <a:buNone/>
             </a:pPr>
             <a:r>
-              <a:rPr lang="en-US" sz="1250" kern="0" spc="150" dirty="0">
+              <a:rPr lang="en-US" sz="1600" kern="0" spc="150" dirty="0">
                 <a:solidFill>
                   <a:srgbClr val="C5D5E8"/>
                 </a:solidFill>
@@ -4088,9 +3835,9 @@
                 <a:ea typeface="Trebuchet MS" pitchFamily="34" charset="-122"/>
                 <a:cs typeface="Trebuchet MS" pitchFamily="34" charset="-120"/>
               </a:rPr>
-              <a:t>Cross Country Webshop  ·  Ádám &amp; Matyi  ·  2025</a:t>
-            </a:r>
-            <a:endParaRPr lang="en-US" sz="1250" dirty="0"/>
+              <a:t>  Ádám &amp; Matyi  </a:t>
+            </a:r>
+            <a:endParaRPr lang="en-US" sz="1600" dirty="0"/>
           </a:p>
         </p:txBody>
       </p:sp>
@@ -4390,7 +4137,7 @@
               <a:buNone/>
             </a:pPr>
             <a:r>
-              <a:rPr lang="en-US" sz="950" b="1" kern="0" spc="150" dirty="0">
+              <a:rPr lang="en-US" b="1" kern="0" spc="150" dirty="0">
                 <a:solidFill>
                   <a:srgbClr val="E9A227"/>
                 </a:solidFill>
@@ -4400,7 +4147,7 @@
               </a:rPr>
               <a:t>SZOFTVER CÉLJA</a:t>
             </a:r>
-            <a:endParaRPr lang="en-US" sz="950" dirty="0"/>
+            <a:endParaRPr lang="en-US" dirty="0"/>
           </a:p>
         </p:txBody>
       </p:sp>
@@ -4464,7 +4211,7 @@
               <a:buNone/>
             </a:pPr>
             <a:r>
-              <a:rPr lang="en-US" sz="1300" dirty="0">
+              <a:rPr lang="en-US" sz="1600" dirty="0">
                 <a:solidFill>
                   <a:srgbClr val="C5D5E8"/>
                 </a:solidFill>
@@ -4474,7 +4221,7 @@
               </a:rPr>
               <a:t>Egy teljes értékű webshop, ahol fiatalok böngészhetnek, kerékpár szervizt foglalhatnak, és termékeket rendelhetnek.</a:t>
             </a:r>
-            <a:endParaRPr lang="en-US" sz="1300" dirty="0"/>
+            <a:endParaRPr lang="en-US" sz="1600" dirty="0"/>
           </a:p>
         </p:txBody>
       </p:sp>
@@ -4486,7 +4233,7 @@
         </p:nvSpPr>
         <p:spPr>
           <a:xfrm>
-            <a:off x="3227832" y="1261872"/>
+            <a:off x="3250692" y="1241755"/>
             <a:ext cx="2633472" cy="3493008"/>
           </a:xfrm>
           <a:prstGeom prst="rect">
@@ -4574,7 +4321,7 @@
               <a:buNone/>
             </a:pPr>
             <a:r>
-              <a:rPr lang="en-US" sz="950" b="1" kern="0" spc="150" dirty="0">
+              <a:rPr lang="en-US" b="1" kern="0" spc="150" dirty="0">
                 <a:solidFill>
                   <a:srgbClr val="E9A227"/>
                 </a:solidFill>
@@ -4584,7 +4331,7 @@
               </a:rPr>
               <a:t>KINEK SZÓL?</a:t>
             </a:r>
-            <a:endParaRPr lang="en-US" sz="950" dirty="0"/>
+            <a:endParaRPr lang="en-US" dirty="0"/>
           </a:p>
         </p:txBody>
       </p:sp>
@@ -4648,7 +4395,7 @@
               <a:buNone/>
             </a:pPr>
             <a:r>
-              <a:rPr lang="en-US" sz="1300" dirty="0">
+              <a:rPr lang="en-US" sz="1600" dirty="0">
                 <a:solidFill>
                   <a:srgbClr val="C5D5E8"/>
                 </a:solidFill>
@@ -4656,9 +4403,64 @@
                 <a:ea typeface="Trebuchet MS" pitchFamily="34" charset="-122"/>
                 <a:cs typeface="Trebuchet MS" pitchFamily="34" charset="-120"/>
               </a:rPr>
-              <a:t>Olyan fiatal végfelhasználóknak, akiket érdekel a kerékpározás világa, akár magas szinten is. Természetesen adminisztrátorok számára is.</a:t>
-            </a:r>
-            <a:endParaRPr lang="en-US" sz="1300" dirty="0"/>
+              <a:t>Olyan </a:t>
+            </a:r>
+            <a:r>
+              <a:rPr lang="en-US" sz="1600" dirty="0" err="1">
+                <a:solidFill>
+                  <a:srgbClr val="C5D5E8"/>
+                </a:solidFill>
+                <a:latin typeface="Trebuchet MS" pitchFamily="34" charset="0"/>
+                <a:ea typeface="Trebuchet MS" pitchFamily="34" charset="-122"/>
+                <a:cs typeface="Trebuchet MS" pitchFamily="34" charset="-120"/>
+              </a:rPr>
+              <a:t>fiatal</a:t>
+            </a:r>
+            <a:r>
+              <a:rPr lang="hu-HU" sz="1600" dirty="0">
+                <a:solidFill>
+                  <a:srgbClr val="C5D5E8"/>
+                </a:solidFill>
+                <a:latin typeface="Trebuchet MS" pitchFamily="34" charset="0"/>
+                <a:ea typeface="Trebuchet MS" pitchFamily="34" charset="-122"/>
+                <a:cs typeface="Trebuchet MS" pitchFamily="34" charset="-120"/>
+              </a:rPr>
+              <a:t>ok</a:t>
+            </a:r>
+            <a:r>
+              <a:rPr lang="en-US" sz="1600" dirty="0">
+                <a:solidFill>
+                  <a:srgbClr val="C5D5E8"/>
+                </a:solidFill>
+                <a:latin typeface="Trebuchet MS" pitchFamily="34" charset="0"/>
+                <a:ea typeface="Trebuchet MS" pitchFamily="34" charset="-122"/>
+                <a:cs typeface="Trebuchet MS" pitchFamily="34" charset="-120"/>
+              </a:rPr>
+              <a:t>nak, akiket érdekel a kerékpározás világa, a</a:t>
+            </a:r>
+            <a:r>
+              <a:rPr lang="hu-HU" sz="1600" dirty="0">
+                <a:solidFill>
+                  <a:srgbClr val="C5D5E8"/>
+                </a:solidFill>
+                <a:latin typeface="Trebuchet MS" pitchFamily="34" charset="0"/>
+                <a:ea typeface="Trebuchet MS" pitchFamily="34" charset="-122"/>
+                <a:cs typeface="Trebuchet MS" pitchFamily="34" charset="-120"/>
+              </a:rPr>
+              <a:t> jövendőbeli szakembereknek</a:t>
+            </a:r>
+            <a:r>
+              <a:rPr lang="en-US" sz="1600" dirty="0">
+                <a:solidFill>
+                  <a:srgbClr val="C5D5E8"/>
+                </a:solidFill>
+                <a:latin typeface="Trebuchet MS" pitchFamily="34" charset="0"/>
+                <a:ea typeface="Trebuchet MS" pitchFamily="34" charset="-122"/>
+                <a:cs typeface="Trebuchet MS" pitchFamily="34" charset="-120"/>
+              </a:rPr>
+              <a:t>. </a:t>
+            </a:r>
+            <a:endParaRPr lang="en-US" sz="1600" dirty="0"/>
           </a:p>
         </p:txBody>
       </p:sp>
@@ -4758,7 +4560,7 @@
               <a:buNone/>
             </a:pPr>
             <a:r>
-              <a:rPr lang="en-US" sz="950" b="1" kern="0" spc="150" dirty="0">
+              <a:rPr lang="en-US" b="1" kern="0" spc="150" dirty="0">
                 <a:solidFill>
                   <a:srgbClr val="E9A227"/>
                 </a:solidFill>
@@ -4768,7 +4570,7 @@
               </a:rPr>
               <a:t>MIÉRT?</a:t>
             </a:r>
-            <a:endParaRPr lang="en-US" sz="950" dirty="0"/>
+            <a:endParaRPr lang="en-US" dirty="0"/>
           </a:p>
         </p:txBody>
       </p:sp>
@@ -4832,7 +4634,7 @@
               <a:buNone/>
             </a:pPr>
             <a:r>
-              <a:rPr lang="en-US" sz="1300" dirty="0">
+              <a:rPr lang="en-US" sz="1600" dirty="0">
                 <a:solidFill>
                   <a:srgbClr val="C5D5E8"/>
                 </a:solidFill>
@@ -4840,9 +4642,47 @@
                 <a:ea typeface="Trebuchet MS" pitchFamily="34" charset="-122"/>
                 <a:cs typeface="Trebuchet MS" pitchFamily="34" charset="-120"/>
               </a:rPr>
-              <a:t>Személy szerint nagyon érdekel a kerékpározás világa, illetve maga a sportág is.</a:t>
-            </a:r>
-            <a:endParaRPr lang="en-US" sz="1300" dirty="0"/>
+              <a:t>Személy szerint nagyon érdekel a kerékpározás világa, illetve maga a </a:t>
+            </a:r>
+            <a:endParaRPr lang="hu-HU" sz="1600" dirty="0">
+              <a:solidFill>
+                <a:srgbClr val="C5D5E8"/>
+              </a:solidFill>
+              <a:latin typeface="Trebuchet MS" pitchFamily="34" charset="0"/>
+              <a:ea typeface="Trebuchet MS" pitchFamily="34" charset="-122"/>
+              <a:cs typeface="Trebuchet MS" pitchFamily="34" charset="-120"/>
+            </a:endParaRPr>
+          </a:p>
+          <a:p>
+            <a:pPr marL="0" indent="0">
+              <a:lnSpc>
+                <a:spcPct val="150000"/>
+              </a:lnSpc>
+              <a:buNone/>
+            </a:pPr>
+            <a:r>
+              <a:rPr lang="en-US" sz="1600" dirty="0" err="1">
+                <a:solidFill>
+                  <a:srgbClr val="C5D5E8"/>
+                </a:solidFill>
+                <a:latin typeface="Trebuchet MS" pitchFamily="34" charset="0"/>
+                <a:ea typeface="Trebuchet MS" pitchFamily="34" charset="-122"/>
+                <a:cs typeface="Trebuchet MS" pitchFamily="34" charset="-120"/>
+              </a:rPr>
+              <a:t>sportág</a:t>
+            </a:r>
+            <a:r>
+              <a:rPr lang="en-US" sz="1600" dirty="0">
+                <a:solidFill>
+                  <a:srgbClr val="C5D5E8"/>
+                </a:solidFill>
+                <a:latin typeface="Trebuchet MS" pitchFamily="34" charset="0"/>
+                <a:ea typeface="Trebuchet MS" pitchFamily="34" charset="-122"/>
+                <a:cs typeface="Trebuchet MS" pitchFamily="34" charset="-120"/>
+              </a:rPr>
+              <a:t> is.</a:t>
+            </a:r>
+            <a:endParaRPr lang="en-US" sz="1600" dirty="0"/>
           </a:p>
         </p:txBody>
       </p:sp>
@@ -5170,7 +5010,7 @@
               <a:buNone/>
             </a:pPr>
             <a:r>
-              <a:rPr lang="en-US" sz="900" b="1" kern="0" spc="150" dirty="0">
+              <a:rPr lang="en-US" sz="1600" b="1" kern="0" spc="150" dirty="0">
                 <a:solidFill>
                   <a:srgbClr val="E9A227"/>
                 </a:solidFill>
@@ -5180,7 +5020,7 @@
               </a:rPr>
               <a:t>FRONTEND</a:t>
             </a:r>
-            <a:endParaRPr lang="en-US" sz="900" dirty="0"/>
+            <a:endParaRPr lang="en-US" sz="1600" dirty="0"/>
           </a:p>
         </p:txBody>
       </p:sp>
@@ -5237,14 +5077,13 @@
           <a:bodyPr wrap="square" lIns="0" tIns="0" rIns="0" bIns="0" rtlCol="0" anchor="t"/>
           <a:lstStyle/>
           <a:p>
-            <a:pPr marL="0" indent="0">
+            <a:pPr algn="ctr">
               <a:lnSpc>
                 <a:spcPct val="140000"/>
               </a:lnSpc>
-              <a:buNone/>
             </a:pPr>
             <a:r>
-              <a:rPr lang="en-US" sz="1200" dirty="0">
+              <a:rPr lang="en-US" sz="1400" dirty="0">
                 <a:solidFill>
                   <a:srgbClr val="C5D5E8"/>
                 </a:solidFill>
@@ -5252,19 +5091,25 @@
                 <a:ea typeface="Trebuchet MS" pitchFamily="34" charset="-122"/>
                 <a:cs typeface="Trebuchet MS" pitchFamily="34" charset="-120"/>
               </a:rPr>
-              <a:t>React + React Router v7</a:t>
-            </a:r>
-            <a:endParaRPr lang="en-US" sz="1200" dirty="0"/>
-          </a:p>
-          <a:p>
-            <a:pPr marL="0" indent="0">
+              <a:t>React </a:t>
+            </a:r>
+            <a:endParaRPr lang="hu-HU" sz="1400" dirty="0">
+              <a:solidFill>
+                <a:srgbClr val="C5D5E8"/>
+              </a:solidFill>
+              <a:latin typeface="Trebuchet MS" pitchFamily="34" charset="0"/>
+              <a:ea typeface="Trebuchet MS" pitchFamily="34" charset="-122"/>
+              <a:cs typeface="Trebuchet MS" pitchFamily="34" charset="-120"/>
+            </a:endParaRPr>
+          </a:p>
+          <a:p>
+            <a:pPr algn="ctr">
               <a:lnSpc>
                 <a:spcPct val="140000"/>
               </a:lnSpc>
-              <a:buNone/>
             </a:pPr>
             <a:r>
-              <a:rPr lang="en-US" sz="1200" dirty="0">
+              <a:rPr lang="en-US" sz="1400" dirty="0">
                 <a:solidFill>
                   <a:srgbClr val="C5D5E8"/>
                 </a:solidFill>
@@ -5272,19 +5117,18 @@
                 <a:ea typeface="Trebuchet MS" pitchFamily="34" charset="-122"/>
                 <a:cs typeface="Trebuchet MS" pitchFamily="34" charset="-120"/>
               </a:rPr>
-              <a:t>Tailwind CSS</a:t>
-            </a:r>
-            <a:endParaRPr lang="en-US" sz="1200" dirty="0"/>
-          </a:p>
-          <a:p>
-            <a:pPr marL="0" indent="0">
+              <a:t>React Router v7</a:t>
+            </a:r>
+            <a:endParaRPr lang="en-US" sz="1400" dirty="0"/>
+          </a:p>
+          <a:p>
+            <a:pPr algn="ctr">
               <a:lnSpc>
                 <a:spcPct val="140000"/>
               </a:lnSpc>
-              <a:buNone/>
             </a:pPr>
             <a:r>
-              <a:rPr lang="en-US" sz="1200" dirty="0">
+              <a:rPr lang="en-US" sz="1400" dirty="0">
                 <a:solidFill>
                   <a:srgbClr val="C5D5E8"/>
                 </a:solidFill>
@@ -5292,9 +5136,28 @@
                 <a:ea typeface="Trebuchet MS" pitchFamily="34" charset="-122"/>
                 <a:cs typeface="Trebuchet MS" pitchFamily="34" charset="-120"/>
               </a:rPr>
+              <a:t>Tailwind CSS</a:t>
+            </a:r>
+            <a:endParaRPr lang="en-US" sz="1400" dirty="0"/>
+          </a:p>
+          <a:p>
+            <a:pPr algn="ctr">
+              <a:lnSpc>
+                <a:spcPct val="140000"/>
+              </a:lnSpc>
+            </a:pPr>
+            <a:r>
+              <a:rPr lang="en-US" sz="1400" dirty="0">
+                <a:solidFill>
+                  <a:srgbClr val="C5D5E8"/>
+                </a:solidFill>
+                <a:latin typeface="Trebuchet MS" pitchFamily="34" charset="0"/>
+                <a:ea typeface="Trebuchet MS" pitchFamily="34" charset="-122"/>
+                <a:cs typeface="Trebuchet MS" pitchFamily="34" charset="-120"/>
+              </a:rPr>
               <a:t>Flowbite React komponens könyvtár</a:t>
             </a:r>
-            <a:endParaRPr lang="en-US" sz="1200" dirty="0"/>
+            <a:endParaRPr lang="en-US" sz="1400" dirty="0"/>
           </a:p>
         </p:txBody>
       </p:sp>
@@ -5422,7 +5285,7 @@
               <a:buNone/>
             </a:pPr>
             <a:r>
-              <a:rPr lang="en-US" sz="900" b="1" kern="0" spc="150" dirty="0">
+              <a:rPr lang="en-US" sz="1600" b="1" kern="0" spc="150" dirty="0">
                 <a:solidFill>
                   <a:srgbClr val="E9A227"/>
                 </a:solidFill>
@@ -5432,7 +5295,7 @@
               </a:rPr>
               <a:t>BACKEND</a:t>
             </a:r>
-            <a:endParaRPr lang="en-US" sz="900" dirty="0"/>
+            <a:endParaRPr lang="en-US" sz="1600" dirty="0"/>
           </a:p>
         </p:txBody>
       </p:sp>
@@ -5489,14 +5352,14 @@
           <a:bodyPr wrap="square" lIns="0" tIns="0" rIns="0" bIns="0" rtlCol="0" anchor="t"/>
           <a:lstStyle/>
           <a:p>
-            <a:pPr marL="0" indent="0">
+            <a:pPr marL="0" indent="0" algn="ctr">
               <a:lnSpc>
                 <a:spcPct val="140000"/>
               </a:lnSpc>
               <a:buNone/>
             </a:pPr>
             <a:r>
-              <a:rPr lang="en-US" sz="1200" dirty="0">
+              <a:rPr lang="en-US" sz="1400" dirty="0">
                 <a:solidFill>
                   <a:srgbClr val="C5D5E8"/>
                 </a:solidFill>
@@ -5506,17 +5369,17 @@
               </a:rPr>
               <a:t>Express / Node.js</a:t>
             </a:r>
-            <a:endParaRPr lang="en-US" sz="1200" dirty="0"/>
-          </a:p>
-          <a:p>
-            <a:pPr marL="0" indent="0">
+            <a:endParaRPr lang="en-US" sz="1400" dirty="0"/>
+          </a:p>
+          <a:p>
+            <a:pPr marL="0" indent="0" algn="ctr">
               <a:lnSpc>
                 <a:spcPct val="140000"/>
               </a:lnSpc>
               <a:buNone/>
             </a:pPr>
             <a:r>
-              <a:rPr lang="en-US" sz="1200" dirty="0">
+              <a:rPr lang="en-US" sz="1400" dirty="0">
                 <a:solidFill>
                   <a:srgbClr val="C5D5E8"/>
                 </a:solidFill>
@@ -5524,9 +5387,43 @@
                 <a:ea typeface="Trebuchet MS" pitchFamily="34" charset="-122"/>
                 <a:cs typeface="Trebuchet MS" pitchFamily="34" charset="-120"/>
               </a:rPr>
-              <a:t>Odin Framework</a:t>
-            </a:r>
-            <a:endParaRPr lang="en-US" sz="1200" dirty="0"/>
+              <a:t>Odin </a:t>
+            </a:r>
+            <a:endParaRPr lang="hu-HU" sz="1400" dirty="0">
+              <a:solidFill>
+                <a:srgbClr val="C5D5E8"/>
+              </a:solidFill>
+              <a:latin typeface="Trebuchet MS" pitchFamily="34" charset="0"/>
+              <a:ea typeface="Trebuchet MS" pitchFamily="34" charset="-122"/>
+              <a:cs typeface="Trebuchet MS" pitchFamily="34" charset="-120"/>
+            </a:endParaRPr>
+          </a:p>
+          <a:p>
+            <a:pPr marL="0" indent="0" algn="ctr">
+              <a:lnSpc>
+                <a:spcPct val="140000"/>
+              </a:lnSpc>
+              <a:buNone/>
+            </a:pPr>
+            <a:r>
+              <a:rPr lang="hu-HU" sz="1400" dirty="0" err="1">
+                <a:solidFill>
+                  <a:srgbClr val="C5D5E8"/>
+                </a:solidFill>
+                <a:latin typeface="Trebuchet MS" pitchFamily="34" charset="0"/>
+              </a:rPr>
+              <a:t>Caddy</a:t>
+            </a:r>
+            <a:r>
+              <a:rPr lang="hu-HU" sz="1400" dirty="0">
+                <a:solidFill>
+                  <a:srgbClr val="C5D5E8"/>
+                </a:solidFill>
+                <a:latin typeface="Trebuchet MS" pitchFamily="34" charset="0"/>
+              </a:rPr>
+              <a:t> szerver</a:t>
+            </a:r>
+            <a:endParaRPr lang="en-US" sz="1400" dirty="0"/>
           </a:p>
         </p:txBody>
       </p:sp>
@@ -5654,7 +5551,7 @@
               <a:buNone/>
             </a:pPr>
             <a:r>
-              <a:rPr lang="en-US" sz="900" b="1" kern="0" spc="150" dirty="0">
+              <a:rPr lang="en-US" sz="1600" b="1" kern="0" spc="150" dirty="0">
                 <a:solidFill>
                   <a:srgbClr val="E9A227"/>
                 </a:solidFill>
@@ -5664,7 +5561,7 @@
               </a:rPr>
               <a:t>ADATBÁZIS</a:t>
             </a:r>
-            <a:endParaRPr lang="en-US" sz="900" dirty="0"/>
+            <a:endParaRPr lang="en-US" sz="1600" dirty="0"/>
           </a:p>
         </p:txBody>
       </p:sp>
@@ -5721,14 +5618,14 @@
           <a:bodyPr wrap="square" lIns="0" tIns="0" rIns="0" bIns="0" rtlCol="0" anchor="t"/>
           <a:lstStyle/>
           <a:p>
-            <a:pPr marL="0" indent="0">
+            <a:pPr marL="0" indent="0" algn="ctr">
               <a:lnSpc>
                 <a:spcPct val="140000"/>
               </a:lnSpc>
               <a:buNone/>
             </a:pPr>
             <a:r>
-              <a:rPr lang="en-US" sz="1200" dirty="0">
+              <a:rPr lang="en-US" sz="1400" dirty="0">
                 <a:solidFill>
                   <a:srgbClr val="C5D5E8"/>
                 </a:solidFill>
@@ -5736,9 +5633,36 @@
                 <a:ea typeface="Trebuchet MS" pitchFamily="34" charset="-122"/>
                 <a:cs typeface="Trebuchet MS" pitchFamily="34" charset="-120"/>
               </a:rPr>
-              <a:t>MySQL / PostgreSQL</a:t>
-            </a:r>
-            <a:endParaRPr lang="en-US" sz="1200" dirty="0"/>
+              <a:t>MySQL </a:t>
+            </a:r>
+            <a:endParaRPr lang="hu-HU" sz="1400" dirty="0">
+              <a:solidFill>
+                <a:srgbClr val="C5D5E8"/>
+              </a:solidFill>
+              <a:latin typeface="Trebuchet MS" pitchFamily="34" charset="0"/>
+              <a:ea typeface="Trebuchet MS" pitchFamily="34" charset="-122"/>
+              <a:cs typeface="Trebuchet MS" pitchFamily="34" charset="-120"/>
+            </a:endParaRPr>
+          </a:p>
+          <a:p>
+            <a:pPr marL="0" indent="0" algn="ctr">
+              <a:lnSpc>
+                <a:spcPct val="140000"/>
+              </a:lnSpc>
+              <a:buNone/>
+            </a:pPr>
+            <a:r>
+              <a:rPr lang="en-US" sz="1400" dirty="0">
+                <a:solidFill>
+                  <a:srgbClr val="C5D5E8"/>
+                </a:solidFill>
+                <a:latin typeface="Trebuchet MS" pitchFamily="34" charset="0"/>
+                <a:ea typeface="Trebuchet MS" pitchFamily="34" charset="-122"/>
+                <a:cs typeface="Trebuchet MS" pitchFamily="34" charset="-120"/>
+              </a:rPr>
+              <a:t> PostgreSQL</a:t>
+            </a:r>
+            <a:endParaRPr lang="en-US" sz="1400" dirty="0"/>
           </a:p>
         </p:txBody>
       </p:sp>
@@ -5866,7 +5790,7 @@
               <a:buNone/>
             </a:pPr>
             <a:r>
-              <a:rPr lang="en-US" sz="900" b="1" kern="0" spc="150" dirty="0">
+              <a:rPr lang="en-US" sz="1600" b="1" kern="0" spc="150" dirty="0">
                 <a:solidFill>
                   <a:srgbClr val="E9A227"/>
                 </a:solidFill>
@@ -5876,7 +5800,7 @@
               </a:rPr>
               <a:t>TESZTELÉS</a:t>
             </a:r>
-            <a:endParaRPr lang="en-US" sz="900" dirty="0"/>
+            <a:endParaRPr lang="en-US" sz="1600" dirty="0"/>
           </a:p>
         </p:txBody>
       </p:sp>
@@ -5933,14 +5857,14 @@
           <a:bodyPr wrap="square" lIns="0" tIns="0" rIns="0" bIns="0" rtlCol="0" anchor="t"/>
           <a:lstStyle/>
           <a:p>
-            <a:pPr marL="0" indent="0">
+            <a:pPr marL="0" indent="0" algn="ctr">
               <a:lnSpc>
                 <a:spcPct val="140000"/>
               </a:lnSpc>
               <a:buNone/>
             </a:pPr>
             <a:r>
-              <a:rPr lang="en-US" sz="1200" dirty="0">
+              <a:rPr lang="en-US" sz="1400" dirty="0">
                 <a:solidFill>
                   <a:srgbClr val="C5D5E8"/>
                 </a:solidFill>
@@ -5950,7 +5874,32 @@
               </a:rPr>
               <a:t>Cypress</a:t>
             </a:r>
-            <a:endParaRPr lang="en-US" sz="1200" dirty="0"/>
+            <a:endParaRPr lang="hu-HU" sz="1400" dirty="0">
+              <a:solidFill>
+                <a:srgbClr val="C5D5E8"/>
+              </a:solidFill>
+              <a:latin typeface="Trebuchet MS" pitchFamily="34" charset="0"/>
+              <a:ea typeface="Trebuchet MS" pitchFamily="34" charset="-122"/>
+              <a:cs typeface="Trebuchet MS" pitchFamily="34" charset="-120"/>
+            </a:endParaRPr>
+          </a:p>
+          <a:p>
+            <a:pPr marL="0" indent="0" algn="ctr">
+              <a:lnSpc>
+                <a:spcPct val="140000"/>
+              </a:lnSpc>
+              <a:buNone/>
+            </a:pPr>
+            <a:r>
+              <a:rPr lang="hu-HU" sz="1400" dirty="0" err="1">
+                <a:solidFill>
+                  <a:srgbClr val="C5D5E8"/>
+                </a:solidFill>
+                <a:latin typeface="Trebuchet MS" pitchFamily="34" charset="0"/>
+              </a:rPr>
+              <a:t>Jest</a:t>
+            </a:r>
+            <a:endParaRPr lang="en-US" sz="1400" dirty="0"/>
           </a:p>
         </p:txBody>
       </p:sp>
@@ -6130,10 +6079,10 @@
       </p:pic>
       <p:pic>
         <p:nvPicPr>
-          <p:cNvPr id="44" name="Kép 43">
+          <p:cNvPr id="8" name="Kép 7">
             <a:extLst>
               <a:ext uri="{FF2B5EF4-FFF2-40B4-BE49-F238E27FC236}">
-                <a16:creationId xmlns:a16="http://schemas.microsoft.com/office/drawing/2014/main" id="{AB6A49FD-6514-436D-5D46-969A0F488C91}"/>
+                <a16:creationId xmlns:a16="http://schemas.microsoft.com/office/drawing/2014/main" id="{D583B7B1-8186-CB38-721F-F8C2C0002D1D}"/>
               </a:ext>
             </a:extLst>
           </p:cNvPr>
@@ -6150,8 +6099,8 @@
         </p:blipFill>
         <p:spPr>
           <a:xfrm>
-            <a:off x="3041093" y="1275386"/>
-            <a:ext cx="867254" cy="867254"/>
+            <a:off x="2768778" y="1337010"/>
+            <a:ext cx="1420535" cy="738678"/>
           </a:xfrm>
           <a:prstGeom prst="rect">
             <a:avLst/>
@@ -6256,7 +6205,95 @@
                 <a:ea typeface="Palatino Linotype" pitchFamily="34" charset="-122"/>
                 <a:cs typeface="Palatino Linotype" pitchFamily="34" charset="-120"/>
               </a:rPr>
-              <a:t>Az Alkalmazás Főbb Funkciói  (felhasználói oldal)</a:t>
+              <a:t>Az </a:t>
+            </a:r>
+            <a:r>
+              <a:rPr lang="hu-HU" sz="3200" b="1" dirty="0">
+                <a:solidFill>
+                  <a:srgbClr val="FFFFFF"/>
+                </a:solidFill>
+                <a:latin typeface="Palatino Linotype" pitchFamily="34" charset="0"/>
+                <a:ea typeface="Palatino Linotype" pitchFamily="34" charset="-122"/>
+                <a:cs typeface="Palatino Linotype" pitchFamily="34" charset="-120"/>
+              </a:rPr>
+              <a:t>a</a:t>
+            </a:r>
+            <a:r>
+              <a:rPr lang="en-US" sz="3200" b="1" dirty="0" err="1">
+                <a:solidFill>
+                  <a:srgbClr val="FFFFFF"/>
+                </a:solidFill>
+                <a:latin typeface="Palatino Linotype" pitchFamily="34" charset="0"/>
+                <a:ea typeface="Palatino Linotype" pitchFamily="34" charset="-122"/>
+                <a:cs typeface="Palatino Linotype" pitchFamily="34" charset="-120"/>
+              </a:rPr>
+              <a:t>lkalmazás</a:t>
+            </a:r>
+            <a:r>
+              <a:rPr lang="en-US" sz="3200" b="1" dirty="0">
+                <a:solidFill>
+                  <a:srgbClr val="FFFFFF"/>
+                </a:solidFill>
+                <a:latin typeface="Palatino Linotype" pitchFamily="34" charset="0"/>
+                <a:ea typeface="Palatino Linotype" pitchFamily="34" charset="-122"/>
+                <a:cs typeface="Palatino Linotype" pitchFamily="34" charset="-120"/>
+              </a:rPr>
+              <a:t> </a:t>
+            </a:r>
+            <a:r>
+              <a:rPr lang="hu-HU" sz="3200" b="1" dirty="0">
+                <a:solidFill>
+                  <a:srgbClr val="FFFFFF"/>
+                </a:solidFill>
+                <a:latin typeface="Palatino Linotype" pitchFamily="34" charset="0"/>
+                <a:ea typeface="Palatino Linotype" pitchFamily="34" charset="-122"/>
+                <a:cs typeface="Palatino Linotype" pitchFamily="34" charset="-120"/>
+              </a:rPr>
+              <a:t>f</a:t>
+            </a:r>
+            <a:r>
+              <a:rPr lang="en-US" sz="3200" b="1" dirty="0" err="1">
+                <a:solidFill>
+                  <a:srgbClr val="FFFFFF"/>
+                </a:solidFill>
+                <a:latin typeface="Palatino Linotype" pitchFamily="34" charset="0"/>
+                <a:ea typeface="Palatino Linotype" pitchFamily="34" charset="-122"/>
+                <a:cs typeface="Palatino Linotype" pitchFamily="34" charset="-120"/>
+              </a:rPr>
+              <a:t>őbb</a:t>
+            </a:r>
+            <a:r>
+              <a:rPr lang="en-US" sz="3200" b="1" dirty="0">
+                <a:solidFill>
+                  <a:srgbClr val="FFFFFF"/>
+                </a:solidFill>
+                <a:latin typeface="Palatino Linotype" pitchFamily="34" charset="0"/>
+                <a:ea typeface="Palatino Linotype" pitchFamily="34" charset="-122"/>
+                <a:cs typeface="Palatino Linotype" pitchFamily="34" charset="-120"/>
+              </a:rPr>
+              <a:t> </a:t>
+            </a:r>
+            <a:r>
+              <a:rPr lang="hu-HU" sz="3200" b="1" dirty="0">
+                <a:solidFill>
+                  <a:srgbClr val="FFFFFF"/>
+                </a:solidFill>
+                <a:latin typeface="Palatino Linotype" pitchFamily="34" charset="0"/>
+                <a:ea typeface="Palatino Linotype" pitchFamily="34" charset="-122"/>
+                <a:cs typeface="Palatino Linotype" pitchFamily="34" charset="-120"/>
+              </a:rPr>
+              <a:t>f</a:t>
+            </a:r>
+            <a:r>
+              <a:rPr lang="en-US" sz="3200" b="1" dirty="0" err="1">
+                <a:solidFill>
+                  <a:srgbClr val="FFFFFF"/>
+                </a:solidFill>
+                <a:latin typeface="Palatino Linotype" pitchFamily="34" charset="0"/>
+                <a:ea typeface="Palatino Linotype" pitchFamily="34" charset="-122"/>
+                <a:cs typeface="Palatino Linotype" pitchFamily="34" charset="-120"/>
+              </a:rPr>
+              <a:t>unkciói</a:t>
             </a:r>
             <a:endParaRPr lang="en-US" sz="3200" dirty="0"/>
           </a:p>
@@ -6421,18 +6458,7 @@
             <a:pPr marL="0" indent="0" algn="ctr">
               <a:buNone/>
             </a:pPr>
-            <a:r>
-              <a:rPr lang="en-US" sz="2200" b="1" dirty="0">
-                <a:solidFill>
-                  <a:srgbClr val="E9A227"/>
-                </a:solidFill>
-                <a:latin typeface="Palatino Linotype" pitchFamily="34" charset="0"/>
-                <a:ea typeface="Palatino Linotype" pitchFamily="34" charset="-122"/>
-                <a:cs typeface="Palatino Linotype" pitchFamily="34" charset="-120"/>
-              </a:rPr>
-              <a:t>01</a:t>
-            </a:r>
-            <a:endParaRPr lang="en-US" sz="2200" dirty="0"/>
+            <a:endParaRPr lang="en-US" dirty="0"/>
           </a:p>
         </p:txBody>
       </p:sp>
@@ -6493,7 +6519,7 @@
               <a:buNone/>
             </a:pPr>
             <a:r>
-              <a:rPr lang="en-US" sz="1400" dirty="0">
+              <a:rPr lang="en-US" dirty="0">
                 <a:solidFill>
                   <a:srgbClr val="FFFFFF"/>
                 </a:solidFill>
@@ -6503,7 +6529,7 @@
               </a:rPr>
               <a:t>Termékek böngészése, szűrése</a:t>
             </a:r>
-            <a:endParaRPr lang="en-US" sz="1400" dirty="0"/>
+            <a:endParaRPr lang="en-US" dirty="0"/>
           </a:p>
         </p:txBody>
       </p:sp>
@@ -6602,18 +6628,7 @@
             <a:pPr marL="0" indent="0" algn="ctr">
               <a:buNone/>
             </a:pPr>
-            <a:r>
-              <a:rPr lang="en-US" sz="2200" b="1" dirty="0">
-                <a:solidFill>
-                  <a:srgbClr val="E9A227"/>
-                </a:solidFill>
-                <a:latin typeface="Palatino Linotype" pitchFamily="34" charset="0"/>
-                <a:ea typeface="Palatino Linotype" pitchFamily="34" charset="-122"/>
-                <a:cs typeface="Palatino Linotype" pitchFamily="34" charset="-120"/>
-              </a:rPr>
-              <a:t>02</a:t>
-            </a:r>
-            <a:endParaRPr lang="en-US" sz="2200" dirty="0"/>
+            <a:endParaRPr lang="en-US" dirty="0"/>
           </a:p>
         </p:txBody>
       </p:sp>
@@ -6674,7 +6689,7 @@
               <a:buNone/>
             </a:pPr>
             <a:r>
-              <a:rPr lang="en-US" sz="1400" dirty="0">
+              <a:rPr lang="en-US" dirty="0">
                 <a:solidFill>
                   <a:srgbClr val="FFFFFF"/>
                 </a:solidFill>
@@ -6684,7 +6699,7 @@
               </a:rPr>
               <a:t>Regisztráció / Bejelentkezés</a:t>
             </a:r>
-            <a:endParaRPr lang="en-US" sz="1400" dirty="0"/>
+            <a:endParaRPr lang="en-US" dirty="0"/>
           </a:p>
         </p:txBody>
       </p:sp>
@@ -6783,18 +6798,7 @@
             <a:pPr marL="0" indent="0" algn="ctr">
               <a:buNone/>
             </a:pPr>
-            <a:r>
-              <a:rPr lang="en-US" sz="2200" b="1" dirty="0">
-                <a:solidFill>
-                  <a:srgbClr val="E9A227"/>
-                </a:solidFill>
-                <a:latin typeface="Palatino Linotype" pitchFamily="34" charset="0"/>
-                <a:ea typeface="Palatino Linotype" pitchFamily="34" charset="-122"/>
-                <a:cs typeface="Palatino Linotype" pitchFamily="34" charset="-120"/>
-              </a:rPr>
-              <a:t>03</a:t>
-            </a:r>
-            <a:endParaRPr lang="en-US" sz="2200" dirty="0"/>
+            <a:endParaRPr lang="en-US" dirty="0"/>
           </a:p>
         </p:txBody>
       </p:sp>
@@ -6855,7 +6859,7 @@
               <a:buNone/>
             </a:pPr>
             <a:r>
-              <a:rPr lang="en-US" sz="1400" dirty="0">
+              <a:rPr lang="hu-HU" dirty="0" err="1">
                 <a:solidFill>
                   <a:srgbClr val="FFFFFF"/>
                 </a:solidFill>
@@ -6863,9 +6867,31 @@
                 <a:ea typeface="Trebuchet MS" pitchFamily="34" charset="-122"/>
                 <a:cs typeface="Trebuchet MS" pitchFamily="34" charset="-120"/>
               </a:rPr>
-              <a:t>Szerviz foglalás</a:t>
-            </a:r>
-            <a:endParaRPr lang="en-US" sz="1400" dirty="0"/>
+              <a:t>Kerékpárs</a:t>
+            </a:r>
+            <a:r>
+              <a:rPr lang="en-US" dirty="0" err="1">
+                <a:solidFill>
+                  <a:srgbClr val="FFFFFF"/>
+                </a:solidFill>
+                <a:latin typeface="Trebuchet MS" pitchFamily="34" charset="0"/>
+                <a:ea typeface="Trebuchet MS" pitchFamily="34" charset="-122"/>
+                <a:cs typeface="Trebuchet MS" pitchFamily="34" charset="-120"/>
+              </a:rPr>
+              <a:t>zerviz</a:t>
+            </a:r>
+            <a:r>
+              <a:rPr lang="en-US" dirty="0">
+                <a:solidFill>
+                  <a:srgbClr val="FFFFFF"/>
+                </a:solidFill>
+                <a:latin typeface="Trebuchet MS" pitchFamily="34" charset="0"/>
+                <a:ea typeface="Trebuchet MS" pitchFamily="34" charset="-122"/>
+                <a:cs typeface="Trebuchet MS" pitchFamily="34" charset="-120"/>
+              </a:rPr>
+              <a:t> foglalás</a:t>
+            </a:r>
+            <a:endParaRPr lang="en-US" dirty="0"/>
           </a:p>
         </p:txBody>
       </p:sp>
@@ -6964,18 +6990,7 @@
             <a:pPr marL="0" indent="0" algn="ctr">
               <a:buNone/>
             </a:pPr>
-            <a:r>
-              <a:rPr lang="en-US" sz="2200" b="1" dirty="0">
-                <a:solidFill>
-                  <a:srgbClr val="E9A227"/>
-                </a:solidFill>
-                <a:latin typeface="Palatino Linotype" pitchFamily="34" charset="0"/>
-                <a:ea typeface="Palatino Linotype" pitchFamily="34" charset="-122"/>
-                <a:cs typeface="Palatino Linotype" pitchFamily="34" charset="-120"/>
-              </a:rPr>
-              <a:t>04</a:t>
-            </a:r>
-            <a:endParaRPr lang="en-US" sz="2200" dirty="0"/>
+            <a:endParaRPr lang="en-US" dirty="0"/>
           </a:p>
         </p:txBody>
       </p:sp>
@@ -7019,8 +7034,8 @@
         </p:nvSpPr>
         <p:spPr>
           <a:xfrm>
-            <a:off x="1335024" y="4005072"/>
-            <a:ext cx="7132320" cy="621792"/>
+            <a:off x="1335023" y="4005072"/>
+            <a:ext cx="7318857" cy="621792"/>
           </a:xfrm>
           <a:prstGeom prst="rect">
             <a:avLst/>
@@ -7039,107 +7054,260 @@
               <a:buNone/>
             </a:pPr>
             <a:r>
-              <a:rPr lang="en-US" sz="1400" dirty="0">
+              <a:rPr lang="hu-HU" dirty="0">
                 <a:solidFill>
                   <a:srgbClr val="FFFFFF"/>
                 </a:solidFill>
                 <a:latin typeface="Trebuchet MS" pitchFamily="34" charset="0"/>
-                <a:ea typeface="Trebuchet MS" pitchFamily="34" charset="-122"/>
-                <a:cs typeface="Trebuchet MS" pitchFamily="34" charset="-120"/>
-              </a:rPr>
-              <a:t>Megrendelés </a:t>
-            </a:r>
-            <a:r>
-              <a:rPr lang="en-US" sz="1400" dirty="0" err="1">
-                <a:solidFill>
-                  <a:srgbClr val="FFFFFF"/>
-                </a:solidFill>
-                <a:latin typeface="Trebuchet MS" pitchFamily="34" charset="0"/>
-                <a:ea typeface="Trebuchet MS" pitchFamily="34" charset="-122"/>
-                <a:cs typeface="Trebuchet MS" pitchFamily="34" charset="-120"/>
-              </a:rPr>
-              <a:t>folyamata</a:t>
-            </a:r>
-            <a:r>
-              <a:rPr lang="en-US" sz="1400" dirty="0">
-                <a:solidFill>
-                  <a:srgbClr val="FFFFFF"/>
-                </a:solidFill>
-                <a:latin typeface="Trebuchet MS" pitchFamily="34" charset="0"/>
-                <a:ea typeface="Trebuchet MS" pitchFamily="34" charset="-122"/>
-                <a:cs typeface="Trebuchet MS" pitchFamily="34" charset="-120"/>
-              </a:rPr>
-              <a:t>:</a:t>
-            </a:r>
-            <a:endParaRPr lang="hu-HU" sz="1400" dirty="0">
+              </a:rPr>
+              <a:t>Megrendelési folyamat (kosár       adatok        e-mail visszaigazolás)</a:t>
+            </a:r>
+            <a:endParaRPr lang="en-US" dirty="0">
               <a:solidFill>
                 <a:srgbClr val="FFFFFF"/>
               </a:solidFill>
               <a:latin typeface="Trebuchet MS" pitchFamily="34" charset="0"/>
-              <a:ea typeface="Trebuchet MS" pitchFamily="34" charset="-122"/>
-              <a:cs typeface="Trebuchet MS" pitchFamily="34" charset="-120"/>
             </a:endParaRPr>
           </a:p>
-          <a:p>
-            <a:pPr marL="0" indent="0">
-              <a:buNone/>
-            </a:pPr>
-            <a:r>
-              <a:rPr lang="en-US" sz="1400" dirty="0">
-                <a:solidFill>
-                  <a:srgbClr val="FFFFFF"/>
-                </a:solidFill>
-                <a:latin typeface="Trebuchet MS" pitchFamily="34" charset="0"/>
-                <a:ea typeface="Trebuchet MS" pitchFamily="34" charset="-122"/>
-                <a:cs typeface="Trebuchet MS" pitchFamily="34" charset="-120"/>
-              </a:rPr>
-              <a:t> </a:t>
-            </a:r>
-            <a:r>
-              <a:rPr lang="en-US" sz="1400" dirty="0" err="1">
-                <a:solidFill>
-                  <a:srgbClr val="FFFFFF"/>
-                </a:solidFill>
-                <a:latin typeface="Trebuchet MS" pitchFamily="34" charset="0"/>
-                <a:ea typeface="Trebuchet MS" pitchFamily="34" charset="-122"/>
-                <a:cs typeface="Trebuchet MS" pitchFamily="34" charset="-120"/>
-              </a:rPr>
-              <a:t>Termék</a:t>
-            </a:r>
-            <a:r>
-              <a:rPr lang="hu-HU" sz="1400" dirty="0">
-                <a:solidFill>
-                  <a:srgbClr val="FFFFFF"/>
-                </a:solidFill>
-                <a:latin typeface="Trebuchet MS" pitchFamily="34" charset="0"/>
-                <a:ea typeface="Trebuchet MS" pitchFamily="34" charset="-122"/>
-                <a:cs typeface="Trebuchet MS" pitchFamily="34" charset="-120"/>
-              </a:rPr>
-              <a:t> </a:t>
-            </a:r>
-            <a:r>
-              <a:rPr lang="en-US" sz="1400" dirty="0" err="1">
-                <a:solidFill>
-                  <a:srgbClr val="FFFFFF"/>
-                </a:solidFill>
-                <a:latin typeface="Trebuchet MS" pitchFamily="34" charset="0"/>
-                <a:ea typeface="Trebuchet MS" pitchFamily="34" charset="-122"/>
-                <a:cs typeface="Trebuchet MS" pitchFamily="34" charset="-120"/>
-              </a:rPr>
-              <a:t>kiválasztása</a:t>
-            </a:r>
-            <a:r>
-              <a:rPr lang="en-US" sz="1400" dirty="0">
-                <a:solidFill>
-                  <a:srgbClr val="FFFFFF"/>
-                </a:solidFill>
-                <a:latin typeface="Trebuchet MS" pitchFamily="34" charset="0"/>
-                <a:ea typeface="Trebuchet MS" pitchFamily="34" charset="-122"/>
-                <a:cs typeface="Trebuchet MS" pitchFamily="34" charset="-120"/>
-              </a:rPr>
-              <a:t> → Személyes adatok megadása → Visszaigazolás (email)</a:t>
-            </a:r>
-            <a:endParaRPr lang="en-US" sz="1400" dirty="0"/>
+        </p:txBody>
+      </p:sp>
+      <p:cxnSp>
+        <p:nvCxnSpPr>
+          <p:cNvPr id="27" name="Egyenes összekötő nyíllal 26">
+            <a:extLst>
+              <a:ext uri="{FF2B5EF4-FFF2-40B4-BE49-F238E27FC236}">
+                <a16:creationId xmlns:a16="http://schemas.microsoft.com/office/drawing/2014/main" id="{C7129F49-E6B7-1200-FE7B-5DBF7866F18C}"/>
+              </a:ext>
+            </a:extLst>
+          </p:cNvPr>
+          <p:cNvCxnSpPr>
+            <a:cxnSpLocks/>
+          </p:cNvCxnSpPr>
+          <p:nvPr/>
+        </p:nvCxnSpPr>
+        <p:spPr>
+          <a:xfrm>
+            <a:off x="4384357" y="4328160"/>
+            <a:ext cx="375285" cy="0"/>
+          </a:xfrm>
+          <a:prstGeom prst="straightConnector1">
+            <a:avLst/>
+          </a:prstGeom>
+          <a:ln w="19050">
+            <a:solidFill>
+              <a:schemeClr val="bg1"/>
+            </a:solidFill>
+            <a:tailEnd type="triangle"/>
+          </a:ln>
+        </p:spPr>
+        <p:style>
+          <a:lnRef idx="1">
+            <a:schemeClr val="accent1"/>
+          </a:lnRef>
+          <a:fillRef idx="0">
+            <a:schemeClr val="accent1"/>
+          </a:fillRef>
+          <a:effectRef idx="0">
+            <a:schemeClr val="accent1"/>
+          </a:effectRef>
+          <a:fontRef idx="minor">
+            <a:schemeClr val="tx1"/>
+          </a:fontRef>
+        </p:style>
+      </p:cxnSp>
+      <p:cxnSp>
+        <p:nvCxnSpPr>
+          <p:cNvPr id="29" name="Egyenes összekötő nyíllal 28">
+            <a:extLst>
+              <a:ext uri="{FF2B5EF4-FFF2-40B4-BE49-F238E27FC236}">
+                <a16:creationId xmlns:a16="http://schemas.microsoft.com/office/drawing/2014/main" id="{A1305938-92D1-5945-23E3-1B88BFAB8B96}"/>
+              </a:ext>
+            </a:extLst>
+          </p:cNvPr>
+          <p:cNvCxnSpPr>
+            <a:cxnSpLocks/>
+          </p:cNvCxnSpPr>
+          <p:nvPr/>
+        </p:nvCxnSpPr>
+        <p:spPr>
+          <a:xfrm>
+            <a:off x="5634037" y="4328160"/>
+            <a:ext cx="375285" cy="0"/>
+          </a:xfrm>
+          <a:prstGeom prst="straightConnector1">
+            <a:avLst/>
+          </a:prstGeom>
+          <a:ln w="19050">
+            <a:solidFill>
+              <a:schemeClr val="bg1"/>
+            </a:solidFill>
+            <a:tailEnd type="triangle"/>
+          </a:ln>
+        </p:spPr>
+        <p:style>
+          <a:lnRef idx="1">
+            <a:schemeClr val="accent1"/>
+          </a:lnRef>
+          <a:fillRef idx="0">
+            <a:schemeClr val="accent1"/>
+          </a:fillRef>
+          <a:effectRef idx="0">
+            <a:schemeClr val="accent1"/>
+          </a:effectRef>
+          <a:fontRef idx="minor">
+            <a:schemeClr val="tx1"/>
+          </a:fontRef>
+        </p:style>
+      </p:cxnSp>
+      <p:sp>
+        <p:nvSpPr>
+          <p:cNvPr id="6" name="Shape 7">
+            <a:extLst>
+              <a:ext uri="{FF2B5EF4-FFF2-40B4-BE49-F238E27FC236}">
+                <a16:creationId xmlns:a16="http://schemas.microsoft.com/office/drawing/2014/main" id="{280A4678-34B1-3322-CBE2-4DB9477F33BF}"/>
+              </a:ext>
+            </a:extLst>
+          </p:cNvPr>
+          <p:cNvSpPr/>
+          <p:nvPr/>
+        </p:nvSpPr>
+        <p:spPr>
+          <a:xfrm>
+            <a:off x="770910" y="1517904"/>
+            <a:ext cx="219456" cy="219456"/>
+          </a:xfrm>
+          <a:prstGeom prst="ellipse">
+            <a:avLst/>
+          </a:prstGeom>
+          <a:solidFill>
+            <a:srgbClr val="E9A227"/>
+          </a:solidFill>
+          <a:ln w="12700">
+            <a:solidFill>
+              <a:srgbClr val="E9A227"/>
+            </a:solidFill>
+            <a:prstDash val="solid"/>
+          </a:ln>
+        </p:spPr>
+        <p:txBody>
+          <a:bodyPr/>
+          <a:lstStyle/>
+          <a:p>
+            <a:endParaRPr lang="hu-HU"/>
+          </a:p>
+        </p:txBody>
+      </p:sp>
+      <p:sp>
+        <p:nvSpPr>
+          <p:cNvPr id="28" name="Shape 7">
+            <a:extLst>
+              <a:ext uri="{FF2B5EF4-FFF2-40B4-BE49-F238E27FC236}">
+                <a16:creationId xmlns:a16="http://schemas.microsoft.com/office/drawing/2014/main" id="{FF47BFA9-3048-7D92-3C38-EB2053EFDD24}"/>
+              </a:ext>
+            </a:extLst>
+          </p:cNvPr>
+          <p:cNvSpPr/>
+          <p:nvPr/>
+        </p:nvSpPr>
+        <p:spPr>
+          <a:xfrm>
+            <a:off x="770910" y="2395306"/>
+            <a:ext cx="219456" cy="219456"/>
+          </a:xfrm>
+          <a:prstGeom prst="ellipse">
+            <a:avLst/>
+          </a:prstGeom>
+          <a:solidFill>
+            <a:srgbClr val="E9A227"/>
+          </a:solidFill>
+          <a:ln w="12700">
+            <a:solidFill>
+              <a:srgbClr val="E9A227"/>
+            </a:solidFill>
+            <a:prstDash val="solid"/>
+          </a:ln>
+        </p:spPr>
+        <p:txBody>
+          <a:bodyPr/>
+          <a:lstStyle/>
+          <a:p>
+            <a:endParaRPr lang="hu-HU"/>
+          </a:p>
+        </p:txBody>
+      </p:sp>
+      <p:sp>
+        <p:nvSpPr>
+          <p:cNvPr id="30" name="Shape 7">
+            <a:extLst>
+              <a:ext uri="{FF2B5EF4-FFF2-40B4-BE49-F238E27FC236}">
+                <a16:creationId xmlns:a16="http://schemas.microsoft.com/office/drawing/2014/main" id="{E4983FDF-8D4C-E0B1-87FA-AE059E0644ED}"/>
+              </a:ext>
+            </a:extLst>
+          </p:cNvPr>
+          <p:cNvSpPr/>
+          <p:nvPr/>
+        </p:nvSpPr>
+        <p:spPr>
+          <a:xfrm>
+            <a:off x="770910" y="3310128"/>
+            <a:ext cx="219456" cy="219456"/>
+          </a:xfrm>
+          <a:prstGeom prst="ellipse">
+            <a:avLst/>
+          </a:prstGeom>
+          <a:solidFill>
+            <a:srgbClr val="E9A227"/>
+          </a:solidFill>
+          <a:ln w="12700">
+            <a:solidFill>
+              <a:srgbClr val="E9A227"/>
+            </a:solidFill>
+            <a:prstDash val="solid"/>
+          </a:ln>
+        </p:spPr>
+        <p:txBody>
+          <a:bodyPr/>
+          <a:lstStyle/>
+          <a:p>
+            <a:endParaRPr lang="hu-HU"/>
+          </a:p>
+        </p:txBody>
+      </p:sp>
+      <p:sp>
+        <p:nvSpPr>
+          <p:cNvPr id="31" name="Shape 7">
+            <a:extLst>
+              <a:ext uri="{FF2B5EF4-FFF2-40B4-BE49-F238E27FC236}">
+                <a16:creationId xmlns:a16="http://schemas.microsoft.com/office/drawing/2014/main" id="{8DD0E068-3EC7-25AF-E13B-4D0E38734738}"/>
+              </a:ext>
+            </a:extLst>
+          </p:cNvPr>
+          <p:cNvSpPr/>
+          <p:nvPr/>
+        </p:nvSpPr>
+        <p:spPr>
+          <a:xfrm>
+            <a:off x="773020" y="4199206"/>
+            <a:ext cx="219456" cy="219456"/>
+          </a:xfrm>
+          <a:prstGeom prst="ellipse">
+            <a:avLst/>
+          </a:prstGeom>
+          <a:solidFill>
+            <a:srgbClr val="E9A227"/>
+          </a:solidFill>
+          <a:ln w="12700">
+            <a:solidFill>
+              <a:srgbClr val="E9A227"/>
+            </a:solidFill>
+            <a:prstDash val="solid"/>
+          </a:ln>
+        </p:spPr>
+        <p:txBody>
+          <a:bodyPr/>
+          <a:lstStyle/>
+          <a:p>
+            <a:endParaRPr lang="hu-HU"/>
           </a:p>
         </p:txBody>
       </p:sp>
@@ -7239,7 +7407,7 @@
                 </a:solidFill>
                 <a:latin typeface="Palatino Linotype" pitchFamily="34" charset="0"/>
               </a:rPr>
-              <a:t>Próbáljuk ki! (megrendelés)</a:t>
+              <a:t>Adatbázistáblák </a:t>
             </a:r>
             <a:endParaRPr lang="en-US" sz="3200" dirty="0"/>
           </a:p>
@@ -7309,900 +7477,36 @@
           </a:p>
         </p:txBody>
       </p:sp>
-      <p:sp>
-        <p:nvSpPr>
-          <p:cNvPr id="7" name="Shape 5"/>
-          <p:cNvSpPr/>
-          <p:nvPr/>
-        </p:nvSpPr>
-        <p:spPr>
-          <a:xfrm>
-            <a:off x="457200" y="1261872"/>
-            <a:ext cx="4069080" cy="1005840"/>
-          </a:xfrm>
-          <a:prstGeom prst="rect">
-            <a:avLst/>
-          </a:prstGeom>
-          <a:solidFill>
-            <a:srgbClr val="1A2B42"/>
-          </a:solidFill>
-          <a:ln w="9525">
-            <a:solidFill>
-              <a:srgbClr val="1F3050"/>
-            </a:solidFill>
-            <a:prstDash val="solid"/>
-          </a:ln>
-          <a:effectLst>
-            <a:outerShdw blurRad="101600" dist="25400" dir="8100000" algn="bl" rotWithShape="0">
-              <a:srgbClr val="000000">
-                <a:alpha val="30000"/>
-              </a:srgbClr>
-            </a:outerShdw>
-          </a:effectLst>
-        </p:spPr>
-        <p:txBody>
-          <a:bodyPr/>
-          <a:lstStyle/>
-          <a:p>
-            <a:endParaRPr lang="hu-HU"/>
-          </a:p>
-        </p:txBody>
-      </p:sp>
-      <p:sp>
-        <p:nvSpPr>
-          <p:cNvPr id="8" name="Shape 6"/>
-          <p:cNvSpPr/>
-          <p:nvPr/>
-        </p:nvSpPr>
-        <p:spPr>
-          <a:xfrm>
-            <a:off x="603504" y="1417320"/>
-            <a:ext cx="676656" cy="676656"/>
-          </a:xfrm>
-          <a:prstGeom prst="ellipse">
-            <a:avLst/>
-          </a:prstGeom>
-          <a:solidFill>
-            <a:srgbClr val="E9A227"/>
-          </a:solidFill>
-          <a:ln w="12700">
-            <a:solidFill>
-              <a:srgbClr val="E9A227"/>
-            </a:solidFill>
-            <a:prstDash val="solid"/>
-          </a:ln>
-        </p:spPr>
-        <p:txBody>
-          <a:bodyPr/>
-          <a:lstStyle/>
-          <a:p>
-            <a:endParaRPr lang="hu-HU"/>
-          </a:p>
-        </p:txBody>
-      </p:sp>
-      <p:sp>
-        <p:nvSpPr>
-          <p:cNvPr id="9" name="Text 7"/>
-          <p:cNvSpPr/>
-          <p:nvPr/>
-        </p:nvSpPr>
-        <p:spPr>
-          <a:xfrm>
-            <a:off x="603504" y="1417320"/>
-            <a:ext cx="676656" cy="676656"/>
-          </a:xfrm>
-          <a:prstGeom prst="rect">
-            <a:avLst/>
-          </a:prstGeom>
-          <a:noFill/>
-          <a:ln/>
-        </p:spPr>
-        <p:txBody>
-          <a:bodyPr wrap="square" lIns="0" tIns="0" rIns="0" bIns="0" rtlCol="0" anchor="ctr"/>
-          <a:lstStyle/>
-          <a:p>
-            <a:pPr marL="0" indent="0" algn="ctr">
-              <a:buNone/>
-            </a:pPr>
-            <a:r>
-              <a:rPr lang="en-US" sz="2200" b="1" dirty="0">
-                <a:solidFill>
-                  <a:srgbClr val="0B1628"/>
-                </a:solidFill>
-                <a:latin typeface="Palatino Linotype" pitchFamily="34" charset="0"/>
-                <a:ea typeface="Palatino Linotype" pitchFamily="34" charset="-122"/>
-                <a:cs typeface="Palatino Linotype" pitchFamily="34" charset="-120"/>
-              </a:rPr>
-              <a:t>1</a:t>
-            </a:r>
-            <a:endParaRPr lang="en-US" sz="2200" dirty="0"/>
-          </a:p>
-        </p:txBody>
-      </p:sp>
-      <p:sp>
-        <p:nvSpPr>
-          <p:cNvPr id="10" name="Text 8"/>
-          <p:cNvSpPr/>
-          <p:nvPr/>
-        </p:nvSpPr>
-        <p:spPr>
-          <a:xfrm>
-            <a:off x="1426464" y="1353312"/>
-            <a:ext cx="2944368" cy="822960"/>
-          </a:xfrm>
-          <a:prstGeom prst="rect">
-            <a:avLst/>
-          </a:prstGeom>
-          <a:noFill/>
-          <a:ln/>
-        </p:spPr>
-        <p:txBody>
-          <a:bodyPr wrap="square" lIns="0" tIns="0" rIns="0" bIns="0" rtlCol="0" anchor="ctr"/>
-          <a:lstStyle/>
-          <a:p>
-            <a:pPr marL="0" indent="0">
-              <a:buNone/>
-            </a:pPr>
-            <a:r>
-              <a:rPr lang="en-US" sz="1350" dirty="0">
-                <a:solidFill>
-                  <a:srgbClr val="FFFFFF"/>
-                </a:solidFill>
-                <a:latin typeface="Trebuchet MS" pitchFamily="34" charset="0"/>
-                <a:ea typeface="Trebuchet MS" pitchFamily="34" charset="-122"/>
-                <a:cs typeface="Trebuchet MS" pitchFamily="34" charset="-120"/>
-              </a:rPr>
-              <a:t>Böngészés termékek között</a:t>
-            </a:r>
-            <a:endParaRPr lang="en-US" sz="1350" dirty="0"/>
-          </a:p>
-        </p:txBody>
-      </p:sp>
-      <p:sp>
-        <p:nvSpPr>
-          <p:cNvPr id="11" name="Shape 9"/>
-          <p:cNvSpPr/>
-          <p:nvPr/>
-        </p:nvSpPr>
-        <p:spPr>
-          <a:xfrm>
-            <a:off x="4754880" y="1261872"/>
-            <a:ext cx="4069080" cy="1005840"/>
-          </a:xfrm>
-          <a:prstGeom prst="rect">
-            <a:avLst/>
-          </a:prstGeom>
-          <a:solidFill>
-            <a:srgbClr val="1A2B42"/>
-          </a:solidFill>
-          <a:ln w="9525">
-            <a:solidFill>
-              <a:srgbClr val="1F3050"/>
-            </a:solidFill>
-            <a:prstDash val="solid"/>
-          </a:ln>
-          <a:effectLst>
-            <a:outerShdw blurRad="101600" dist="25400" dir="8100000" algn="bl" rotWithShape="0">
-              <a:srgbClr val="000000">
-                <a:alpha val="30000"/>
-              </a:srgbClr>
-            </a:outerShdw>
-          </a:effectLst>
-        </p:spPr>
-        <p:txBody>
-          <a:bodyPr/>
-          <a:lstStyle/>
-          <a:p>
-            <a:endParaRPr lang="hu-HU"/>
-          </a:p>
-        </p:txBody>
-      </p:sp>
-      <p:sp>
-        <p:nvSpPr>
-          <p:cNvPr id="12" name="Shape 10"/>
-          <p:cNvSpPr/>
-          <p:nvPr/>
-        </p:nvSpPr>
-        <p:spPr>
-          <a:xfrm>
-            <a:off x="4901184" y="1417320"/>
-            <a:ext cx="676656" cy="676656"/>
-          </a:xfrm>
-          <a:prstGeom prst="ellipse">
-            <a:avLst/>
-          </a:prstGeom>
-          <a:solidFill>
-            <a:srgbClr val="E9A227"/>
-          </a:solidFill>
-          <a:ln w="12700">
-            <a:solidFill>
-              <a:srgbClr val="E9A227"/>
-            </a:solidFill>
-            <a:prstDash val="solid"/>
-          </a:ln>
-        </p:spPr>
-        <p:txBody>
-          <a:bodyPr/>
-          <a:lstStyle/>
-          <a:p>
-            <a:endParaRPr lang="hu-HU"/>
-          </a:p>
-        </p:txBody>
-      </p:sp>
-      <p:sp>
-        <p:nvSpPr>
-          <p:cNvPr id="13" name="Text 11"/>
-          <p:cNvSpPr/>
-          <p:nvPr/>
-        </p:nvSpPr>
-        <p:spPr>
-          <a:xfrm>
-            <a:off x="4901184" y="1417320"/>
-            <a:ext cx="676656" cy="676656"/>
-          </a:xfrm>
-          <a:prstGeom prst="rect">
-            <a:avLst/>
-          </a:prstGeom>
-          <a:noFill/>
-          <a:ln/>
-        </p:spPr>
-        <p:txBody>
-          <a:bodyPr wrap="square" lIns="0" tIns="0" rIns="0" bIns="0" rtlCol="0" anchor="ctr"/>
-          <a:lstStyle/>
-          <a:p>
-            <a:pPr marL="0" indent="0" algn="ctr">
-              <a:buNone/>
-            </a:pPr>
-            <a:r>
-              <a:rPr lang="en-US" sz="2200" b="1" dirty="0">
-                <a:solidFill>
-                  <a:srgbClr val="0B1628"/>
-                </a:solidFill>
-                <a:latin typeface="Palatino Linotype" pitchFamily="34" charset="0"/>
-                <a:ea typeface="Palatino Linotype" pitchFamily="34" charset="-122"/>
-                <a:cs typeface="Palatino Linotype" pitchFamily="34" charset="-120"/>
-              </a:rPr>
-              <a:t>2</a:t>
-            </a:r>
-            <a:endParaRPr lang="en-US" sz="2200" dirty="0"/>
-          </a:p>
-        </p:txBody>
-      </p:sp>
-      <p:sp>
-        <p:nvSpPr>
-          <p:cNvPr id="14" name="Text 12"/>
-          <p:cNvSpPr/>
-          <p:nvPr/>
-        </p:nvSpPr>
-        <p:spPr>
-          <a:xfrm>
-            <a:off x="5724144" y="1353312"/>
-            <a:ext cx="2944368" cy="822960"/>
-          </a:xfrm>
-          <a:prstGeom prst="rect">
-            <a:avLst/>
-          </a:prstGeom>
-          <a:noFill/>
-          <a:ln/>
-        </p:spPr>
-        <p:txBody>
-          <a:bodyPr wrap="square" lIns="0" tIns="0" rIns="0" bIns="0" rtlCol="0" anchor="ctr"/>
-          <a:lstStyle/>
-          <a:p>
-            <a:pPr marL="0" indent="0">
-              <a:buNone/>
-            </a:pPr>
-            <a:r>
-              <a:rPr lang="en-US" sz="1350" dirty="0">
-                <a:solidFill>
-                  <a:srgbClr val="FFFFFF"/>
-                </a:solidFill>
-                <a:latin typeface="Trebuchet MS" pitchFamily="34" charset="0"/>
-                <a:ea typeface="Trebuchet MS" pitchFamily="34" charset="-122"/>
-                <a:cs typeface="Trebuchet MS" pitchFamily="34" charset="-120"/>
-              </a:rPr>
-              <a:t>Termék hozzáadása a kosárhoz</a:t>
-            </a:r>
-            <a:endParaRPr lang="en-US" sz="1350" dirty="0"/>
-          </a:p>
-        </p:txBody>
-      </p:sp>
-      <p:sp>
-        <p:nvSpPr>
-          <p:cNvPr id="15" name="Shape 13"/>
-          <p:cNvSpPr/>
-          <p:nvPr/>
-        </p:nvSpPr>
-        <p:spPr>
-          <a:xfrm>
-            <a:off x="457200" y="2496312"/>
-            <a:ext cx="4069080" cy="1005840"/>
-          </a:xfrm>
-          <a:prstGeom prst="rect">
-            <a:avLst/>
-          </a:prstGeom>
-          <a:solidFill>
-            <a:srgbClr val="1A2B42"/>
-          </a:solidFill>
-          <a:ln w="9525">
-            <a:solidFill>
-              <a:srgbClr val="1F3050"/>
-            </a:solidFill>
-            <a:prstDash val="solid"/>
-          </a:ln>
-          <a:effectLst>
-            <a:outerShdw blurRad="101600" dist="25400" dir="8100000" algn="bl" rotWithShape="0">
-              <a:srgbClr val="000000">
-                <a:alpha val="30000"/>
-              </a:srgbClr>
-            </a:outerShdw>
-          </a:effectLst>
-        </p:spPr>
-        <p:txBody>
-          <a:bodyPr/>
-          <a:lstStyle/>
-          <a:p>
-            <a:endParaRPr lang="hu-HU"/>
-          </a:p>
-        </p:txBody>
-      </p:sp>
-      <p:sp>
-        <p:nvSpPr>
-          <p:cNvPr id="16" name="Shape 14"/>
-          <p:cNvSpPr/>
-          <p:nvPr/>
-        </p:nvSpPr>
-        <p:spPr>
-          <a:xfrm>
-            <a:off x="603504" y="2651760"/>
-            <a:ext cx="676656" cy="676656"/>
-          </a:xfrm>
-          <a:prstGeom prst="ellipse">
-            <a:avLst/>
-          </a:prstGeom>
-          <a:solidFill>
-            <a:srgbClr val="E9A227"/>
-          </a:solidFill>
-          <a:ln w="12700">
-            <a:solidFill>
-              <a:srgbClr val="E9A227"/>
-            </a:solidFill>
-            <a:prstDash val="solid"/>
-          </a:ln>
-        </p:spPr>
-        <p:txBody>
-          <a:bodyPr/>
-          <a:lstStyle/>
-          <a:p>
-            <a:endParaRPr lang="hu-HU"/>
-          </a:p>
-        </p:txBody>
-      </p:sp>
-      <p:sp>
-        <p:nvSpPr>
-          <p:cNvPr id="17" name="Text 15"/>
-          <p:cNvSpPr/>
-          <p:nvPr/>
-        </p:nvSpPr>
-        <p:spPr>
-          <a:xfrm>
-            <a:off x="603504" y="2651760"/>
-            <a:ext cx="676656" cy="676656"/>
-          </a:xfrm>
-          <a:prstGeom prst="rect">
-            <a:avLst/>
-          </a:prstGeom>
-          <a:noFill/>
-          <a:ln/>
-        </p:spPr>
-        <p:txBody>
-          <a:bodyPr wrap="square" lIns="0" tIns="0" rIns="0" bIns="0" rtlCol="0" anchor="ctr"/>
-          <a:lstStyle/>
-          <a:p>
-            <a:pPr marL="0" indent="0" algn="ctr">
-              <a:buNone/>
-            </a:pPr>
-            <a:r>
-              <a:rPr lang="en-US" sz="2200" b="1" dirty="0">
-                <a:solidFill>
-                  <a:srgbClr val="0B1628"/>
-                </a:solidFill>
-                <a:latin typeface="Palatino Linotype" pitchFamily="34" charset="0"/>
-                <a:ea typeface="Palatino Linotype" pitchFamily="34" charset="-122"/>
-                <a:cs typeface="Palatino Linotype" pitchFamily="34" charset="-120"/>
-              </a:rPr>
-              <a:t>3</a:t>
-            </a:r>
-            <a:endParaRPr lang="en-US" sz="2200" dirty="0"/>
-          </a:p>
-        </p:txBody>
-      </p:sp>
-      <p:sp>
-        <p:nvSpPr>
-          <p:cNvPr id="18" name="Text 16"/>
-          <p:cNvSpPr/>
-          <p:nvPr/>
-        </p:nvSpPr>
-        <p:spPr>
-          <a:xfrm>
-            <a:off x="1426464" y="2587752"/>
-            <a:ext cx="2944368" cy="822960"/>
-          </a:xfrm>
-          <a:prstGeom prst="rect">
-            <a:avLst/>
-          </a:prstGeom>
-          <a:noFill/>
-          <a:ln/>
-        </p:spPr>
-        <p:txBody>
-          <a:bodyPr wrap="square" lIns="0" tIns="0" rIns="0" bIns="0" rtlCol="0" anchor="ctr"/>
-          <a:lstStyle/>
-          <a:p>
-            <a:pPr marL="0" indent="0">
-              <a:buNone/>
-            </a:pPr>
-            <a:r>
-              <a:rPr lang="en-US" sz="1350" dirty="0">
-                <a:solidFill>
-                  <a:srgbClr val="FFFFFF"/>
-                </a:solidFill>
-                <a:latin typeface="Trebuchet MS" pitchFamily="34" charset="0"/>
-                <a:ea typeface="Trebuchet MS" pitchFamily="34" charset="-122"/>
-                <a:cs typeface="Trebuchet MS" pitchFamily="34" charset="-120"/>
-              </a:rPr>
-              <a:t>Bejelentkezés</a:t>
-            </a:r>
-            <a:endParaRPr lang="en-US" sz="1350" dirty="0"/>
-          </a:p>
-        </p:txBody>
-      </p:sp>
-      <p:sp>
-        <p:nvSpPr>
-          <p:cNvPr id="19" name="Shape 17"/>
-          <p:cNvSpPr/>
-          <p:nvPr/>
-        </p:nvSpPr>
-        <p:spPr>
-          <a:xfrm>
-            <a:off x="4754880" y="2496312"/>
-            <a:ext cx="4069080" cy="1005840"/>
-          </a:xfrm>
-          <a:prstGeom prst="rect">
-            <a:avLst/>
-          </a:prstGeom>
-          <a:solidFill>
-            <a:srgbClr val="1A2B42"/>
-          </a:solidFill>
-          <a:ln w="9525">
-            <a:solidFill>
-              <a:srgbClr val="1F3050"/>
-            </a:solidFill>
-            <a:prstDash val="solid"/>
-          </a:ln>
-          <a:effectLst>
-            <a:outerShdw blurRad="101600" dist="25400" dir="8100000" algn="bl" rotWithShape="0">
-              <a:srgbClr val="000000">
-                <a:alpha val="30000"/>
-              </a:srgbClr>
-            </a:outerShdw>
-          </a:effectLst>
-        </p:spPr>
-        <p:txBody>
-          <a:bodyPr/>
-          <a:lstStyle/>
-          <a:p>
-            <a:endParaRPr lang="hu-HU"/>
-          </a:p>
-        </p:txBody>
-      </p:sp>
-      <p:sp>
-        <p:nvSpPr>
-          <p:cNvPr id="20" name="Shape 18"/>
-          <p:cNvSpPr/>
-          <p:nvPr/>
-        </p:nvSpPr>
-        <p:spPr>
-          <a:xfrm>
-            <a:off x="4901184" y="2651760"/>
-            <a:ext cx="676656" cy="676656"/>
-          </a:xfrm>
-          <a:prstGeom prst="ellipse">
-            <a:avLst/>
-          </a:prstGeom>
-          <a:solidFill>
-            <a:srgbClr val="E9A227"/>
-          </a:solidFill>
-          <a:ln w="12700">
-            <a:solidFill>
-              <a:srgbClr val="E9A227"/>
-            </a:solidFill>
-            <a:prstDash val="solid"/>
-          </a:ln>
-        </p:spPr>
-        <p:txBody>
-          <a:bodyPr/>
-          <a:lstStyle/>
-          <a:p>
-            <a:endParaRPr lang="hu-HU"/>
-          </a:p>
-        </p:txBody>
-      </p:sp>
-      <p:sp>
-        <p:nvSpPr>
-          <p:cNvPr id="21" name="Text 19"/>
-          <p:cNvSpPr/>
-          <p:nvPr/>
-        </p:nvSpPr>
-        <p:spPr>
-          <a:xfrm>
-            <a:off x="4901184" y="2651760"/>
-            <a:ext cx="676656" cy="676656"/>
-          </a:xfrm>
-          <a:prstGeom prst="rect">
-            <a:avLst/>
-          </a:prstGeom>
-          <a:noFill/>
-          <a:ln/>
-        </p:spPr>
-        <p:txBody>
-          <a:bodyPr wrap="square" lIns="0" tIns="0" rIns="0" bIns="0" rtlCol="0" anchor="ctr"/>
-          <a:lstStyle/>
-          <a:p>
-            <a:pPr marL="0" indent="0" algn="ctr">
-              <a:buNone/>
-            </a:pPr>
-            <a:r>
-              <a:rPr lang="en-US" sz="2200" b="1" dirty="0">
-                <a:solidFill>
-                  <a:srgbClr val="0B1628"/>
-                </a:solidFill>
-                <a:latin typeface="Palatino Linotype" pitchFamily="34" charset="0"/>
-                <a:ea typeface="Palatino Linotype" pitchFamily="34" charset="-122"/>
-                <a:cs typeface="Palatino Linotype" pitchFamily="34" charset="-120"/>
-              </a:rPr>
-              <a:t>4</a:t>
-            </a:r>
-            <a:endParaRPr lang="en-US" sz="2200" dirty="0"/>
-          </a:p>
-        </p:txBody>
-      </p:sp>
-      <p:sp>
-        <p:nvSpPr>
-          <p:cNvPr id="22" name="Text 20"/>
-          <p:cNvSpPr/>
-          <p:nvPr/>
-        </p:nvSpPr>
-        <p:spPr>
-          <a:xfrm>
-            <a:off x="5724144" y="2587752"/>
-            <a:ext cx="2944368" cy="822960"/>
-          </a:xfrm>
-          <a:prstGeom prst="rect">
-            <a:avLst/>
-          </a:prstGeom>
-          <a:noFill/>
-          <a:ln/>
-        </p:spPr>
-        <p:txBody>
-          <a:bodyPr wrap="square" lIns="0" tIns="0" rIns="0" bIns="0" rtlCol="0" anchor="ctr"/>
-          <a:lstStyle/>
-          <a:p>
-            <a:pPr marL="0" indent="0">
-              <a:buNone/>
-            </a:pPr>
-            <a:r>
-              <a:rPr lang="en-US" sz="1350" dirty="0">
-                <a:solidFill>
-                  <a:srgbClr val="FFFFFF"/>
-                </a:solidFill>
-                <a:latin typeface="Trebuchet MS" pitchFamily="34" charset="0"/>
-                <a:ea typeface="Trebuchet MS" pitchFamily="34" charset="-122"/>
-                <a:cs typeface="Trebuchet MS" pitchFamily="34" charset="-120"/>
-              </a:rPr>
-              <a:t>Kosárban termékek megtekintése</a:t>
-            </a:r>
-            <a:endParaRPr lang="en-US" sz="1350" dirty="0"/>
-          </a:p>
-        </p:txBody>
-      </p:sp>
-      <p:sp>
-        <p:nvSpPr>
-          <p:cNvPr id="23" name="Shape 21"/>
-          <p:cNvSpPr/>
-          <p:nvPr/>
-        </p:nvSpPr>
-        <p:spPr>
-          <a:xfrm>
-            <a:off x="457200" y="3730752"/>
-            <a:ext cx="4069080" cy="1005840"/>
-          </a:xfrm>
-          <a:prstGeom prst="rect">
-            <a:avLst/>
-          </a:prstGeom>
-          <a:solidFill>
-            <a:srgbClr val="1A2B42"/>
-          </a:solidFill>
-          <a:ln w="9525">
-            <a:solidFill>
-              <a:srgbClr val="1F3050"/>
-            </a:solidFill>
-            <a:prstDash val="solid"/>
-          </a:ln>
-          <a:effectLst>
-            <a:outerShdw blurRad="101600" dist="25400" dir="8100000" algn="bl" rotWithShape="0">
-              <a:srgbClr val="000000">
-                <a:alpha val="30000"/>
-              </a:srgbClr>
-            </a:outerShdw>
-          </a:effectLst>
-        </p:spPr>
-        <p:txBody>
-          <a:bodyPr/>
-          <a:lstStyle/>
-          <a:p>
-            <a:endParaRPr lang="hu-HU"/>
-          </a:p>
-        </p:txBody>
-      </p:sp>
-      <p:sp>
-        <p:nvSpPr>
-          <p:cNvPr id="24" name="Shape 22"/>
-          <p:cNvSpPr/>
-          <p:nvPr/>
-        </p:nvSpPr>
-        <p:spPr>
-          <a:xfrm>
-            <a:off x="603504" y="3886200"/>
-            <a:ext cx="676656" cy="676656"/>
-          </a:xfrm>
-          <a:prstGeom prst="ellipse">
-            <a:avLst/>
-          </a:prstGeom>
-          <a:solidFill>
-            <a:srgbClr val="E9A227"/>
-          </a:solidFill>
-          <a:ln w="12700">
-            <a:solidFill>
-              <a:srgbClr val="E9A227"/>
-            </a:solidFill>
-            <a:prstDash val="solid"/>
-          </a:ln>
-        </p:spPr>
-        <p:txBody>
-          <a:bodyPr/>
-          <a:lstStyle/>
-          <a:p>
-            <a:endParaRPr lang="hu-HU"/>
-          </a:p>
-        </p:txBody>
-      </p:sp>
-      <p:sp>
-        <p:nvSpPr>
-          <p:cNvPr id="25" name="Text 23"/>
-          <p:cNvSpPr/>
-          <p:nvPr/>
-        </p:nvSpPr>
-        <p:spPr>
-          <a:xfrm>
-            <a:off x="603504" y="3886200"/>
-            <a:ext cx="676656" cy="676656"/>
-          </a:xfrm>
-          <a:prstGeom prst="rect">
-            <a:avLst/>
-          </a:prstGeom>
-          <a:noFill/>
-          <a:ln/>
-        </p:spPr>
-        <p:txBody>
-          <a:bodyPr wrap="square" lIns="0" tIns="0" rIns="0" bIns="0" rtlCol="0" anchor="ctr"/>
-          <a:lstStyle/>
-          <a:p>
-            <a:pPr marL="0" indent="0" algn="ctr">
-              <a:buNone/>
-            </a:pPr>
-            <a:r>
-              <a:rPr lang="en-US" sz="2200" b="1" dirty="0">
-                <a:solidFill>
-                  <a:srgbClr val="0B1628"/>
-                </a:solidFill>
-                <a:latin typeface="Palatino Linotype" pitchFamily="34" charset="0"/>
-                <a:ea typeface="Palatino Linotype" pitchFamily="34" charset="-122"/>
-                <a:cs typeface="Palatino Linotype" pitchFamily="34" charset="-120"/>
-              </a:rPr>
-              <a:t>5</a:t>
-            </a:r>
-            <a:endParaRPr lang="en-US" sz="2200" dirty="0"/>
-          </a:p>
-        </p:txBody>
-      </p:sp>
-      <p:sp>
-        <p:nvSpPr>
-          <p:cNvPr id="26" name="Text 24"/>
-          <p:cNvSpPr/>
-          <p:nvPr/>
-        </p:nvSpPr>
-        <p:spPr>
-          <a:xfrm>
-            <a:off x="1426464" y="3822192"/>
-            <a:ext cx="2944368" cy="822960"/>
-          </a:xfrm>
-          <a:prstGeom prst="rect">
-            <a:avLst/>
-          </a:prstGeom>
-          <a:noFill/>
-          <a:ln/>
-        </p:spPr>
-        <p:txBody>
-          <a:bodyPr wrap="square" lIns="0" tIns="0" rIns="0" bIns="0" rtlCol="0" anchor="ctr"/>
-          <a:lstStyle/>
-          <a:p>
-            <a:pPr marL="0" indent="0">
-              <a:buNone/>
-            </a:pPr>
-            <a:r>
-              <a:rPr lang="en-US" sz="1350" dirty="0">
-                <a:solidFill>
-                  <a:srgbClr val="FFFFFF"/>
-                </a:solidFill>
-                <a:latin typeface="Trebuchet MS" pitchFamily="34" charset="0"/>
-                <a:ea typeface="Trebuchet MS" pitchFamily="34" charset="-122"/>
-                <a:cs typeface="Trebuchet MS" pitchFamily="34" charset="-120"/>
-              </a:rPr>
-              <a:t>Megrendelési adatok megadása</a:t>
-            </a:r>
-            <a:endParaRPr lang="en-US" sz="1350" dirty="0"/>
-          </a:p>
-        </p:txBody>
-      </p:sp>
-      <p:sp>
-        <p:nvSpPr>
-          <p:cNvPr id="27" name="Shape 25"/>
-          <p:cNvSpPr/>
-          <p:nvPr/>
-        </p:nvSpPr>
-        <p:spPr>
-          <a:xfrm>
-            <a:off x="4754880" y="3730752"/>
-            <a:ext cx="4069080" cy="1005840"/>
-          </a:xfrm>
-          <a:prstGeom prst="rect">
-            <a:avLst/>
-          </a:prstGeom>
-          <a:solidFill>
-            <a:srgbClr val="1A2B42"/>
-          </a:solidFill>
-          <a:ln w="9525">
-            <a:solidFill>
-              <a:srgbClr val="1F3050"/>
-            </a:solidFill>
-            <a:prstDash val="solid"/>
-          </a:ln>
-          <a:effectLst>
-            <a:outerShdw blurRad="101600" dist="25400" dir="8100000" algn="bl" rotWithShape="0">
-              <a:srgbClr val="000000">
-                <a:alpha val="30000"/>
-              </a:srgbClr>
-            </a:outerShdw>
-          </a:effectLst>
-        </p:spPr>
-        <p:txBody>
-          <a:bodyPr/>
-          <a:lstStyle/>
-          <a:p>
-            <a:endParaRPr lang="hu-HU"/>
-          </a:p>
-        </p:txBody>
-      </p:sp>
-      <p:sp>
-        <p:nvSpPr>
-          <p:cNvPr id="28" name="Shape 26"/>
-          <p:cNvSpPr/>
-          <p:nvPr/>
-        </p:nvSpPr>
-        <p:spPr>
-          <a:xfrm>
-            <a:off x="4901184" y="3886200"/>
-            <a:ext cx="676656" cy="676656"/>
-          </a:xfrm>
-          <a:prstGeom prst="ellipse">
-            <a:avLst/>
-          </a:prstGeom>
-          <a:solidFill>
-            <a:srgbClr val="E9A227"/>
-          </a:solidFill>
-          <a:ln w="12700">
-            <a:solidFill>
-              <a:srgbClr val="E9A227"/>
-            </a:solidFill>
-            <a:prstDash val="solid"/>
-          </a:ln>
-        </p:spPr>
-        <p:txBody>
-          <a:bodyPr/>
-          <a:lstStyle/>
-          <a:p>
-            <a:endParaRPr lang="hu-HU"/>
-          </a:p>
-        </p:txBody>
-      </p:sp>
-      <p:sp>
-        <p:nvSpPr>
-          <p:cNvPr id="29" name="Text 27"/>
-          <p:cNvSpPr/>
-          <p:nvPr/>
-        </p:nvSpPr>
-        <p:spPr>
-          <a:xfrm>
-            <a:off x="4901184" y="3886200"/>
-            <a:ext cx="676656" cy="676656"/>
-          </a:xfrm>
-          <a:prstGeom prst="rect">
-            <a:avLst/>
-          </a:prstGeom>
-          <a:noFill/>
-          <a:ln/>
-        </p:spPr>
-        <p:txBody>
-          <a:bodyPr wrap="square" lIns="0" tIns="0" rIns="0" bIns="0" rtlCol="0" anchor="ctr"/>
-          <a:lstStyle/>
-          <a:p>
-            <a:pPr marL="0" indent="0" algn="ctr">
-              <a:buNone/>
-            </a:pPr>
-            <a:r>
-              <a:rPr lang="en-US" sz="2200" b="1" dirty="0">
-                <a:solidFill>
-                  <a:srgbClr val="0B1628"/>
-                </a:solidFill>
-                <a:latin typeface="Palatino Linotype" pitchFamily="34" charset="0"/>
-                <a:ea typeface="Palatino Linotype" pitchFamily="34" charset="-122"/>
-                <a:cs typeface="Palatino Linotype" pitchFamily="34" charset="-120"/>
-              </a:rPr>
-              <a:t>6</a:t>
-            </a:r>
-            <a:endParaRPr lang="en-US" sz="2200" dirty="0"/>
-          </a:p>
-        </p:txBody>
-      </p:sp>
-      <p:sp>
-        <p:nvSpPr>
-          <p:cNvPr id="30" name="Text 28"/>
-          <p:cNvSpPr/>
-          <p:nvPr/>
-        </p:nvSpPr>
-        <p:spPr>
-          <a:xfrm>
-            <a:off x="5724144" y="3822192"/>
-            <a:ext cx="2944368" cy="822960"/>
-          </a:xfrm>
-          <a:prstGeom prst="rect">
-            <a:avLst/>
-          </a:prstGeom>
-          <a:noFill/>
-          <a:ln/>
-        </p:spPr>
-        <p:txBody>
-          <a:bodyPr wrap="square" lIns="0" tIns="0" rIns="0" bIns="0" rtlCol="0" anchor="ctr"/>
-          <a:lstStyle/>
-          <a:p>
-            <a:pPr marL="0" indent="0">
-              <a:buNone/>
-            </a:pPr>
-            <a:r>
-              <a:rPr lang="en-US" sz="1350" dirty="0">
-                <a:solidFill>
-                  <a:srgbClr val="FFFFFF"/>
-                </a:solidFill>
-                <a:latin typeface="Trebuchet MS" pitchFamily="34" charset="0"/>
-                <a:ea typeface="Trebuchet MS" pitchFamily="34" charset="-122"/>
-                <a:cs typeface="Trebuchet MS" pitchFamily="34" charset="-120"/>
-              </a:rPr>
-              <a:t>Rendelés véglegesítése</a:t>
-            </a:r>
-            <a:endParaRPr lang="en-US" sz="1350" dirty="0"/>
-          </a:p>
-        </p:txBody>
-      </p:sp>
+      <p:pic>
+        <p:nvPicPr>
+          <p:cNvPr id="31" name="Kép 30">
+            <a:extLst>
+              <a:ext uri="{FF2B5EF4-FFF2-40B4-BE49-F238E27FC236}">
+                <a16:creationId xmlns:a16="http://schemas.microsoft.com/office/drawing/2014/main" id="{CD02984A-589D-2537-3AC9-D01E456C0FD3}"/>
+              </a:ext>
+            </a:extLst>
+          </p:cNvPr>
+          <p:cNvPicPr>
+            <a:picLocks noChangeAspect="1"/>
+          </p:cNvPicPr>
+          <p:nvPr/>
+        </p:nvPicPr>
+        <p:blipFill>
+          <a:blip r:embed="rId3"/>
+          <a:stretch>
+            <a:fillRect/>
+          </a:stretch>
+        </p:blipFill>
+        <p:spPr>
+          <a:xfrm>
+            <a:off x="512064" y="1253813"/>
+            <a:ext cx="8888172" cy="4467517"/>
+          </a:xfrm>
+          <a:prstGeom prst="rect">
+            <a:avLst/>
+          </a:prstGeom>
+        </p:spPr>
+      </p:pic>
     </p:spTree>
   </p:cSld>
   <p:clrMapOvr>
@@ -8444,7 +7748,7 @@
         </p:nvSpPr>
         <p:spPr>
           <a:xfrm>
-            <a:off x="457200" y="4251960"/>
+            <a:off x="396240" y="4323283"/>
             <a:ext cx="4434840" cy="228600"/>
           </a:xfrm>
           <a:prstGeom prst="rect">
@@ -8461,7 +7765,7 @@
               <a:buNone/>
             </a:pPr>
             <a:r>
-              <a:rPr lang="en-US" sz="1400" i="1" dirty="0">
+              <a:rPr lang="en-US" sz="1600" i="1" dirty="0">
                 <a:solidFill>
                   <a:srgbClr val="5C7A9B"/>
                 </a:solidFill>
@@ -8471,7 +7775,7 @@
               </a:rPr>
               <a:t>Token kezelése a frontend oldalon</a:t>
             </a:r>
-            <a:endParaRPr lang="en-US" sz="1400" dirty="0"/>
+            <a:endParaRPr lang="en-US" sz="1600" dirty="0"/>
           </a:p>
         </p:txBody>
       </p:sp>
@@ -8571,7 +7875,7 @@
               <a:buNone/>
             </a:pPr>
             <a:r>
-              <a:rPr lang="en-US" sz="1300" b="1" dirty="0">
+              <a:rPr lang="en-US" b="1" dirty="0">
                 <a:solidFill>
                   <a:srgbClr val="FFFFFF"/>
                 </a:solidFill>
@@ -8581,7 +7885,7 @@
               </a:rPr>
               <a:t>Bejelentkezés</a:t>
             </a:r>
-            <a:endParaRPr lang="en-US" sz="1300" dirty="0"/>
+            <a:endParaRPr lang="en-US" dirty="0"/>
           </a:p>
         </p:txBody>
       </p:sp>
@@ -8610,7 +7914,7 @@
               <a:buNone/>
             </a:pPr>
             <a:r>
-              <a:rPr lang="en-US" sz="1050" dirty="0">
+              <a:rPr lang="en-US" sz="1400" dirty="0">
                 <a:solidFill>
                   <a:srgbClr val="C5D5E8"/>
                 </a:solidFill>
@@ -8620,7 +7924,7 @@
               </a:rPr>
               <a:t>(POST) /api/login  ·  username, password</a:t>
             </a:r>
-            <a:endParaRPr lang="en-US" sz="1050" dirty="0"/>
+            <a:endParaRPr lang="en-US" sz="1400" dirty="0"/>
           </a:p>
         </p:txBody>
       </p:sp>
@@ -8720,7 +8024,7 @@
               <a:buNone/>
             </a:pPr>
             <a:r>
-              <a:rPr lang="en-US" sz="1300" b="1" dirty="0">
+              <a:rPr lang="en-US" b="1" dirty="0">
                 <a:solidFill>
                   <a:srgbClr val="FFFFFF"/>
                 </a:solidFill>
@@ -8730,7 +8034,7 @@
               </a:rPr>
               <a:t>Token tárolás</a:t>
             </a:r>
-            <a:endParaRPr lang="en-US" sz="1300" dirty="0"/>
+            <a:endParaRPr lang="en-US" dirty="0"/>
           </a:p>
         </p:txBody>
       </p:sp>
@@ -8759,7 +8063,7 @@
               <a:buNone/>
             </a:pPr>
             <a:r>
-              <a:rPr lang="en-US" sz="1050" dirty="0">
+              <a:rPr lang="en-US" sz="1400" dirty="0">
                 <a:solidFill>
                   <a:srgbClr val="C5D5E8"/>
                 </a:solidFill>
@@ -8769,7 +8073,7 @@
               </a:rPr>
               <a:t>Kliens oldalon localStorage + header</a:t>
             </a:r>
-            <a:endParaRPr lang="en-US" sz="1050" dirty="0"/>
+            <a:endParaRPr lang="en-US" sz="1400" dirty="0"/>
           </a:p>
         </p:txBody>
       </p:sp>
@@ -8869,7 +8173,7 @@
               <a:buNone/>
             </a:pPr>
             <a:r>
-              <a:rPr lang="en-US" sz="1300" b="1" dirty="0">
+              <a:rPr lang="en-US" b="1" dirty="0">
                 <a:solidFill>
                   <a:srgbClr val="FFFFFF"/>
                 </a:solidFill>
@@ -8879,7 +8183,7 @@
               </a:rPr>
               <a:t>Token generálás</a:t>
             </a:r>
-            <a:endParaRPr lang="en-US" sz="1300" dirty="0"/>
+            <a:endParaRPr lang="en-US" dirty="0"/>
           </a:p>
         </p:txBody>
       </p:sp>
@@ -8908,7 +8212,7 @@
               <a:buNone/>
             </a:pPr>
             <a:r>
-              <a:rPr lang="en-US" sz="1050" dirty="0">
+              <a:rPr lang="en-US" sz="1400" dirty="0">
                 <a:solidFill>
                   <a:srgbClr val="C5D5E8"/>
                 </a:solidFill>
@@ -8918,7 +8222,7 @@
               </a:rPr>
               <a:t>jwt.sign( ) függvény — backenden</a:t>
             </a:r>
-            <a:endParaRPr lang="en-US" sz="1050" dirty="0"/>
+            <a:endParaRPr lang="en-US" sz="1400" dirty="0"/>
           </a:p>
         </p:txBody>
       </p:sp>
@@ -9018,7 +8322,7 @@
               <a:buNone/>
             </a:pPr>
             <a:r>
-              <a:rPr lang="en-US" sz="1300" b="1" dirty="0">
+              <a:rPr lang="en-US" b="1" dirty="0">
                 <a:solidFill>
                   <a:srgbClr val="FFFFFF"/>
                 </a:solidFill>
@@ -9028,7 +8332,7 @@
               </a:rPr>
               <a:t>Védett végpont</a:t>
             </a:r>
-            <a:endParaRPr lang="en-US" sz="1300" dirty="0"/>
+            <a:endParaRPr lang="en-US" dirty="0"/>
           </a:p>
         </p:txBody>
       </p:sp>
@@ -9057,7 +8361,7 @@
               <a:buNone/>
             </a:pPr>
             <a:r>
-              <a:rPr lang="en-US" sz="1050" dirty="0">
+              <a:rPr lang="en-US" sz="1400" dirty="0">
                 <a:solidFill>
                   <a:srgbClr val="C5D5E8"/>
                 </a:solidFill>
@@ -9067,7 +8371,7 @@
               </a:rPr>
               <a:t>Authorization: Bearer &lt;token&gt;</a:t>
             </a:r>
-            <a:endParaRPr lang="en-US" sz="1050" dirty="0"/>
+            <a:endParaRPr lang="en-US" sz="1400" dirty="0"/>
           </a:p>
         </p:txBody>
       </p:sp>
@@ -9366,7 +8670,7 @@
               <a:buNone/>
             </a:pPr>
             <a:r>
-              <a:rPr lang="en-US" sz="1300" b="1" dirty="0">
+              <a:rPr lang="en-US" b="1" dirty="0">
                 <a:solidFill>
                   <a:srgbClr val="FFFFFF"/>
                 </a:solidFill>
@@ -9376,7 +8680,7 @@
               </a:rPr>
               <a:t>DRY elv</a:t>
             </a:r>
-            <a:endParaRPr lang="en-US" sz="1300" dirty="0"/>
+            <a:endParaRPr lang="en-US" dirty="0"/>
           </a:p>
         </p:txBody>
       </p:sp>
@@ -9405,7 +8709,7 @@
               <a:buNone/>
             </a:pPr>
             <a:r>
-              <a:rPr lang="en-US" sz="1050" dirty="0">
+              <a:rPr lang="en-US" sz="1400" dirty="0">
                 <a:solidFill>
                   <a:srgbClr val="C5D5E8"/>
                 </a:solidFill>
@@ -9415,7 +8719,7 @@
               </a:rPr>
               <a:t>Egy függvény szinte minden műveletre</a:t>
             </a:r>
-            <a:endParaRPr lang="en-US" sz="1050" dirty="0"/>
+            <a:endParaRPr lang="en-US" sz="1400" dirty="0"/>
           </a:p>
         </p:txBody>
       </p:sp>
@@ -9515,7 +8819,7 @@
               <a:buNone/>
             </a:pPr>
             <a:r>
-              <a:rPr lang="en-US" sz="1300" b="1" dirty="0">
+              <a:rPr lang="en-US" b="1" dirty="0">
                 <a:solidFill>
                   <a:srgbClr val="FFFFFF"/>
                 </a:solidFill>
@@ -9523,9 +8827,31 @@
                 <a:ea typeface="Trebuchet MS" pitchFamily="34" charset="-122"/>
                 <a:cs typeface="Trebuchet MS" pitchFamily="34" charset="-120"/>
               </a:rPr>
-              <a:t>Auto token kezelés</a:t>
-            </a:r>
-            <a:endParaRPr lang="en-US" sz="1300" dirty="0"/>
+              <a:t>Auto</a:t>
+            </a:r>
+            <a:r>
+              <a:rPr lang="hu-HU" b="1" dirty="0" err="1">
+                <a:solidFill>
+                  <a:srgbClr val="FFFFFF"/>
+                </a:solidFill>
+                <a:latin typeface="Trebuchet MS" pitchFamily="34" charset="0"/>
+                <a:ea typeface="Trebuchet MS" pitchFamily="34" charset="-122"/>
+                <a:cs typeface="Trebuchet MS" pitchFamily="34" charset="-120"/>
+              </a:rPr>
+              <a:t>matikus</a:t>
+            </a:r>
+            <a:r>
+              <a:rPr lang="en-US" b="1" dirty="0">
+                <a:solidFill>
+                  <a:srgbClr val="FFFFFF"/>
+                </a:solidFill>
+                <a:latin typeface="Trebuchet MS" pitchFamily="34" charset="0"/>
+                <a:ea typeface="Trebuchet MS" pitchFamily="34" charset="-122"/>
+                <a:cs typeface="Trebuchet MS" pitchFamily="34" charset="-120"/>
+              </a:rPr>
+              <a:t> token kezelés</a:t>
+            </a:r>
+            <a:endParaRPr lang="en-US" dirty="0"/>
           </a:p>
         </p:txBody>
       </p:sp>
@@ -9554,7 +8880,7 @@
               <a:buNone/>
             </a:pPr>
             <a:r>
-              <a:rPr lang="en-US" sz="1050" dirty="0">
+              <a:rPr lang="en-US" sz="1400" dirty="0">
                 <a:solidFill>
                   <a:srgbClr val="C5D5E8"/>
                 </a:solidFill>
@@ -9564,7 +8890,7 @@
               </a:rPr>
               <a:t>Token automatikus csatolása minden kéréshez</a:t>
             </a:r>
-            <a:endParaRPr lang="en-US" sz="1050" dirty="0"/>
+            <a:endParaRPr lang="en-US" sz="1400" dirty="0"/>
           </a:p>
         </p:txBody>
       </p:sp>
@@ -9664,7 +8990,7 @@
               <a:buNone/>
             </a:pPr>
             <a:r>
-              <a:rPr lang="en-US" sz="1300" b="1" dirty="0">
+              <a:rPr lang="en-US" b="1" dirty="0">
                 <a:solidFill>
                   <a:srgbClr val="FFFFFF"/>
                 </a:solidFill>
@@ -9674,7 +9000,7 @@
               </a:rPr>
               <a:t>Content-Type</a:t>
             </a:r>
-            <a:endParaRPr lang="en-US" sz="1300" dirty="0"/>
+            <a:endParaRPr lang="en-US" dirty="0"/>
           </a:p>
         </p:txBody>
       </p:sp>
@@ -9703,7 +9029,7 @@
               <a:buNone/>
             </a:pPr>
             <a:r>
-              <a:rPr lang="en-US" sz="1050" dirty="0">
+              <a:rPr lang="en-US" sz="1400" dirty="0">
                 <a:solidFill>
                   <a:srgbClr val="C5D5E8"/>
                 </a:solidFill>
@@ -9713,7 +9039,7 @@
               </a:rPr>
               <a:t>Intelligens beállítás header szinten</a:t>
             </a:r>
-            <a:endParaRPr lang="en-US" sz="1050" dirty="0"/>
+            <a:endParaRPr lang="en-US" sz="1400" dirty="0"/>
           </a:p>
         </p:txBody>
       </p:sp>
@@ -9813,7 +9139,7 @@
               <a:buNone/>
             </a:pPr>
             <a:r>
-              <a:rPr lang="en-US" sz="1300" b="1" dirty="0">
+              <a:rPr lang="en-US" b="1" dirty="0">
                 <a:solidFill>
                   <a:srgbClr val="FFFFFF"/>
                 </a:solidFill>
@@ -9823,7 +9149,7 @@
               </a:rPr>
               <a:t>Token lejárat</a:t>
             </a:r>
-            <a:endParaRPr lang="en-US" sz="1300" dirty="0"/>
+            <a:endParaRPr lang="en-US" dirty="0"/>
           </a:p>
         </p:txBody>
       </p:sp>
@@ -9852,7 +9178,7 @@
               <a:buNone/>
             </a:pPr>
             <a:r>
-              <a:rPr lang="en-US" sz="1050" dirty="0">
+              <a:rPr lang="en-US" sz="1400" dirty="0">
                 <a:solidFill>
                   <a:srgbClr val="C5D5E8"/>
                 </a:solidFill>
@@ -9862,7 +9188,7 @@
               </a:rPr>
               <a:t>Automatikus lejárat kezelése</a:t>
             </a:r>
-            <a:endParaRPr lang="en-US" sz="1050" dirty="0"/>
+            <a:endParaRPr lang="en-US" sz="1400" dirty="0"/>
           </a:p>
         </p:txBody>
       </p:sp>
@@ -9964,7 +9290,62 @@
                 <a:ea typeface="Palatino Linotype" pitchFamily="34" charset="-122"/>
                 <a:cs typeface="Palatino Linotype" pitchFamily="34" charset="-120"/>
               </a:rPr>
-              <a:t>Admin Felület Megvalósítása</a:t>
+              <a:t>Admin </a:t>
+            </a:r>
+            <a:r>
+              <a:rPr lang="hu-HU" sz="3200" b="1" dirty="0">
+                <a:solidFill>
+                  <a:srgbClr val="FFFFFF"/>
+                </a:solidFill>
+                <a:latin typeface="Palatino Linotype" pitchFamily="34" charset="0"/>
+                <a:ea typeface="Palatino Linotype" pitchFamily="34" charset="-122"/>
+                <a:cs typeface="Palatino Linotype" pitchFamily="34" charset="-120"/>
+              </a:rPr>
+              <a:t>f</a:t>
+            </a:r>
+            <a:r>
+              <a:rPr lang="en-US" sz="3200" b="1" dirty="0" err="1">
+                <a:solidFill>
+                  <a:srgbClr val="FFFFFF"/>
+                </a:solidFill>
+                <a:latin typeface="Palatino Linotype" pitchFamily="34" charset="0"/>
+                <a:ea typeface="Palatino Linotype" pitchFamily="34" charset="-122"/>
+                <a:cs typeface="Palatino Linotype" pitchFamily="34" charset="-120"/>
+              </a:rPr>
+              <a:t>elület</a:t>
+            </a:r>
+            <a:r>
+              <a:rPr lang="en-US" sz="3200" b="1" dirty="0">
+                <a:solidFill>
+                  <a:srgbClr val="FFFFFF"/>
+                </a:solidFill>
+                <a:latin typeface="Palatino Linotype" pitchFamily="34" charset="0"/>
+                <a:ea typeface="Palatino Linotype" pitchFamily="34" charset="-122"/>
+                <a:cs typeface="Palatino Linotype" pitchFamily="34" charset="-120"/>
+              </a:rPr>
+              <a:t> </a:t>
+            </a:r>
+            <a:r>
+              <a:rPr lang="hu-HU" sz="3200" b="1" dirty="0">
+                <a:solidFill>
+                  <a:srgbClr val="FFFFFF"/>
+                </a:solidFill>
+                <a:latin typeface="Palatino Linotype" pitchFamily="34" charset="0"/>
+                <a:ea typeface="Palatino Linotype" pitchFamily="34" charset="-122"/>
+                <a:cs typeface="Palatino Linotype" pitchFamily="34" charset="-120"/>
+              </a:rPr>
+              <a:t>m</a:t>
+            </a:r>
+            <a:r>
+              <a:rPr lang="en-US" sz="3200" b="1" dirty="0" err="1">
+                <a:solidFill>
+                  <a:srgbClr val="FFFFFF"/>
+                </a:solidFill>
+                <a:latin typeface="Palatino Linotype" pitchFamily="34" charset="0"/>
+                <a:ea typeface="Palatino Linotype" pitchFamily="34" charset="-122"/>
+                <a:cs typeface="Palatino Linotype" pitchFamily="34" charset="-120"/>
+              </a:rPr>
+              <a:t>egvalósítása</a:t>
             </a:r>
             <a:endParaRPr lang="en-US" sz="3200" dirty="0"/>
           </a:p>
@@ -10130,7 +9511,7 @@
               <a:buNone/>
             </a:pPr>
             <a:r>
-              <a:rPr lang="en-US" sz="1350" b="1" dirty="0">
+              <a:rPr lang="en-US" b="1" dirty="0">
                 <a:solidFill>
                   <a:srgbClr val="FFFFFF"/>
                 </a:solidFill>
@@ -10140,7 +9521,7 @@
               </a:rPr>
               <a:t>Szerepkör alapú hozzáférés</a:t>
             </a:r>
-            <a:endParaRPr lang="en-US" sz="1350" dirty="0"/>
+            <a:endParaRPr lang="en-US" dirty="0"/>
           </a:p>
         </p:txBody>
       </p:sp>
@@ -10201,7 +9582,7 @@
               <a:buNone/>
             </a:pPr>
             <a:r>
-              <a:rPr lang="en-US" sz="1050" dirty="0">
+              <a:rPr lang="en-US" sz="1400" dirty="0">
                 <a:solidFill>
                   <a:srgbClr val="C5D5E8"/>
                 </a:solidFill>
@@ -10211,7 +9592,7 @@
               </a:rPr>
               <a:t>role: 'user' / 'admin'  ·  JWT payload-ban</a:t>
             </a:r>
-            <a:endParaRPr lang="en-US" sz="1050" dirty="0"/>
+            <a:endParaRPr lang="en-US" sz="1400" dirty="0"/>
           </a:p>
         </p:txBody>
       </p:sp>
@@ -10307,92 +9688,90 @@
           <a:bodyPr wrap="square" lIns="0" tIns="0" rIns="0" bIns="0" rtlCol="0" anchor="b"/>
           <a:lstStyle/>
           <a:p>
+            <a:r>
+              <a:rPr lang="hu-HU" b="1" dirty="0">
+                <a:solidFill>
+                  <a:srgbClr val="FFFFFF"/>
+                </a:solidFill>
+                <a:latin typeface="Trebuchet MS" pitchFamily="34" charset="0"/>
+              </a:rPr>
+              <a:t>Termékkezelés (CRUD)</a:t>
+            </a:r>
+            <a:endParaRPr lang="en-US" b="1" dirty="0">
+              <a:solidFill>
+                <a:srgbClr val="FFFFFF"/>
+              </a:solidFill>
+              <a:latin typeface="Trebuchet MS" pitchFamily="34" charset="0"/>
+            </a:endParaRPr>
+          </a:p>
+        </p:txBody>
+      </p:sp>
+      <p:sp>
+        <p:nvSpPr>
+          <p:cNvPr id="15" name="Shape 13"/>
+          <p:cNvSpPr/>
+          <p:nvPr/>
+        </p:nvSpPr>
+        <p:spPr>
+          <a:xfrm>
+            <a:off x="4919472" y="1792224"/>
+            <a:ext cx="3566160" cy="36576"/>
+          </a:xfrm>
+          <a:prstGeom prst="rect">
+            <a:avLst/>
+          </a:prstGeom>
+          <a:solidFill>
+            <a:srgbClr val="E9A227"/>
+          </a:solidFill>
+          <a:ln w="12700">
+            <a:solidFill>
+              <a:srgbClr val="E9A227"/>
+            </a:solidFill>
+            <a:prstDash val="solid"/>
+          </a:ln>
+        </p:spPr>
+        <p:txBody>
+          <a:bodyPr/>
+          <a:lstStyle/>
+          <a:p>
+            <a:endParaRPr lang="hu-HU"/>
+          </a:p>
+        </p:txBody>
+      </p:sp>
+      <p:sp>
+        <p:nvSpPr>
+          <p:cNvPr id="16" name="Text 14"/>
+          <p:cNvSpPr/>
+          <p:nvPr/>
+        </p:nvSpPr>
+        <p:spPr>
+          <a:xfrm>
+            <a:off x="4919472" y="1883664"/>
+            <a:ext cx="3749040" cy="320040"/>
+          </a:xfrm>
+          <a:prstGeom prst="rect">
+            <a:avLst/>
+          </a:prstGeom>
+          <a:noFill/>
+          <a:ln/>
+        </p:spPr>
+        <p:txBody>
+          <a:bodyPr wrap="square" lIns="0" tIns="0" rIns="0" bIns="0" rtlCol="0" anchor="ctr"/>
+          <a:lstStyle/>
+          <a:p>
             <a:pPr marL="0" indent="0">
               <a:buNone/>
             </a:pPr>
             <a:r>
-              <a:rPr lang="en-US" sz="1350" b="1" dirty="0">
-                <a:solidFill>
-                  <a:srgbClr val="FFFFFF"/>
+              <a:rPr lang="hu-HU" sz="1400" dirty="0">
+                <a:solidFill>
+                  <a:srgbClr val="C5D5E8"/>
                 </a:solidFill>
                 <a:latin typeface="Trebuchet MS" pitchFamily="34" charset="0"/>
-                <a:ea typeface="Trebuchet MS" pitchFamily="34" charset="-122"/>
-                <a:cs typeface="Trebuchet MS" pitchFamily="34" charset="-120"/>
-              </a:rPr>
-              <a:t>Termék hozzáadása, szerkesztése, törlése</a:t>
-            </a:r>
-            <a:endParaRPr lang="en-US" sz="1350" dirty="0"/>
-          </a:p>
-        </p:txBody>
-      </p:sp>
-      <p:sp>
-        <p:nvSpPr>
-          <p:cNvPr id="15" name="Shape 13"/>
-          <p:cNvSpPr/>
-          <p:nvPr/>
-        </p:nvSpPr>
-        <p:spPr>
-          <a:xfrm>
-            <a:off x="4919472" y="1792224"/>
-            <a:ext cx="3566160" cy="36576"/>
-          </a:xfrm>
-          <a:prstGeom prst="rect">
-            <a:avLst/>
-          </a:prstGeom>
-          <a:solidFill>
-            <a:srgbClr val="E9A227"/>
-          </a:solidFill>
-          <a:ln w="12700">
-            <a:solidFill>
-              <a:srgbClr val="E9A227"/>
-            </a:solidFill>
-            <a:prstDash val="solid"/>
-          </a:ln>
-        </p:spPr>
-        <p:txBody>
-          <a:bodyPr/>
-          <a:lstStyle/>
-          <a:p>
-            <a:endParaRPr lang="hu-HU"/>
-          </a:p>
-        </p:txBody>
-      </p:sp>
-      <p:sp>
-        <p:nvSpPr>
-          <p:cNvPr id="16" name="Text 14"/>
-          <p:cNvSpPr/>
-          <p:nvPr/>
-        </p:nvSpPr>
-        <p:spPr>
-          <a:xfrm>
-            <a:off x="4919472" y="1883664"/>
-            <a:ext cx="3749040" cy="320040"/>
-          </a:xfrm>
-          <a:prstGeom prst="rect">
-            <a:avLst/>
-          </a:prstGeom>
-          <a:noFill/>
-          <a:ln/>
-        </p:spPr>
-        <p:txBody>
-          <a:bodyPr wrap="square" lIns="0" tIns="0" rIns="0" bIns="0" rtlCol="0" anchor="ctr"/>
-          <a:lstStyle/>
-          <a:p>
-            <a:pPr marL="0" indent="0">
-              <a:buNone/>
-            </a:pPr>
-            <a:r>
-              <a:rPr lang="en-US" sz="1050" dirty="0">
-                <a:solidFill>
-                  <a:srgbClr val="C5D5E8"/>
-                </a:solidFill>
-                <a:latin typeface="Trebuchet MS" pitchFamily="34" charset="0"/>
-                <a:ea typeface="Trebuchet MS" pitchFamily="34" charset="-122"/>
-                <a:cs typeface="Trebuchet MS" pitchFamily="34" charset="-120"/>
-              </a:rPr>
-              <a:t>Teljes CRUD műveletek adminoknak</a:t>
-            </a:r>
-            <a:endParaRPr lang="en-US" sz="1050" dirty="0"/>
+              </a:rPr>
+              <a:t>Mindent lefedő termékkezelés</a:t>
+            </a:r>
+            <a:endParaRPr lang="en-US" sz="1400" dirty="0"/>
           </a:p>
         </p:txBody>
       </p:sp>
@@ -10492,7 +9871,7 @@
               <a:buNone/>
             </a:pPr>
             <a:r>
-              <a:rPr lang="en-US" sz="1350" b="1" dirty="0">
+              <a:rPr lang="en-US" b="1" dirty="0" err="1">
                 <a:solidFill>
                   <a:srgbClr val="FFFFFF"/>
                 </a:solidFill>
@@ -10500,9 +9879,42 @@
                 <a:ea typeface="Trebuchet MS" pitchFamily="34" charset="-122"/>
                 <a:cs typeface="Trebuchet MS" pitchFamily="34" charset="-120"/>
               </a:rPr>
-              <a:t>Rendelések listázása, törlése, lezárása</a:t>
-            </a:r>
-            <a:endParaRPr lang="en-US" sz="1350" dirty="0"/>
+              <a:t>Rendelések</a:t>
+            </a:r>
+            <a:r>
+              <a:rPr lang="en-US" b="1" dirty="0">
+                <a:solidFill>
+                  <a:srgbClr val="FFFFFF"/>
+                </a:solidFill>
+                <a:latin typeface="Trebuchet MS" pitchFamily="34" charset="0"/>
+                <a:ea typeface="Trebuchet MS" pitchFamily="34" charset="-122"/>
+                <a:cs typeface="Trebuchet MS" pitchFamily="34" charset="-120"/>
+              </a:rPr>
+              <a:t> </a:t>
+            </a:r>
+            <a:r>
+              <a:rPr lang="en-US" b="1" dirty="0" err="1">
+                <a:solidFill>
+                  <a:srgbClr val="FFFFFF"/>
+                </a:solidFill>
+                <a:latin typeface="Trebuchet MS" pitchFamily="34" charset="0"/>
+                <a:ea typeface="Trebuchet MS" pitchFamily="34" charset="-122"/>
+                <a:cs typeface="Trebuchet MS" pitchFamily="34" charset="-120"/>
+              </a:rPr>
+              <a:t>listázása</a:t>
+            </a:r>
+            <a:r>
+              <a:rPr lang="en-US" b="1" dirty="0">
+                <a:solidFill>
+                  <a:srgbClr val="FFFFFF"/>
+                </a:solidFill>
+                <a:latin typeface="Trebuchet MS" pitchFamily="34" charset="0"/>
+                <a:ea typeface="Trebuchet MS" pitchFamily="34" charset="-122"/>
+                <a:cs typeface="Trebuchet MS" pitchFamily="34" charset="-120"/>
+              </a:rPr>
+              <a:t>, lezárása</a:t>
+            </a:r>
+            <a:endParaRPr lang="en-US" dirty="0"/>
           </a:p>
         </p:txBody>
       </p:sp>
@@ -10563,17 +9975,15 @@
               <a:buNone/>
             </a:pPr>
             <a:r>
-              <a:rPr lang="en-US" sz="1050" dirty="0">
+              <a:rPr lang="hu-HU" sz="1400" dirty="0">
                 <a:solidFill>
                   <a:srgbClr val="C5D5E8"/>
                 </a:solidFill>
                 <a:latin typeface="Trebuchet MS" pitchFamily="34" charset="0"/>
-                <a:ea typeface="Trebuchet MS" pitchFamily="34" charset="-122"/>
-                <a:cs typeface="Trebuchet MS" pitchFamily="34" charset="-120"/>
-              </a:rPr>
-              <a:t>Admin dashboard nézetből</a:t>
-            </a:r>
-            <a:endParaRPr lang="en-US" sz="1050" dirty="0"/>
+              </a:rPr>
+              <a:t>Külön felület az összefüggő funkcióknak</a:t>
+            </a:r>
+            <a:endParaRPr lang="en-US" sz="1400" dirty="0"/>
           </a:p>
         </p:txBody>
       </p:sp>
@@ -10673,7 +10083,7 @@
               <a:buNone/>
             </a:pPr>
             <a:r>
-              <a:rPr lang="en-US" sz="1350" b="1" dirty="0">
+              <a:rPr lang="en-US" b="1" dirty="0" err="1">
                 <a:solidFill>
                   <a:srgbClr val="FFFFFF"/>
                 </a:solidFill>
@@ -10681,9 +10091,42 @@
                 <a:ea typeface="Trebuchet MS" pitchFamily="34" charset="-122"/>
                 <a:cs typeface="Trebuchet MS" pitchFamily="34" charset="-120"/>
               </a:rPr>
-              <a:t>Felhasználók böngészése</a:t>
-            </a:r>
-            <a:endParaRPr lang="en-US" sz="1350" dirty="0"/>
+              <a:t>Felhasználók</a:t>
+            </a:r>
+            <a:r>
+              <a:rPr lang="hu-HU" b="1" dirty="0">
+                <a:solidFill>
+                  <a:srgbClr val="FFFFFF"/>
+                </a:solidFill>
+                <a:latin typeface="Trebuchet MS" pitchFamily="34" charset="0"/>
+                <a:ea typeface="Trebuchet MS" pitchFamily="34" charset="-122"/>
+                <a:cs typeface="Trebuchet MS" pitchFamily="34" charset="-120"/>
+              </a:rPr>
+              <a:t> között</a:t>
+            </a:r>
+            <a:r>
+              <a:rPr lang="en-US" b="1" dirty="0">
+                <a:solidFill>
+                  <a:srgbClr val="FFFFFF"/>
+                </a:solidFill>
+                <a:latin typeface="Trebuchet MS" pitchFamily="34" charset="0"/>
+                <a:ea typeface="Trebuchet MS" pitchFamily="34" charset="-122"/>
+                <a:cs typeface="Trebuchet MS" pitchFamily="34" charset="-120"/>
+              </a:rPr>
+              <a:t> </a:t>
+            </a:r>
+            <a:r>
+              <a:rPr lang="en-US" b="1" dirty="0" err="1">
+                <a:solidFill>
+                  <a:srgbClr val="FFFFFF"/>
+                </a:solidFill>
+                <a:latin typeface="Trebuchet MS" pitchFamily="34" charset="0"/>
+                <a:ea typeface="Trebuchet MS" pitchFamily="34" charset="-122"/>
+                <a:cs typeface="Trebuchet MS" pitchFamily="34" charset="-120"/>
+              </a:rPr>
+              <a:t>böngészés</a:t>
+            </a:r>
+            <a:endParaRPr lang="en-US" dirty="0"/>
           </a:p>
         </p:txBody>
       </p:sp>
@@ -10744,7 +10187,7 @@
               <a:buNone/>
             </a:pPr>
             <a:r>
-              <a:rPr lang="en-US" sz="1050" dirty="0">
+              <a:rPr lang="hu-HU" sz="1400" dirty="0">
                 <a:solidFill>
                   <a:srgbClr val="C5D5E8"/>
                 </a:solidFill>
@@ -10752,9 +10195,31 @@
                 <a:ea typeface="Trebuchet MS" pitchFamily="34" charset="-122"/>
                 <a:cs typeface="Trebuchet MS" pitchFamily="34" charset="-120"/>
               </a:rPr>
-              <a:t>Felhasználó-kezelő modul</a:t>
-            </a:r>
-            <a:endParaRPr lang="en-US" sz="1050" dirty="0"/>
+              <a:t>F</a:t>
+            </a:r>
+            <a:r>
+              <a:rPr lang="en-US" sz="1400" dirty="0" err="1">
+                <a:solidFill>
+                  <a:srgbClr val="C5D5E8"/>
+                </a:solidFill>
+                <a:latin typeface="Trebuchet MS" pitchFamily="34" charset="0"/>
+                <a:ea typeface="Trebuchet MS" pitchFamily="34" charset="-122"/>
+                <a:cs typeface="Trebuchet MS" pitchFamily="34" charset="-120"/>
+              </a:rPr>
+              <a:t>elhasználó-kezelő</a:t>
+            </a:r>
+            <a:r>
+              <a:rPr lang="en-US" sz="1400" dirty="0">
+                <a:solidFill>
+                  <a:srgbClr val="C5D5E8"/>
+                </a:solidFill>
+                <a:latin typeface="Trebuchet MS" pitchFamily="34" charset="0"/>
+                <a:ea typeface="Trebuchet MS" pitchFamily="34" charset="-122"/>
+                <a:cs typeface="Trebuchet MS" pitchFamily="34" charset="-120"/>
+              </a:rPr>
+              <a:t> modul</a:t>
+            </a:r>
+            <a:endParaRPr lang="en-US" sz="1400" dirty="0"/>
           </a:p>
         </p:txBody>
       </p:sp>
@@ -10854,7 +10319,7 @@
               <a:buNone/>
             </a:pPr>
             <a:r>
-              <a:rPr lang="en-US" sz="1350" b="1" dirty="0">
+              <a:rPr lang="en-US" b="1" dirty="0">
                 <a:solidFill>
                   <a:srgbClr val="FFFFFF"/>
                 </a:solidFill>
@@ -10864,7 +10329,7 @@
               </a:rPr>
               <a:t>Szervizek listázása és böngészése</a:t>
             </a:r>
-            <a:endParaRPr lang="en-US" sz="1350" dirty="0"/>
+            <a:endParaRPr lang="en-US" dirty="0"/>
           </a:p>
         </p:txBody>
       </p:sp>
@@ -10925,7 +10390,7 @@
               <a:buNone/>
             </a:pPr>
             <a:r>
-              <a:rPr lang="en-US" sz="1050" dirty="0">
+              <a:rPr lang="en-US" sz="1400" dirty="0">
                 <a:solidFill>
                   <a:srgbClr val="C5D5E8"/>
                 </a:solidFill>
@@ -10935,7 +10400,7 @@
               </a:rPr>
               <a:t>Szerviz adminisztrációs felület</a:t>
             </a:r>
-            <a:endParaRPr lang="en-US" sz="1050" dirty="0"/>
+            <a:endParaRPr lang="en-US" sz="1400" dirty="0"/>
           </a:p>
         </p:txBody>
       </p:sp>
@@ -10974,7 +10439,7 @@
           <a:bodyPr/>
           <a:lstStyle/>
           <a:p>
-            <a:endParaRPr lang="hu-HU"/>
+            <a:endParaRPr lang="hu-HU" dirty="0"/>
           </a:p>
         </p:txBody>
       </p:sp>
@@ -11029,94 +10494,92 @@
         </p:spPr>
         <p:txBody>
           <a:bodyPr wrap="square" lIns="0" tIns="0" rIns="0" bIns="0" rtlCol="0" anchor="b"/>
+          <a:lstStyle/>
+          <a:p>
+            <a:r>
+              <a:rPr lang="hu-HU" b="1" dirty="0">
+                <a:solidFill>
+                  <a:srgbClr val="FFFFFF"/>
+                </a:solidFill>
+                <a:latin typeface="Trebuchet MS" pitchFamily="34" charset="0"/>
+              </a:rPr>
+              <a:t>Automatikus e-mail értesítések</a:t>
+            </a:r>
+            <a:endParaRPr lang="en-US" b="1" dirty="0">
+              <a:solidFill>
+                <a:srgbClr val="FFFFFF"/>
+              </a:solidFill>
+              <a:latin typeface="Trebuchet MS" pitchFamily="34" charset="0"/>
+            </a:endParaRPr>
+          </a:p>
+        </p:txBody>
+      </p:sp>
+      <p:sp>
+        <p:nvSpPr>
+          <p:cNvPr id="35" name="Shape 33"/>
+          <p:cNvSpPr/>
+          <p:nvPr/>
+        </p:nvSpPr>
+        <p:spPr>
+          <a:xfrm>
+            <a:off x="4919472" y="4315968"/>
+            <a:ext cx="3566160" cy="36576"/>
+          </a:xfrm>
+          <a:prstGeom prst="rect">
+            <a:avLst/>
+          </a:prstGeom>
+          <a:solidFill>
+            <a:srgbClr val="E9A227"/>
+          </a:solidFill>
+          <a:ln w="12700">
+            <a:solidFill>
+              <a:srgbClr val="E9A227"/>
+            </a:solidFill>
+            <a:prstDash val="solid"/>
+          </a:ln>
+        </p:spPr>
+        <p:txBody>
+          <a:bodyPr/>
+          <a:lstStyle/>
+          <a:p>
+            <a:endParaRPr lang="hu-HU"/>
+          </a:p>
+        </p:txBody>
+      </p:sp>
+      <p:sp>
+        <p:nvSpPr>
+          <p:cNvPr id="36" name="Text 34"/>
+          <p:cNvSpPr/>
+          <p:nvPr/>
+        </p:nvSpPr>
+        <p:spPr>
+          <a:xfrm>
+            <a:off x="4919472" y="4407408"/>
+            <a:ext cx="3749040" cy="320040"/>
+          </a:xfrm>
+          <a:prstGeom prst="rect">
+            <a:avLst/>
+          </a:prstGeom>
+          <a:noFill/>
+          <a:ln/>
+        </p:spPr>
+        <p:txBody>
+          <a:bodyPr wrap="square" lIns="0" tIns="0" rIns="0" bIns="0" rtlCol="0" anchor="ctr"/>
           <a:lstStyle/>
           <a:p>
             <a:pPr marL="0" indent="0">
               <a:buNone/>
             </a:pPr>
             <a:r>
-              <a:rPr lang="en-US" sz="1350" b="1" dirty="0">
-                <a:solidFill>
-                  <a:srgbClr val="FFFFFF"/>
+              <a:rPr lang="hu-HU" sz="1400" dirty="0">
+                <a:solidFill>
+                  <a:srgbClr val="C5D5E8"/>
                 </a:solidFill>
                 <a:latin typeface="Trebuchet MS" pitchFamily="34" charset="0"/>
-                <a:ea typeface="Trebuchet MS" pitchFamily="34" charset="-122"/>
-                <a:cs typeface="Trebuchet MS" pitchFamily="34" charset="-120"/>
-              </a:rPr>
-              <a:t>Rendelési státusz módosítása</a:t>
-            </a:r>
-            <a:endParaRPr lang="en-US" sz="1350" dirty="0"/>
-          </a:p>
-        </p:txBody>
-      </p:sp>
-      <p:sp>
-        <p:nvSpPr>
-          <p:cNvPr id="35" name="Shape 33"/>
-          <p:cNvSpPr/>
-          <p:nvPr/>
-        </p:nvSpPr>
-        <p:spPr>
-          <a:xfrm>
-            <a:off x="4919472" y="4315968"/>
-            <a:ext cx="3566160" cy="36576"/>
-          </a:xfrm>
-          <a:prstGeom prst="rect">
-            <a:avLst/>
-          </a:prstGeom>
-          <a:solidFill>
-            <a:srgbClr val="E9A227"/>
-          </a:solidFill>
-          <a:ln w="12700">
-            <a:solidFill>
-              <a:srgbClr val="E9A227"/>
-            </a:solidFill>
-            <a:prstDash val="solid"/>
-          </a:ln>
-        </p:spPr>
-        <p:txBody>
-          <a:bodyPr/>
-          <a:lstStyle/>
-          <a:p>
-            <a:endParaRPr lang="hu-HU"/>
-          </a:p>
-        </p:txBody>
-      </p:sp>
-      <p:sp>
-        <p:nvSpPr>
-          <p:cNvPr id="36" name="Text 34"/>
-          <p:cNvSpPr/>
-          <p:nvPr/>
-        </p:nvSpPr>
-        <p:spPr>
-          <a:xfrm>
-            <a:off x="4919472" y="4407408"/>
-            <a:ext cx="3749040" cy="320040"/>
-          </a:xfrm>
-          <a:prstGeom prst="rect">
-            <a:avLst/>
-          </a:prstGeom>
-          <a:noFill/>
-          <a:ln/>
-        </p:spPr>
-        <p:txBody>
-          <a:bodyPr wrap="square" lIns="0" tIns="0" rIns="0" bIns="0" rtlCol="0" anchor="ctr"/>
-          <a:lstStyle/>
-          <a:p>
-            <a:pPr marL="0" indent="0">
-              <a:buNone/>
-            </a:pPr>
-            <a:r>
-              <a:rPr lang="en-US" sz="1050" dirty="0">
-                <a:solidFill>
-                  <a:srgbClr val="C5D5E8"/>
-                </a:solidFill>
-                <a:latin typeface="Trebuchet MS" pitchFamily="34" charset="0"/>
-                <a:ea typeface="Trebuchet MS" pitchFamily="34" charset="-122"/>
-                <a:cs typeface="Trebuchet MS" pitchFamily="34" charset="-120"/>
-              </a:rPr>
-              <a:t>Order state machine</a:t>
-            </a:r>
-            <a:endParaRPr lang="en-US" sz="1050" dirty="0"/>
+              </a:rPr>
+              <a:t>Rendelési és szerviz műveleteknél</a:t>
+            </a:r>
+            <a:endParaRPr lang="en-US" sz="1400" dirty="0"/>
           </a:p>
         </p:txBody>
       </p:sp>
@@ -11416,7 +10879,7 @@
               <a:buNone/>
             </a:pPr>
             <a:r>
-              <a:rPr lang="en-US" sz="1450" dirty="0">
+              <a:rPr lang="en-US" dirty="0">
                 <a:solidFill>
                   <a:srgbClr val="FFFFFF"/>
                 </a:solidFill>
@@ -11426,7 +10889,7 @@
               </a:rPr>
               <a:t>Online fizetési integráció</a:t>
             </a:r>
-            <a:endParaRPr lang="en-US" sz="1450" dirty="0"/>
+            <a:endParaRPr lang="en-US" dirty="0"/>
           </a:p>
         </p:txBody>
       </p:sp>
@@ -11558,17 +11021,15 @@
               <a:buNone/>
             </a:pPr>
             <a:r>
-              <a:rPr lang="en-US" sz="1450" dirty="0">
+              <a:rPr lang="hu-HU" dirty="0">
                 <a:solidFill>
                   <a:srgbClr val="FFFFFF"/>
                 </a:solidFill>
                 <a:latin typeface="Trebuchet MS" pitchFamily="34" charset="0"/>
-                <a:ea typeface="Trebuchet MS" pitchFamily="34" charset="-122"/>
-                <a:cs typeface="Trebuchet MS" pitchFamily="34" charset="-120"/>
-              </a:rPr>
-              <a:t>Valódi email értesítések</a:t>
-            </a:r>
-            <a:endParaRPr lang="en-US" sz="1450" dirty="0"/>
+              </a:rPr>
+              <a:t>SMTP integráció valós környezetben</a:t>
+            </a:r>
+            <a:endParaRPr lang="en-US" dirty="0"/>
           </a:p>
         </p:txBody>
       </p:sp>
@@ -11700,7 +11161,7 @@
               <a:buNone/>
             </a:pPr>
             <a:r>
-              <a:rPr lang="en-US" sz="1450" dirty="0">
+              <a:rPr lang="en-US" dirty="0">
                 <a:solidFill>
                   <a:srgbClr val="FFFFFF"/>
                 </a:solidFill>
@@ -11710,7 +11171,7 @@
               </a:rPr>
               <a:t>Megfelelő megrendeléskezelés</a:t>
             </a:r>
-            <a:endParaRPr lang="en-US" sz="1450" dirty="0"/>
+            <a:endParaRPr lang="en-US" dirty="0"/>
           </a:p>
         </p:txBody>
       </p:sp>
@@ -11838,11 +11299,8 @@
           <a:bodyPr wrap="square" lIns="0" tIns="0" rIns="0" bIns="0" rtlCol="0" anchor="ctr"/>
           <a:lstStyle/>
           <a:p>
-            <a:pPr marL="0" indent="0">
-              <a:buNone/>
-            </a:pPr>
-            <a:r>
-              <a:rPr lang="en-US" sz="1450" dirty="0">
+            <a:r>
+              <a:rPr lang="en-US" dirty="0" err="1">
                 <a:solidFill>
                   <a:srgbClr val="FFFFFF"/>
                 </a:solidFill>
@@ -11850,9 +11308,53 @@
                 <a:ea typeface="Trebuchet MS" pitchFamily="34" charset="-122"/>
                 <a:cs typeface="Trebuchet MS" pitchFamily="34" charset="-120"/>
               </a:rPr>
-              <a:t>Adminisztrátori felület funkcióinak továbbfejlesztése</a:t>
-            </a:r>
-            <a:endParaRPr lang="en-US" sz="1450" dirty="0"/>
+              <a:t>Szerviz</a:t>
+            </a:r>
+            <a:r>
+              <a:rPr lang="en-US" dirty="0">
+                <a:solidFill>
+                  <a:srgbClr val="FFFFFF"/>
+                </a:solidFill>
+                <a:latin typeface="Trebuchet MS" pitchFamily="34" charset="0"/>
+                <a:ea typeface="Trebuchet MS" pitchFamily="34" charset="-122"/>
+                <a:cs typeface="Trebuchet MS" pitchFamily="34" charset="-120"/>
+              </a:rPr>
+              <a:t> </a:t>
+            </a:r>
+            <a:r>
+              <a:rPr lang="en-US" dirty="0" err="1">
+                <a:solidFill>
+                  <a:srgbClr val="FFFFFF"/>
+                </a:solidFill>
+                <a:latin typeface="Trebuchet MS" pitchFamily="34" charset="0"/>
+                <a:ea typeface="Trebuchet MS" pitchFamily="34" charset="-122"/>
+                <a:cs typeface="Trebuchet MS" pitchFamily="34" charset="-120"/>
+              </a:rPr>
+              <a:t>felület</a:t>
+            </a:r>
+            <a:r>
+              <a:rPr lang="en-US" dirty="0">
+                <a:solidFill>
+                  <a:srgbClr val="FFFFFF"/>
+                </a:solidFill>
+                <a:latin typeface="Trebuchet MS" pitchFamily="34" charset="0"/>
+                <a:ea typeface="Trebuchet MS" pitchFamily="34" charset="-122"/>
+                <a:cs typeface="Trebuchet MS" pitchFamily="34" charset="-120"/>
+              </a:rPr>
+              <a:t> </a:t>
+            </a:r>
+            <a:r>
+              <a:rPr lang="en-US" dirty="0" err="1">
+                <a:solidFill>
+                  <a:srgbClr val="FFFFFF"/>
+                </a:solidFill>
+                <a:latin typeface="Trebuchet MS" pitchFamily="34" charset="0"/>
+                <a:ea typeface="Trebuchet MS" pitchFamily="34" charset="-122"/>
+                <a:cs typeface="Trebuchet MS" pitchFamily="34" charset="-120"/>
+              </a:rPr>
+              <a:t>továbbfejlesztése</a:t>
+            </a:r>
+            <a:endParaRPr lang="en-US" dirty="0"/>
           </a:p>
         </p:txBody>
       </p:sp>
@@ -11891,7 +11393,7 @@
           <a:bodyPr/>
           <a:lstStyle/>
           <a:p>
-            <a:endParaRPr lang="hu-HU"/>
+            <a:endParaRPr lang="hu-HU" dirty="0"/>
           </a:p>
         </p:txBody>
       </p:sp>
@@ -11983,18 +11485,47 @@
             <a:pPr marL="0" indent="0">
               <a:buNone/>
             </a:pPr>
-            <a:r>
-              <a:rPr lang="en-US" sz="1450" dirty="0">
+            <a:endParaRPr lang="en-US" dirty="0"/>
+          </a:p>
+        </p:txBody>
+      </p:sp>
+      <p:sp>
+        <p:nvSpPr>
+          <p:cNvPr id="6" name="Szövegdoboz 5">
+            <a:extLst>
+              <a:ext uri="{FF2B5EF4-FFF2-40B4-BE49-F238E27FC236}">
+                <a16:creationId xmlns:a16="http://schemas.microsoft.com/office/drawing/2014/main" id="{BB3F5325-D90C-17CD-4585-708B37A64641}"/>
+              </a:ext>
+            </a:extLst>
+          </p:cNvPr>
+          <p:cNvSpPr txBox="1"/>
+          <p:nvPr/>
+        </p:nvSpPr>
+        <p:spPr>
+          <a:xfrm>
+            <a:off x="1024128" y="4466058"/>
+            <a:ext cx="4715490" cy="369332"/>
+          </a:xfrm>
+          <a:prstGeom prst="rect">
+            <a:avLst/>
+          </a:prstGeom>
+          <a:noFill/>
+        </p:spPr>
+        <p:txBody>
+          <a:bodyPr wrap="square" rtlCol="0">
+            <a:spAutoFit/>
+          </a:bodyPr>
+          <a:lstStyle/>
+          <a:p>
+            <a:r>
+              <a:rPr lang="hu-HU" dirty="0">
                 <a:solidFill>
                   <a:srgbClr val="FFFFFF"/>
                 </a:solidFill>
                 <a:latin typeface="Trebuchet MS" pitchFamily="34" charset="0"/>
-                <a:ea typeface="Trebuchet MS" pitchFamily="34" charset="-122"/>
-                <a:cs typeface="Trebuchet MS" pitchFamily="34" charset="-120"/>
-              </a:rPr>
-              <a:t>Szerviz felület továbbfejlesztése</a:t>
-            </a:r>
-            <a:endParaRPr lang="en-US" sz="1450" dirty="0"/>
+              </a:rPr>
+              <a:t>További kliens oldali funkciók beépítése</a:t>
+            </a:r>
           </a:p>
         </p:txBody>
       </p:sp>
@@ -12761,6 +12292,14 @@
 </file>
 
 <file path=customXml/item2.xml><?xml version="1.0" encoding="utf-8"?>
+<p:properties xmlns:p="http://schemas.microsoft.com/office/2006/metadata/properties" xmlns:xsi="http://www.w3.org/2001/XMLSchema-instance" xmlns:pc="http://schemas.microsoft.com/office/infopath/2007/PartnerControls">
+  <documentManagement>
+    <ReferenceId xmlns="87aa24f1-5ba0-4b45-9ca0-cb710780616f" xsi:nil="true"/>
+  </documentManagement>
+</p:properties>
+</file>
+
+<file path=customXml/item3.xml><?xml version="1.0" encoding="utf-8"?>
 <?mso-contentType ?>
 <FormTemplates xmlns="http://schemas.microsoft.com/sharepoint/v3/contenttype/forms">
   <Display>DocumentLibraryForm</Display>
@@ -12769,22 +12308,38 @@
 </FormTemplates>
 </file>
 
-<file path=customXml/item3.xml><?xml version="1.0" encoding="utf-8"?>
-<p:properties xmlns:p="http://schemas.microsoft.com/office/2006/metadata/properties" xmlns:xsi="http://www.w3.org/2001/XMLSchema-instance" xmlns:pc="http://schemas.microsoft.com/office/infopath/2007/PartnerControls">
-  <documentManagement>
-    <ReferenceId xmlns="87aa24f1-5ba0-4b45-9ca0-cb710780616f" xsi:nil="true"/>
-  </documentManagement>
-</p:properties>
-</file>
-
 <file path=customXml/itemProps1.xml><?xml version="1.0" encoding="utf-8"?>
-<ds:datastoreItem xmlns:ds="http://schemas.openxmlformats.org/officeDocument/2006/customXml" ds:itemID="{26430B49-CDF2-4854-9EF5-30E772CBB287}"/>
+<ds:datastoreItem xmlns:ds="http://schemas.openxmlformats.org/officeDocument/2006/customXml" ds:itemID="{26430B49-CDF2-4854-9EF5-30E772CBB287}">
+  <ds:schemaRefs>
+    <ds:schemaRef ds:uri="http://schemas.microsoft.com/office/2006/metadata/contentType"/>
+    <ds:schemaRef ds:uri="http://schemas.microsoft.com/office/2006/metadata/properties/metaAttributes"/>
+    <ds:schemaRef ds:uri="http://www.w3.org/2001/XMLSchema"/>
+    <ds:schemaRef ds:uri="http://schemas.microsoft.com/office/2006/metadata/properties"/>
+    <ds:schemaRef ds:uri="87aa24f1-5ba0-4b45-9ca0-cb710780616f"/>
+    <ds:schemaRef ds:uri="http://schemas.microsoft.com/office/2006/documentManagement/types"/>
+    <ds:schemaRef ds:uri="http://schemas.microsoft.com/office/infopath/2007/PartnerControls"/>
+    <ds:schemaRef ds:uri="http://schemas.openxmlformats.org/package/2006/metadata/core-properties"/>
+    <ds:schemaRef ds:uri="http://purl.org/dc/elements/1.1/"/>
+    <ds:schemaRef ds:uri="http://purl.org/dc/terms/"/>
+    <ds:schemaRef ds:uri="http://schemas.microsoft.com/internal/obd"/>
+  </ds:schemaRefs>
+</ds:datastoreItem>
 </file>
 
 <file path=customXml/itemProps2.xml><?xml version="1.0" encoding="utf-8"?>
-<ds:datastoreItem xmlns:ds="http://schemas.openxmlformats.org/officeDocument/2006/customXml" ds:itemID="{6200B2EB-C840-4BCD-BAB1-BC8073AF05E6}"/>
+<ds:datastoreItem xmlns:ds="http://schemas.openxmlformats.org/officeDocument/2006/customXml" ds:itemID="{EAC5D19B-4118-451B-867A-9FDFB4FA3F3D}">
+  <ds:schemaRefs>
+    <ds:schemaRef ds:uri="http://schemas.microsoft.com/office/2006/metadata/properties"/>
+    <ds:schemaRef ds:uri="http://schemas.microsoft.com/office/infopath/2007/PartnerControls"/>
+    <ds:schemaRef ds:uri="87aa24f1-5ba0-4b45-9ca0-cb710780616f"/>
+  </ds:schemaRefs>
+</ds:datastoreItem>
 </file>
 
 <file path=customXml/itemProps3.xml><?xml version="1.0" encoding="utf-8"?>
-<ds:datastoreItem xmlns:ds="http://schemas.openxmlformats.org/officeDocument/2006/customXml" ds:itemID="{EAC5D19B-4118-451B-867A-9FDFB4FA3F3D}"/>
+<ds:datastoreItem xmlns:ds="http://schemas.openxmlformats.org/officeDocument/2006/customXml" ds:itemID="{6200B2EB-C840-4BCD-BAB1-BC8073AF05E6}">
+  <ds:schemaRefs>
+    <ds:schemaRef ds:uri="http://schemas.microsoft.com/sharepoint/v3/contenttype/forms"/>
+  </ds:schemaRefs>
+</ds:datastoreItem>
 </file>
</xml_diff>

<commit_message>
még több ppt szerkesztés
</commit_message>
<xml_diff>
--- a/doc/CrossCountryWebshop_Premium (1).pptx
+++ b/doc/CrossCountryWebshop_Premium (1).pptx
@@ -2484,6 +2484,17 @@
               </a:rPr>
               <a:t>UI / UX</a:t>
             </a:r>
+            <a:r>
+              <a:rPr lang="hu-HU" sz="1600">
+                <a:solidFill>
+                  <a:srgbClr val="C5D5E8"/>
+                </a:solidFill>
+                <a:latin typeface="Trebuchet MS" pitchFamily="34" charset="0"/>
+                <a:ea typeface="Trebuchet MS" pitchFamily="34" charset="-122"/>
+                <a:cs typeface="Trebuchet MS" pitchFamily="34" charset="-120"/>
+              </a:rPr>
+              <a:t> design</a:t>
+            </a:r>
             <a:endParaRPr lang="en-US" sz="1600" dirty="0"/>
           </a:p>
         </p:txBody>
@@ -2509,42 +2520,6 @@
           <a:bodyPr wrap="square" lIns="0" tIns="0" rIns="0" bIns="0" rtlCol="0" anchor="ctr"/>
           <a:lstStyle/>
           <a:p>
-            <a:r>
-              <a:rPr lang="hu-HU" sz="1600" dirty="0" err="1">
-                <a:solidFill>
-                  <a:srgbClr val="C5D5E8"/>
-                </a:solidFill>
-                <a:latin typeface="Trebuchet MS" pitchFamily="34" charset="0"/>
-              </a:rPr>
-              <a:t>Token</a:t>
-            </a:r>
-            <a:r>
-              <a:rPr lang="hu-HU" sz="1600" dirty="0">
-                <a:solidFill>
-                  <a:srgbClr val="C5D5E8"/>
-                </a:solidFill>
-                <a:latin typeface="Trebuchet MS" pitchFamily="34" charset="0"/>
-              </a:rPr>
-              <a:t> / </a:t>
-            </a:r>
-            <a:r>
-              <a:rPr lang="hu-HU" sz="1600" dirty="0" err="1">
-                <a:solidFill>
-                  <a:srgbClr val="C5D5E8"/>
-                </a:solidFill>
-                <a:latin typeface="Trebuchet MS" pitchFamily="34" charset="0"/>
-              </a:rPr>
-              <a:t>role</a:t>
-            </a:r>
-            <a:r>
-              <a:rPr lang="hu-HU" sz="1600" dirty="0">
-                <a:solidFill>
-                  <a:srgbClr val="C5D5E8"/>
-                </a:solidFill>
-                <a:latin typeface="Trebuchet MS" pitchFamily="34" charset="0"/>
-              </a:rPr>
-              <a:t> kezelés</a:t>
-            </a:r>
             <a:endParaRPr lang="en-US" sz="1600" dirty="0">
               <a:solidFill>
                 <a:srgbClr val="C5D5E8"/>
@@ -3077,7 +3052,7 @@
               <a:buNone/>
             </a:pPr>
             <a:r>
-              <a:rPr lang="en-US" sz="1600" dirty="0">
+              <a:rPr lang="hu-HU" sz="1600" dirty="0">
                 <a:solidFill>
                   <a:srgbClr val="C5D5E8"/>
                 </a:solidFill>
@@ -3085,7 +3060,40 @@
                 <a:ea typeface="Trebuchet MS" pitchFamily="34" charset="-122"/>
                 <a:cs typeface="Trebuchet MS" pitchFamily="34" charset="-120"/>
               </a:rPr>
-              <a:t>Admin middleware </a:t>
+              <a:t>M</a:t>
+            </a:r>
+            <a:r>
+              <a:rPr lang="en-US" sz="1600" dirty="0" err="1">
+                <a:solidFill>
+                  <a:srgbClr val="C5D5E8"/>
+                </a:solidFill>
+                <a:latin typeface="Trebuchet MS" pitchFamily="34" charset="0"/>
+                <a:ea typeface="Trebuchet MS" pitchFamily="34" charset="-122"/>
+                <a:cs typeface="Trebuchet MS" pitchFamily="34" charset="-120"/>
+              </a:rPr>
+              <a:t>iddleware</a:t>
+            </a:r>
+            <a:r>
+              <a:rPr lang="hu-HU" sz="1600" dirty="0">
+                <a:solidFill>
+                  <a:srgbClr val="C5D5E8"/>
+                </a:solidFill>
+                <a:latin typeface="Trebuchet MS" pitchFamily="34" charset="0"/>
+                <a:ea typeface="Trebuchet MS" pitchFamily="34" charset="-122"/>
+                <a:cs typeface="Trebuchet MS" pitchFamily="34" charset="-120"/>
+              </a:rPr>
+              <a:t> kialakítása</a:t>
+            </a:r>
+            <a:r>
+              <a:rPr lang="en-US" sz="1600" dirty="0">
+                <a:solidFill>
+                  <a:srgbClr val="C5D5E8"/>
+                </a:solidFill>
+                <a:latin typeface="Trebuchet MS" pitchFamily="34" charset="0"/>
+                <a:ea typeface="Trebuchet MS" pitchFamily="34" charset="-122"/>
+                <a:cs typeface="Trebuchet MS" pitchFamily="34" charset="-120"/>
+              </a:rPr>
+              <a:t> </a:t>
             </a:r>
             <a:endParaRPr lang="hu-HU" sz="1600" dirty="0">
               <a:solidFill>
@@ -8079,13 +8087,13 @@
       </p:sp>
       <p:sp>
         <p:nvSpPr>
-          <p:cNvPr id="18" name="Shape 15"/>
-          <p:cNvSpPr/>
-          <p:nvPr/>
-        </p:nvSpPr>
-        <p:spPr>
-          <a:xfrm>
-            <a:off x="5074920" y="2770632"/>
+          <p:cNvPr id="22" name="Shape 19"/>
+          <p:cNvSpPr/>
+          <p:nvPr/>
+        </p:nvSpPr>
+        <p:spPr>
+          <a:xfrm>
+            <a:off x="5074920" y="2836469"/>
             <a:ext cx="3657600" cy="658368"/>
           </a:xfrm>
           <a:prstGeom prst="rect">
@@ -8118,13 +8126,13 @@
       </p:sp>
       <p:sp>
         <p:nvSpPr>
-          <p:cNvPr id="19" name="Shape 16"/>
-          <p:cNvSpPr/>
-          <p:nvPr/>
-        </p:nvSpPr>
-        <p:spPr>
-          <a:xfrm>
-            <a:off x="5074920" y="2770632"/>
+          <p:cNvPr id="23" name="Shape 20"/>
+          <p:cNvSpPr/>
+          <p:nvPr/>
+        </p:nvSpPr>
+        <p:spPr>
+          <a:xfrm>
+            <a:off x="5074920" y="2836469"/>
             <a:ext cx="45720" cy="658368"/>
           </a:xfrm>
           <a:prstGeom prst="rect">
@@ -8150,13 +8158,13 @@
       </p:sp>
       <p:sp>
         <p:nvSpPr>
-          <p:cNvPr id="20" name="Text 17"/>
-          <p:cNvSpPr/>
-          <p:nvPr/>
-        </p:nvSpPr>
-        <p:spPr>
-          <a:xfrm>
-            <a:off x="5248656" y="2843784"/>
+          <p:cNvPr id="24" name="Text 21"/>
+          <p:cNvSpPr/>
+          <p:nvPr/>
+        </p:nvSpPr>
+        <p:spPr>
+          <a:xfrm>
+            <a:off x="5248656" y="2909621"/>
             <a:ext cx="3383280" cy="274320"/>
           </a:xfrm>
           <a:prstGeom prst="rect">
@@ -8181,7 +8189,7 @@
                 <a:ea typeface="Trebuchet MS" pitchFamily="34" charset="-122"/>
                 <a:cs typeface="Trebuchet MS" pitchFamily="34" charset="-120"/>
               </a:rPr>
-              <a:t>Token generálás</a:t>
+              <a:t>Védett végpont</a:t>
             </a:r>
             <a:endParaRPr lang="en-US" dirty="0"/>
           </a:p>
@@ -8189,162 +8197,13 @@
       </p:sp>
       <p:sp>
         <p:nvSpPr>
-          <p:cNvPr id="21" name="Text 18"/>
-          <p:cNvSpPr/>
-          <p:nvPr/>
-        </p:nvSpPr>
-        <p:spPr>
-          <a:xfrm>
-            <a:off x="5248656" y="3154680"/>
-            <a:ext cx="3383280" cy="228600"/>
-          </a:xfrm>
-          <a:prstGeom prst="rect">
-            <a:avLst/>
-          </a:prstGeom>
-          <a:noFill/>
-          <a:ln/>
-        </p:spPr>
-        <p:txBody>
-          <a:bodyPr wrap="square" lIns="0" tIns="0" rIns="0" bIns="0" rtlCol="0" anchor="ctr"/>
-          <a:lstStyle/>
-          <a:p>
-            <a:pPr marL="0" indent="0">
-              <a:buNone/>
-            </a:pPr>
-            <a:r>
-              <a:rPr lang="en-US" sz="1400" dirty="0">
-                <a:solidFill>
-                  <a:srgbClr val="C5D5E8"/>
-                </a:solidFill>
-                <a:latin typeface="Trebuchet MS" pitchFamily="34" charset="0"/>
-                <a:ea typeface="Trebuchet MS" pitchFamily="34" charset="-122"/>
-                <a:cs typeface="Trebuchet MS" pitchFamily="34" charset="-120"/>
-              </a:rPr>
-              <a:t>jwt.sign( ) függvény — backenden</a:t>
-            </a:r>
-            <a:endParaRPr lang="en-US" sz="1400" dirty="0"/>
-          </a:p>
-        </p:txBody>
-      </p:sp>
-      <p:sp>
-        <p:nvSpPr>
-          <p:cNvPr id="22" name="Shape 19"/>
-          <p:cNvSpPr/>
-          <p:nvPr/>
-        </p:nvSpPr>
-        <p:spPr>
-          <a:xfrm>
-            <a:off x="5074920" y="3538728"/>
-            <a:ext cx="3657600" cy="658368"/>
-          </a:xfrm>
-          <a:prstGeom prst="rect">
-            <a:avLst/>
-          </a:prstGeom>
-          <a:solidFill>
-            <a:srgbClr val="1A2B42"/>
-          </a:solidFill>
-          <a:ln w="9525">
-            <a:solidFill>
-              <a:srgbClr val="1F3050"/>
-            </a:solidFill>
-            <a:prstDash val="solid"/>
-          </a:ln>
-          <a:effectLst>
-            <a:outerShdw blurRad="101600" dist="25400" dir="8100000" algn="bl" rotWithShape="0">
-              <a:srgbClr val="000000">
-                <a:alpha val="30000"/>
-              </a:srgbClr>
-            </a:outerShdw>
-          </a:effectLst>
-        </p:spPr>
-        <p:txBody>
-          <a:bodyPr/>
-          <a:lstStyle/>
-          <a:p>
-            <a:endParaRPr lang="hu-HU"/>
-          </a:p>
-        </p:txBody>
-      </p:sp>
-      <p:sp>
-        <p:nvSpPr>
-          <p:cNvPr id="23" name="Shape 20"/>
-          <p:cNvSpPr/>
-          <p:nvPr/>
-        </p:nvSpPr>
-        <p:spPr>
-          <a:xfrm>
-            <a:off x="5074920" y="3538728"/>
-            <a:ext cx="45720" cy="658368"/>
-          </a:xfrm>
-          <a:prstGeom prst="rect">
-            <a:avLst/>
-          </a:prstGeom>
-          <a:solidFill>
-            <a:srgbClr val="E9A227"/>
-          </a:solidFill>
-          <a:ln w="12700">
-            <a:solidFill>
-              <a:srgbClr val="E9A227"/>
-            </a:solidFill>
-            <a:prstDash val="solid"/>
-          </a:ln>
-        </p:spPr>
-        <p:txBody>
-          <a:bodyPr/>
-          <a:lstStyle/>
-          <a:p>
-            <a:endParaRPr lang="hu-HU"/>
-          </a:p>
-        </p:txBody>
-      </p:sp>
-      <p:sp>
-        <p:nvSpPr>
-          <p:cNvPr id="24" name="Text 21"/>
-          <p:cNvSpPr/>
-          <p:nvPr/>
-        </p:nvSpPr>
-        <p:spPr>
-          <a:xfrm>
-            <a:off x="5248656" y="3611880"/>
-            <a:ext cx="3383280" cy="274320"/>
-          </a:xfrm>
-          <a:prstGeom prst="rect">
-            <a:avLst/>
-          </a:prstGeom>
-          <a:noFill/>
-          <a:ln/>
-        </p:spPr>
-        <p:txBody>
-          <a:bodyPr wrap="square" lIns="0" tIns="0" rIns="0" bIns="0" rtlCol="0" anchor="ctr"/>
-          <a:lstStyle/>
-          <a:p>
-            <a:pPr marL="0" indent="0">
-              <a:buNone/>
-            </a:pPr>
-            <a:r>
-              <a:rPr lang="en-US" b="1" dirty="0">
-                <a:solidFill>
-                  <a:srgbClr val="FFFFFF"/>
-                </a:solidFill>
-                <a:latin typeface="Trebuchet MS" pitchFamily="34" charset="0"/>
-                <a:ea typeface="Trebuchet MS" pitchFamily="34" charset="-122"/>
-                <a:cs typeface="Trebuchet MS" pitchFamily="34" charset="-120"/>
-              </a:rPr>
-              <a:t>Védett végpont</a:t>
-            </a:r>
-            <a:endParaRPr lang="en-US" dirty="0"/>
-          </a:p>
-        </p:txBody>
-      </p:sp>
-      <p:sp>
-        <p:nvSpPr>
           <p:cNvPr id="25" name="Text 22"/>
           <p:cNvSpPr/>
           <p:nvPr/>
         </p:nvSpPr>
         <p:spPr>
           <a:xfrm>
-            <a:off x="5248656" y="3922776"/>
+            <a:off x="5248656" y="3220517"/>
             <a:ext cx="3383280" cy="228600"/>
           </a:xfrm>
           <a:prstGeom prst="rect">
@@ -12148,6 +12007,23 @@
 </file>
 
 <file path=customXml/item1.xml><?xml version="1.0" encoding="utf-8"?>
+<?mso-contentType ?>
+<FormTemplates xmlns="http://schemas.microsoft.com/sharepoint/v3/contenttype/forms">
+  <Display>DocumentLibraryForm</Display>
+  <Edit>DocumentLibraryForm</Edit>
+  <New>DocumentLibraryForm</New>
+</FormTemplates>
+</file>
+
+<file path=customXml/item2.xml><?xml version="1.0" encoding="utf-8"?>
+<p:properties xmlns:p="http://schemas.microsoft.com/office/2006/metadata/properties" xmlns:xsi="http://www.w3.org/2001/XMLSchema-instance" xmlns:pc="http://schemas.microsoft.com/office/infopath/2007/PartnerControls">
+  <documentManagement>
+    <ReferenceId xmlns="87aa24f1-5ba0-4b45-9ca0-cb710780616f" xsi:nil="true"/>
+  </documentManagement>
+</p:properties>
+</file>
+
+<file path=customXml/item3.xml><?xml version="1.0" encoding="utf-8"?>
 <ct:contentTypeSchema xmlns:ct="http://schemas.microsoft.com/office/2006/metadata/contentType" xmlns:ma="http://schemas.microsoft.com/office/2006/metadata/properties/metaAttributes" ct:_="" ma:_="" ma:contentTypeName="Dokumentum" ma:contentTypeID="0x010100CF33BF45BA2D51468C049D7F49465F36" ma:contentTypeVersion="4" ma:contentTypeDescription="Új dokumentum létrehozása." ma:contentTypeScope="" ma:versionID="99230fe3e1de2d885706f7e7f862bcf2">
   <xsd:schema xmlns:xsd="http://www.w3.org/2001/XMLSchema" xmlns:xs="http://www.w3.org/2001/XMLSchema" xmlns:p="http://schemas.microsoft.com/office/2006/metadata/properties" xmlns:ns2="87aa24f1-5ba0-4b45-9ca0-cb710780616f" targetNamespace="http://schemas.microsoft.com/office/2006/metadata/properties" ma:root="true" ma:fieldsID="4c780e0772cac3b1fb0a258a91ebf9e8" ns2:_="">
     <xsd:import namespace="87aa24f1-5ba0-4b45-9ca0-cb710780616f"/>
@@ -12291,24 +12167,25 @@
 </ct:contentTypeSchema>
 </file>
 
-<file path=customXml/item2.xml><?xml version="1.0" encoding="utf-8"?>
-<p:properties xmlns:p="http://schemas.microsoft.com/office/2006/metadata/properties" xmlns:xsi="http://www.w3.org/2001/XMLSchema-instance" xmlns:pc="http://schemas.microsoft.com/office/infopath/2007/PartnerControls">
-  <documentManagement>
-    <ReferenceId xmlns="87aa24f1-5ba0-4b45-9ca0-cb710780616f" xsi:nil="true"/>
-  </documentManagement>
-</p:properties>
+<file path=customXml/itemProps1.xml><?xml version="1.0" encoding="utf-8"?>
+<ds:datastoreItem xmlns:ds="http://schemas.openxmlformats.org/officeDocument/2006/customXml" ds:itemID="{6200B2EB-C840-4BCD-BAB1-BC8073AF05E6}">
+  <ds:schemaRefs>
+    <ds:schemaRef ds:uri="http://schemas.microsoft.com/sharepoint/v3/contenttype/forms"/>
+  </ds:schemaRefs>
+</ds:datastoreItem>
 </file>
 
-<file path=customXml/item3.xml><?xml version="1.0" encoding="utf-8"?>
-<?mso-contentType ?>
-<FormTemplates xmlns="http://schemas.microsoft.com/sharepoint/v3/contenttype/forms">
-  <Display>DocumentLibraryForm</Display>
-  <Edit>DocumentLibraryForm</Edit>
-  <New>DocumentLibraryForm</New>
-</FormTemplates>
+<file path=customXml/itemProps2.xml><?xml version="1.0" encoding="utf-8"?>
+<ds:datastoreItem xmlns:ds="http://schemas.openxmlformats.org/officeDocument/2006/customXml" ds:itemID="{EAC5D19B-4118-451B-867A-9FDFB4FA3F3D}">
+  <ds:schemaRefs>
+    <ds:schemaRef ds:uri="http://schemas.microsoft.com/office/2006/metadata/properties"/>
+    <ds:schemaRef ds:uri="http://schemas.microsoft.com/office/infopath/2007/PartnerControls"/>
+    <ds:schemaRef ds:uri="87aa24f1-5ba0-4b45-9ca0-cb710780616f"/>
+  </ds:schemaRefs>
+</ds:datastoreItem>
 </file>
 
-<file path=customXml/itemProps1.xml><?xml version="1.0" encoding="utf-8"?>
+<file path=customXml/itemProps3.xml><?xml version="1.0" encoding="utf-8"?>
 <ds:datastoreItem xmlns:ds="http://schemas.openxmlformats.org/officeDocument/2006/customXml" ds:itemID="{26430B49-CDF2-4854-9EF5-30E772CBB287}">
   <ds:schemaRefs>
     <ds:schemaRef ds:uri="http://schemas.microsoft.com/office/2006/metadata/contentType"/>
@@ -12324,22 +12201,4 @@
     <ds:schemaRef ds:uri="http://schemas.microsoft.com/internal/obd"/>
   </ds:schemaRefs>
 </ds:datastoreItem>
-</file>
-
-<file path=customXml/itemProps2.xml><?xml version="1.0" encoding="utf-8"?>
-<ds:datastoreItem xmlns:ds="http://schemas.openxmlformats.org/officeDocument/2006/customXml" ds:itemID="{EAC5D19B-4118-451B-867A-9FDFB4FA3F3D}">
-  <ds:schemaRefs>
-    <ds:schemaRef ds:uri="http://schemas.microsoft.com/office/2006/metadata/properties"/>
-    <ds:schemaRef ds:uri="http://schemas.microsoft.com/office/infopath/2007/PartnerControls"/>
-    <ds:schemaRef ds:uri="87aa24f1-5ba0-4b45-9ca0-cb710780616f"/>
-  </ds:schemaRefs>
-</ds:datastoreItem>
-</file>
-
-<file path=customXml/itemProps3.xml><?xml version="1.0" encoding="utf-8"?>
-<ds:datastoreItem xmlns:ds="http://schemas.openxmlformats.org/officeDocument/2006/customXml" ds:itemID="{6200B2EB-C840-4BCD-BAB1-BC8073AF05E6}">
-  <ds:schemaRefs>
-    <ds:schemaRef ds:uri="http://schemas.microsoft.com/sharepoint/v3/contenttype/forms"/>
-  </ds:schemaRefs>
-</ds:datastoreItem>
 </file>
</xml_diff>

<commit_message>
véletlenül 2 ppt lett de a helyes is jó helyre került
</commit_message>
<xml_diff>
--- a/doc/CrossCountryWebshop_Premium (1).pptx
+++ b/doc/CrossCountryWebshop_Premium (1).pptx
@@ -122,743 +122,6 @@
     </p:ext>
   </p:extLst>
 </p:presentation>
-</file>
-
-<file path=ppt/revisionInfo.xml><?xml version="1.0" encoding="utf-8"?>
-<p1510:revInfo xmlns:a="http://schemas.openxmlformats.org/drawingml/2006/main" xmlns:r="http://schemas.openxmlformats.org/officeDocument/2006/relationships" xmlns:p1510="http://schemas.microsoft.com/office/powerpoint/2015/10/main">
-  <p1510:revLst>
-    <p1510:client id="{30E26957-D098-4181-9C72-F4F77341B7BC}" v="60" dt="2026-04-14T04:35:37.630"/>
-  </p1510:revLst>
-</p1510:revInfo>
-</file>
-
-<file path=ppt/changesInfos/changesInfo1.xml><?xml version="1.0" encoding="utf-8"?>
-<pc:chgInfo xmlns:a="http://schemas.openxmlformats.org/drawingml/2006/main" xmlns:r="http://schemas.openxmlformats.org/officeDocument/2006/relationships" xmlns:ac="http://schemas.microsoft.com/office/drawing/2013/main/command" xmlns:pc="http://schemas.microsoft.com/office/powerpoint/2013/main/command">
-  <pc:docChgLst>
-    <pc:chgData name="Ádám Czirják" userId="688945b6dea242df" providerId="LiveId" clId="{D8E19705-0FAD-428B-87E6-52AA5BE1479A}"/>
-    <pc:docChg chg="undo custSel addSld delSld modSld sldOrd">
-      <pc:chgData name="Ádám Czirják" userId="688945b6dea242df" providerId="LiveId" clId="{D8E19705-0FAD-428B-87E6-52AA5BE1479A}" dt="2026-04-14T06:30:33.077" v="2440" actId="20577"/>
-      <pc:docMkLst>
-        <pc:docMk/>
-      </pc:docMkLst>
-      <pc:sldChg chg="addSp delSp modSp mod">
-        <pc:chgData name="Ádám Czirják" userId="688945b6dea242df" providerId="LiveId" clId="{D8E19705-0FAD-428B-87E6-52AA5BE1479A}" dt="2026-04-14T04:36:14.345" v="199" actId="1076"/>
-        <pc:sldMkLst>
-          <pc:docMk/>
-          <pc:sldMk cId="0" sldId="256"/>
-        </pc:sldMkLst>
-        <pc:spChg chg="add del mod">
-          <ac:chgData name="Ádám Czirják" userId="688945b6dea242df" providerId="LiveId" clId="{D8E19705-0FAD-428B-87E6-52AA5BE1479A}" dt="2026-04-14T04:35:18.449" v="148"/>
-          <ac:spMkLst>
-            <pc:docMk/>
-            <pc:sldMk cId="0" sldId="256"/>
-            <ac:spMk id="2" creationId="{7068B5E4-A13D-925E-EC10-0F68045863CE}"/>
-          </ac:spMkLst>
-        </pc:spChg>
-        <pc:spChg chg="mod">
-          <ac:chgData name="Ádám Czirják" userId="688945b6dea242df" providerId="LiveId" clId="{D8E19705-0FAD-428B-87E6-52AA5BE1479A}" dt="2026-04-14T04:35:16.447" v="146" actId="14100"/>
-          <ac:spMkLst>
-            <pc:docMk/>
-            <pc:sldMk cId="0" sldId="256"/>
-            <ac:spMk id="3" creationId="{00000000-0000-0000-0000-000000000000}"/>
-          </ac:spMkLst>
-        </pc:spChg>
-        <pc:spChg chg="mod">
-          <ac:chgData name="Ádám Czirják" userId="688945b6dea242df" providerId="LiveId" clId="{D8E19705-0FAD-428B-87E6-52AA5BE1479A}" dt="2026-04-14T04:35:00.171" v="144" actId="1076"/>
-          <ac:spMkLst>
-            <pc:docMk/>
-            <pc:sldMk cId="0" sldId="256"/>
-            <ac:spMk id="9" creationId="{00000000-0000-0000-0000-000000000000}"/>
-          </ac:spMkLst>
-        </pc:spChg>
-        <pc:spChg chg="add mod">
-          <ac:chgData name="Ádám Czirják" userId="688945b6dea242df" providerId="LiveId" clId="{D8E19705-0FAD-428B-87E6-52AA5BE1479A}" dt="2026-04-14T04:36:14.345" v="199" actId="1076"/>
-          <ac:spMkLst>
-            <pc:docMk/>
-            <pc:sldMk cId="0" sldId="256"/>
-            <ac:spMk id="11" creationId="{B6A0E304-1E45-1930-1B2C-D7C36430C15B}"/>
-          </ac:spMkLst>
-        </pc:spChg>
-      </pc:sldChg>
-      <pc:sldChg chg="addSp delSp modSp mod modAnim modNotesTx">
-        <pc:chgData name="Ádám Czirják" userId="688945b6dea242df" providerId="LiveId" clId="{D8E19705-0FAD-428B-87E6-52AA5BE1479A}" dt="2026-04-14T06:20:04.732" v="858" actId="20577"/>
-        <pc:sldMkLst>
-          <pc:docMk/>
-          <pc:sldMk cId="0" sldId="257"/>
-        </pc:sldMkLst>
-        <pc:spChg chg="add mod">
-          <ac:chgData name="Ádám Czirják" userId="688945b6dea242df" providerId="LiveId" clId="{D8E19705-0FAD-428B-87E6-52AA5BE1479A}" dt="2026-04-14T06:16:26.132" v="459" actId="1076"/>
-          <ac:spMkLst>
-            <pc:docMk/>
-            <pc:sldMk cId="0" sldId="257"/>
-            <ac:spMk id="6" creationId="{547D1E52-A55B-DA4B-3523-6D7F257F4DCE}"/>
-          </ac:spMkLst>
-        </pc:spChg>
-        <pc:spChg chg="add del">
-          <ac:chgData name="Ádám Czirják" userId="688945b6dea242df" providerId="LiveId" clId="{D8E19705-0FAD-428B-87E6-52AA5BE1479A}" dt="2026-04-14T06:15:45.639" v="455" actId="478"/>
-          <ac:spMkLst>
-            <pc:docMk/>
-            <pc:sldMk cId="0" sldId="257"/>
-            <ac:spMk id="7" creationId="{00000000-0000-0000-0000-000000000000}"/>
-          </ac:spMkLst>
-        </pc:spChg>
-        <pc:spChg chg="add del">
-          <ac:chgData name="Ádám Czirják" userId="688945b6dea242df" providerId="LiveId" clId="{D8E19705-0FAD-428B-87E6-52AA5BE1479A}" dt="2026-04-14T06:15:45.639" v="455" actId="478"/>
-          <ac:spMkLst>
-            <pc:docMk/>
-            <pc:sldMk cId="0" sldId="257"/>
-            <ac:spMk id="8" creationId="{00000000-0000-0000-0000-000000000000}"/>
-          </ac:spMkLst>
-        </pc:spChg>
-        <pc:spChg chg="add del">
-          <ac:chgData name="Ádám Czirják" userId="688945b6dea242df" providerId="LiveId" clId="{D8E19705-0FAD-428B-87E6-52AA5BE1479A}" dt="2026-04-14T06:15:45.639" v="455" actId="478"/>
-          <ac:spMkLst>
-            <pc:docMk/>
-            <pc:sldMk cId="0" sldId="257"/>
-            <ac:spMk id="9" creationId="{00000000-0000-0000-0000-000000000000}"/>
-          </ac:spMkLst>
-        </pc:spChg>
-        <pc:spChg chg="add del">
-          <ac:chgData name="Ádám Czirják" userId="688945b6dea242df" providerId="LiveId" clId="{D8E19705-0FAD-428B-87E6-52AA5BE1479A}" dt="2026-04-14T06:15:45.639" v="455" actId="478"/>
-          <ac:spMkLst>
-            <pc:docMk/>
-            <pc:sldMk cId="0" sldId="257"/>
-            <ac:spMk id="10" creationId="{00000000-0000-0000-0000-000000000000}"/>
-          </ac:spMkLst>
-        </pc:spChg>
-        <pc:spChg chg="add del">
-          <ac:chgData name="Ádám Czirják" userId="688945b6dea242df" providerId="LiveId" clId="{D8E19705-0FAD-428B-87E6-52AA5BE1479A}" dt="2026-04-14T06:15:45.639" v="455" actId="478"/>
-          <ac:spMkLst>
-            <pc:docMk/>
-            <pc:sldMk cId="0" sldId="257"/>
-            <ac:spMk id="11" creationId="{00000000-0000-0000-0000-000000000000}"/>
-          </ac:spMkLst>
-        </pc:spChg>
-        <pc:spChg chg="del">
-          <ac:chgData name="Ádám Czirják" userId="688945b6dea242df" providerId="LiveId" clId="{D8E19705-0FAD-428B-87E6-52AA5BE1479A}" dt="2026-04-14T06:15:49.955" v="456" actId="478"/>
-          <ac:spMkLst>
-            <pc:docMk/>
-            <pc:sldMk cId="0" sldId="257"/>
-            <ac:spMk id="12" creationId="{00000000-0000-0000-0000-000000000000}"/>
-          </ac:spMkLst>
-        </pc:spChg>
-        <pc:spChg chg="del">
-          <ac:chgData name="Ádám Czirják" userId="688945b6dea242df" providerId="LiveId" clId="{D8E19705-0FAD-428B-87E6-52AA5BE1479A}" dt="2026-04-14T06:15:49.955" v="456" actId="478"/>
-          <ac:spMkLst>
-            <pc:docMk/>
-            <pc:sldMk cId="0" sldId="257"/>
-            <ac:spMk id="13" creationId="{00000000-0000-0000-0000-000000000000}"/>
-          </ac:spMkLst>
-        </pc:spChg>
-        <pc:spChg chg="del">
-          <ac:chgData name="Ádám Czirják" userId="688945b6dea242df" providerId="LiveId" clId="{D8E19705-0FAD-428B-87E6-52AA5BE1479A}" dt="2026-04-14T06:15:49.955" v="456" actId="478"/>
-          <ac:spMkLst>
-            <pc:docMk/>
-            <pc:sldMk cId="0" sldId="257"/>
-            <ac:spMk id="14" creationId="{00000000-0000-0000-0000-000000000000}"/>
-          </ac:spMkLst>
-        </pc:spChg>
-        <pc:spChg chg="del">
-          <ac:chgData name="Ádám Czirják" userId="688945b6dea242df" providerId="LiveId" clId="{D8E19705-0FAD-428B-87E6-52AA5BE1479A}" dt="2026-04-14T06:15:49.955" v="456" actId="478"/>
-          <ac:spMkLst>
-            <pc:docMk/>
-            <pc:sldMk cId="0" sldId="257"/>
-            <ac:spMk id="15" creationId="{00000000-0000-0000-0000-000000000000}"/>
-          </ac:spMkLst>
-        </pc:spChg>
-        <pc:spChg chg="del">
-          <ac:chgData name="Ádám Czirják" userId="688945b6dea242df" providerId="LiveId" clId="{D8E19705-0FAD-428B-87E6-52AA5BE1479A}" dt="2026-04-14T06:15:49.955" v="456" actId="478"/>
-          <ac:spMkLst>
-            <pc:docMk/>
-            <pc:sldMk cId="0" sldId="257"/>
-            <ac:spMk id="16" creationId="{00000000-0000-0000-0000-000000000000}"/>
-          </ac:spMkLst>
-        </pc:spChg>
-        <pc:spChg chg="del">
-          <ac:chgData name="Ádám Czirják" userId="688945b6dea242df" providerId="LiveId" clId="{D8E19705-0FAD-428B-87E6-52AA5BE1479A}" dt="2026-04-14T06:15:53.515" v="457" actId="478"/>
-          <ac:spMkLst>
-            <pc:docMk/>
-            <pc:sldMk cId="0" sldId="257"/>
-            <ac:spMk id="17" creationId="{00000000-0000-0000-0000-000000000000}"/>
-          </ac:spMkLst>
-        </pc:spChg>
-        <pc:spChg chg="del">
-          <ac:chgData name="Ádám Czirják" userId="688945b6dea242df" providerId="LiveId" clId="{D8E19705-0FAD-428B-87E6-52AA5BE1479A}" dt="2026-04-14T06:15:53.515" v="457" actId="478"/>
-          <ac:spMkLst>
-            <pc:docMk/>
-            <pc:sldMk cId="0" sldId="257"/>
-            <ac:spMk id="18" creationId="{00000000-0000-0000-0000-000000000000}"/>
-          </ac:spMkLst>
-        </pc:spChg>
-        <pc:spChg chg="del">
-          <ac:chgData name="Ádám Czirják" userId="688945b6dea242df" providerId="LiveId" clId="{D8E19705-0FAD-428B-87E6-52AA5BE1479A}" dt="2026-04-14T06:15:53.515" v="457" actId="478"/>
-          <ac:spMkLst>
-            <pc:docMk/>
-            <pc:sldMk cId="0" sldId="257"/>
-            <ac:spMk id="19" creationId="{00000000-0000-0000-0000-000000000000}"/>
-          </ac:spMkLst>
-        </pc:spChg>
-        <pc:spChg chg="del">
-          <ac:chgData name="Ádám Czirják" userId="688945b6dea242df" providerId="LiveId" clId="{D8E19705-0FAD-428B-87E6-52AA5BE1479A}" dt="2026-04-14T06:15:53.515" v="457" actId="478"/>
-          <ac:spMkLst>
-            <pc:docMk/>
-            <pc:sldMk cId="0" sldId="257"/>
-            <ac:spMk id="20" creationId="{00000000-0000-0000-0000-000000000000}"/>
-          </ac:spMkLst>
-        </pc:spChg>
-        <pc:spChg chg="del">
-          <ac:chgData name="Ádám Czirják" userId="688945b6dea242df" providerId="LiveId" clId="{D8E19705-0FAD-428B-87E6-52AA5BE1479A}" dt="2026-04-14T06:15:53.515" v="457" actId="478"/>
-          <ac:spMkLst>
-            <pc:docMk/>
-            <pc:sldMk cId="0" sldId="257"/>
-            <ac:spMk id="21" creationId="{00000000-0000-0000-0000-000000000000}"/>
-          </ac:spMkLst>
-        </pc:spChg>
-        <pc:spChg chg="add mod">
-          <ac:chgData name="Ádám Czirják" userId="688945b6dea242df" providerId="LiveId" clId="{D8E19705-0FAD-428B-87E6-52AA5BE1479A}" dt="2026-04-14T06:16:26.132" v="459" actId="1076"/>
-          <ac:spMkLst>
-            <pc:docMk/>
-            <pc:sldMk cId="0" sldId="257"/>
-            <ac:spMk id="22" creationId="{B223007A-E269-CDDC-30B3-E15924F0B708}"/>
-          </ac:spMkLst>
-        </pc:spChg>
-        <pc:spChg chg="add mod">
-          <ac:chgData name="Ádám Czirják" userId="688945b6dea242df" providerId="LiveId" clId="{D8E19705-0FAD-428B-87E6-52AA5BE1479A}" dt="2026-04-14T06:16:26.132" v="459" actId="1076"/>
-          <ac:spMkLst>
-            <pc:docMk/>
-            <pc:sldMk cId="0" sldId="257"/>
-            <ac:spMk id="23" creationId="{04104CD0-BDAC-566B-7087-ECB64B857C37}"/>
-          </ac:spMkLst>
-        </pc:spChg>
-        <pc:spChg chg="add mod">
-          <ac:chgData name="Ádám Czirják" userId="688945b6dea242df" providerId="LiveId" clId="{D8E19705-0FAD-428B-87E6-52AA5BE1479A}" dt="2026-04-14T06:16:43.971" v="476" actId="1076"/>
-          <ac:spMkLst>
-            <pc:docMk/>
-            <pc:sldMk cId="0" sldId="257"/>
-            <ac:spMk id="24" creationId="{5CE47C65-9730-CF39-E10B-DF59AB7D1608}"/>
-          </ac:spMkLst>
-        </pc:spChg>
-        <pc:spChg chg="add mod">
-          <ac:chgData name="Ádám Czirják" userId="688945b6dea242df" providerId="LiveId" clId="{D8E19705-0FAD-428B-87E6-52AA5BE1479A}" dt="2026-04-14T06:16:51.972" v="478" actId="1076"/>
-          <ac:spMkLst>
-            <pc:docMk/>
-            <pc:sldMk cId="0" sldId="257"/>
-            <ac:spMk id="25" creationId="{83A06BFA-BF9A-4284-C4E8-7ED927F1120E}"/>
-          </ac:spMkLst>
-        </pc:spChg>
-        <pc:spChg chg="add mod">
-          <ac:chgData name="Ádám Czirják" userId="688945b6dea242df" providerId="LiveId" clId="{D8E19705-0FAD-428B-87E6-52AA5BE1479A}" dt="2026-04-14T06:16:51.972" v="478" actId="1076"/>
-          <ac:spMkLst>
-            <pc:docMk/>
-            <pc:sldMk cId="0" sldId="257"/>
-            <ac:spMk id="26" creationId="{6E04EB9C-0DB0-284C-AB83-F0DE6025E07D}"/>
-          </ac:spMkLst>
-        </pc:spChg>
-        <pc:spChg chg="add mod">
-          <ac:chgData name="Ádám Czirják" userId="688945b6dea242df" providerId="LiveId" clId="{D8E19705-0FAD-428B-87E6-52AA5BE1479A}" dt="2026-04-14T06:16:51.972" v="478" actId="1076"/>
-          <ac:spMkLst>
-            <pc:docMk/>
-            <pc:sldMk cId="0" sldId="257"/>
-            <ac:spMk id="27" creationId="{1E06CB7E-09B6-5C65-F4C0-CA763DE8C223}"/>
-          </ac:spMkLst>
-        </pc:spChg>
-        <pc:spChg chg="add mod">
-          <ac:chgData name="Ádám Czirják" userId="688945b6dea242df" providerId="LiveId" clId="{D8E19705-0FAD-428B-87E6-52AA5BE1479A}" dt="2026-04-14T06:17:39.057" v="503" actId="20577"/>
-          <ac:spMkLst>
-            <pc:docMk/>
-            <pc:sldMk cId="0" sldId="257"/>
-            <ac:spMk id="28" creationId="{D46B2BEF-3486-F2EA-D94E-21C5C12A6E6E}"/>
-          </ac:spMkLst>
-        </pc:spChg>
-        <pc:spChg chg="add mod">
-          <ac:chgData name="Ádám Czirják" userId="688945b6dea242df" providerId="LiveId" clId="{D8E19705-0FAD-428B-87E6-52AA5BE1479A}" dt="2026-04-14T06:17:31.379" v="494" actId="1076"/>
-          <ac:spMkLst>
-            <pc:docMk/>
-            <pc:sldMk cId="0" sldId="257"/>
-            <ac:spMk id="29" creationId="{32CDBBD7-BCFC-5EAA-22C2-C7140C9BE535}"/>
-          </ac:spMkLst>
-        </pc:spChg>
-        <pc:spChg chg="add mod">
-          <ac:chgData name="Ádám Czirják" userId="688945b6dea242df" providerId="LiveId" clId="{D8E19705-0FAD-428B-87E6-52AA5BE1479A}" dt="2026-04-14T06:17:31.379" v="494" actId="1076"/>
-          <ac:spMkLst>
-            <pc:docMk/>
-            <pc:sldMk cId="0" sldId="257"/>
-            <ac:spMk id="30" creationId="{54DE0831-78BF-31C0-D5F5-E7B9F524DFA5}"/>
-          </ac:spMkLst>
-        </pc:spChg>
-        <pc:spChg chg="add mod">
-          <ac:chgData name="Ádám Czirják" userId="688945b6dea242df" providerId="LiveId" clId="{D8E19705-0FAD-428B-87E6-52AA5BE1479A}" dt="2026-04-14T06:17:31.379" v="494" actId="1076"/>
-          <ac:spMkLst>
-            <pc:docMk/>
-            <pc:sldMk cId="0" sldId="257"/>
-            <ac:spMk id="31" creationId="{00F291BB-6268-A3CA-295D-CA87997C13AC}"/>
-          </ac:spMkLst>
-        </pc:spChg>
-        <pc:spChg chg="add mod">
-          <ac:chgData name="Ádám Czirják" userId="688945b6dea242df" providerId="LiveId" clId="{D8E19705-0FAD-428B-87E6-52AA5BE1479A}" dt="2026-04-14T06:17:37.013" v="502" actId="20577"/>
-          <ac:spMkLst>
-            <pc:docMk/>
-            <pc:sldMk cId="0" sldId="257"/>
-            <ac:spMk id="32" creationId="{E70D1300-C813-2692-8223-B0797076754F}"/>
-          </ac:spMkLst>
-        </pc:spChg>
-      </pc:sldChg>
-      <pc:sldChg chg="modNotesTx">
-        <pc:chgData name="Ádám Czirják" userId="688945b6dea242df" providerId="LiveId" clId="{D8E19705-0FAD-428B-87E6-52AA5BE1479A}" dt="2026-04-14T06:22:36.655" v="1226" actId="20577"/>
-        <pc:sldMkLst>
-          <pc:docMk/>
-          <pc:sldMk cId="0" sldId="258"/>
-        </pc:sldMkLst>
-      </pc:sldChg>
-      <pc:sldChg chg="modSp del mod">
-        <pc:chgData name="Ádám Czirják" userId="688945b6dea242df" providerId="LiveId" clId="{D8E19705-0FAD-428B-87E6-52AA5BE1479A}" dt="2026-04-14T04:56:06.481" v="416" actId="2696"/>
-        <pc:sldMkLst>
-          <pc:docMk/>
-          <pc:sldMk cId="0" sldId="259"/>
-        </pc:sldMkLst>
-        <pc:spChg chg="mod">
-          <ac:chgData name="Ádám Czirják" userId="688945b6dea242df" providerId="LiveId" clId="{D8E19705-0FAD-428B-87E6-52AA5BE1479A}" dt="2026-04-14T04:52:16.586" v="358" actId="21"/>
-          <ac:spMkLst>
-            <pc:docMk/>
-            <pc:sldMk cId="0" sldId="259"/>
-            <ac:spMk id="11" creationId="{00000000-0000-0000-0000-000000000000}"/>
-          </ac:spMkLst>
-        </pc:spChg>
-        <pc:spChg chg="mod">
-          <ac:chgData name="Ádám Czirják" userId="688945b6dea242df" providerId="LiveId" clId="{D8E19705-0FAD-428B-87E6-52AA5BE1479A}" dt="2026-04-14T04:52:26.934" v="361" actId="1076"/>
-          <ac:spMkLst>
-            <pc:docMk/>
-            <pc:sldMk cId="0" sldId="259"/>
-            <ac:spMk id="12" creationId="{00000000-0000-0000-0000-000000000000}"/>
-          </ac:spMkLst>
-        </pc:spChg>
-        <pc:spChg chg="mod">
-          <ac:chgData name="Ádám Czirják" userId="688945b6dea242df" providerId="LiveId" clId="{D8E19705-0FAD-428B-87E6-52AA5BE1479A}" dt="2026-04-14T04:52:31.216" v="362" actId="21"/>
-          <ac:spMkLst>
-            <pc:docMk/>
-            <pc:sldMk cId="0" sldId="259"/>
-            <ac:spMk id="16" creationId="{00000000-0000-0000-0000-000000000000}"/>
-          </ac:spMkLst>
-        </pc:spChg>
-        <pc:spChg chg="mod">
-          <ac:chgData name="Ádám Czirják" userId="688945b6dea242df" providerId="LiveId" clId="{D8E19705-0FAD-428B-87E6-52AA5BE1479A}" dt="2026-04-14T04:52:43.980" v="364" actId="21"/>
-          <ac:spMkLst>
-            <pc:docMk/>
-            <pc:sldMk cId="0" sldId="259"/>
-            <ac:spMk id="21" creationId="{00000000-0000-0000-0000-000000000000}"/>
-          </ac:spMkLst>
-        </pc:spChg>
-        <pc:spChg chg="mod">
-          <ac:chgData name="Ádám Czirják" userId="688945b6dea242df" providerId="LiveId" clId="{D8E19705-0FAD-428B-87E6-52AA5BE1479A}" dt="2026-04-14T04:52:54.982" v="366" actId="21"/>
-          <ac:spMkLst>
-            <pc:docMk/>
-            <pc:sldMk cId="0" sldId="259"/>
-            <ac:spMk id="26" creationId="{00000000-0000-0000-0000-000000000000}"/>
-          </ac:spMkLst>
-        </pc:spChg>
-      </pc:sldChg>
-      <pc:sldChg chg="ord">
-        <pc:chgData name="Ádám Czirják" userId="688945b6dea242df" providerId="LiveId" clId="{D8E19705-0FAD-428B-87E6-52AA5BE1479A}" dt="2026-04-14T04:37:51.999" v="203"/>
-        <pc:sldMkLst>
-          <pc:docMk/>
-          <pc:sldMk cId="0" sldId="260"/>
-        </pc:sldMkLst>
-      </pc:sldChg>
-      <pc:sldChg chg="modSp mod modNotesTx">
-        <pc:chgData name="Ádám Czirják" userId="688945b6dea242df" providerId="LiveId" clId="{D8E19705-0FAD-428B-87E6-52AA5BE1479A}" dt="2026-04-14T06:27:43.601" v="2064" actId="20577"/>
-        <pc:sldMkLst>
-          <pc:docMk/>
-          <pc:sldMk cId="0" sldId="262"/>
-        </pc:sldMkLst>
-        <pc:spChg chg="mod">
-          <ac:chgData name="Ádám Czirják" userId="688945b6dea242df" providerId="LiveId" clId="{D8E19705-0FAD-428B-87E6-52AA5BE1479A}" dt="2026-04-14T06:25:52.350" v="1676" actId="6549"/>
-          <ac:spMkLst>
-            <pc:docMk/>
-            <pc:sldMk cId="0" sldId="262"/>
-            <ac:spMk id="12" creationId="{00000000-0000-0000-0000-000000000000}"/>
-          </ac:spMkLst>
-        </pc:spChg>
-        <pc:spChg chg="mod">
-          <ac:chgData name="Ádám Czirják" userId="688945b6dea242df" providerId="LiveId" clId="{D8E19705-0FAD-428B-87E6-52AA5BE1479A}" dt="2026-04-14T06:25:49.666" v="1675" actId="6549"/>
-          <ac:spMkLst>
-            <pc:docMk/>
-            <pc:sldMk cId="0" sldId="262"/>
-            <ac:spMk id="16" creationId="{00000000-0000-0000-0000-000000000000}"/>
-          </ac:spMkLst>
-        </pc:spChg>
-        <pc:spChg chg="mod">
-          <ac:chgData name="Ádám Czirják" userId="688945b6dea242df" providerId="LiveId" clId="{D8E19705-0FAD-428B-87E6-52AA5BE1479A}" dt="2026-04-14T06:25:47.412" v="1674" actId="6549"/>
-          <ac:spMkLst>
-            <pc:docMk/>
-            <pc:sldMk cId="0" sldId="262"/>
-            <ac:spMk id="20" creationId="{00000000-0000-0000-0000-000000000000}"/>
-          </ac:spMkLst>
-        </pc:spChg>
-        <pc:spChg chg="mod">
-          <ac:chgData name="Ádám Czirják" userId="688945b6dea242df" providerId="LiveId" clId="{D8E19705-0FAD-428B-87E6-52AA5BE1479A}" dt="2026-04-14T06:25:44.481" v="1673" actId="6549"/>
-          <ac:spMkLst>
-            <pc:docMk/>
-            <pc:sldMk cId="0" sldId="262"/>
-            <ac:spMk id="24" creationId="{00000000-0000-0000-0000-000000000000}"/>
-          </ac:spMkLst>
-        </pc:spChg>
-      </pc:sldChg>
-      <pc:sldChg chg="modSp del mod">
-        <pc:chgData name="Ádám Czirják" userId="688945b6dea242df" providerId="LiveId" clId="{D8E19705-0FAD-428B-87E6-52AA5BE1479A}" dt="2026-04-14T05:00:52.015" v="448" actId="2696"/>
-        <pc:sldMkLst>
-          <pc:docMk/>
-          <pc:sldMk cId="0" sldId="263"/>
-        </pc:sldMkLst>
-        <pc:spChg chg="mod">
-          <ac:chgData name="Ádám Czirják" userId="688945b6dea242df" providerId="LiveId" clId="{D8E19705-0FAD-428B-87E6-52AA5BE1479A}" dt="2026-04-14T04:56:14.363" v="417" actId="21"/>
-          <ac:spMkLst>
-            <pc:docMk/>
-            <pc:sldMk cId="0" sldId="263"/>
-            <ac:spMk id="14" creationId="{00000000-0000-0000-0000-000000000000}"/>
-          </ac:spMkLst>
-        </pc:spChg>
-        <pc:spChg chg="mod">
-          <ac:chgData name="Ádám Czirják" userId="688945b6dea242df" providerId="LiveId" clId="{D8E19705-0FAD-428B-87E6-52AA5BE1479A}" dt="2026-04-14T04:53:40.273" v="392" actId="21"/>
-          <ac:spMkLst>
-            <pc:docMk/>
-            <pc:sldMk cId="0" sldId="263"/>
-            <ac:spMk id="19" creationId="{00000000-0000-0000-0000-000000000000}"/>
-          </ac:spMkLst>
-        </pc:spChg>
-        <pc:spChg chg="mod">
-          <ac:chgData name="Ádám Czirják" userId="688945b6dea242df" providerId="LiveId" clId="{D8E19705-0FAD-428B-87E6-52AA5BE1479A}" dt="2026-04-14T04:56:52.584" v="422" actId="21"/>
-          <ac:spMkLst>
-            <pc:docMk/>
-            <pc:sldMk cId="0" sldId="263"/>
-            <ac:spMk id="24" creationId="{00000000-0000-0000-0000-000000000000}"/>
-          </ac:spMkLst>
-        </pc:spChg>
-        <pc:spChg chg="mod">
-          <ac:chgData name="Ádám Czirják" userId="688945b6dea242df" providerId="LiveId" clId="{D8E19705-0FAD-428B-87E6-52AA5BE1479A}" dt="2026-04-14T04:53:55.722" v="394" actId="21"/>
-          <ac:spMkLst>
-            <pc:docMk/>
-            <pc:sldMk cId="0" sldId="263"/>
-            <ac:spMk id="29" creationId="{00000000-0000-0000-0000-000000000000}"/>
-          </ac:spMkLst>
-        </pc:spChg>
-        <pc:spChg chg="mod">
-          <ac:chgData name="Ádám Czirják" userId="688945b6dea242df" providerId="LiveId" clId="{D8E19705-0FAD-428B-87E6-52AA5BE1479A}" dt="2026-04-14T04:55:31.541" v="410" actId="21"/>
-          <ac:spMkLst>
-            <pc:docMk/>
-            <pc:sldMk cId="0" sldId="263"/>
-            <ac:spMk id="34" creationId="{00000000-0000-0000-0000-000000000000}"/>
-          </ac:spMkLst>
-        </pc:spChg>
-      </pc:sldChg>
-      <pc:sldChg chg="ord modNotesTx">
-        <pc:chgData name="Ádám Czirják" userId="688945b6dea242df" providerId="LiveId" clId="{D8E19705-0FAD-428B-87E6-52AA5BE1479A}" dt="2026-04-14T06:30:33.077" v="2440" actId="20577"/>
-        <pc:sldMkLst>
-          <pc:docMk/>
-          <pc:sldMk cId="0" sldId="264"/>
-        </pc:sldMkLst>
-      </pc:sldChg>
-      <pc:sldChg chg="ord modNotesTx">
-        <pc:chgData name="Ádám Czirják" userId="688945b6dea242df" providerId="LiveId" clId="{D8E19705-0FAD-428B-87E6-52AA5BE1479A}" dt="2026-04-14T06:21:36.703" v="1086" actId="20577"/>
-        <pc:sldMkLst>
-          <pc:docMk/>
-          <pc:sldMk cId="0" sldId="265"/>
-        </pc:sldMkLst>
-      </pc:sldChg>
-      <pc:sldChg chg="ord">
-        <pc:chgData name="Ádám Czirják" userId="688945b6dea242df" providerId="LiveId" clId="{D8E19705-0FAD-428B-87E6-52AA5BE1479A}" dt="2026-04-14T04:32:00.413" v="1"/>
-        <pc:sldMkLst>
-          <pc:docMk/>
-          <pc:sldMk cId="0" sldId="266"/>
-        </pc:sldMkLst>
-      </pc:sldChg>
-      <pc:sldChg chg="modSp mod modNotesTx">
-        <pc:chgData name="Ádám Czirják" userId="688945b6dea242df" providerId="LiveId" clId="{D8E19705-0FAD-428B-87E6-52AA5BE1479A}" dt="2026-04-14T06:25:35.282" v="1672" actId="20577"/>
-        <pc:sldMkLst>
-          <pc:docMk/>
-          <pc:sldMk cId="3857609010" sldId="269"/>
-        </pc:sldMkLst>
-        <pc:spChg chg="mod">
-          <ac:chgData name="Ádám Czirják" userId="688945b6dea242df" providerId="LiveId" clId="{D8E19705-0FAD-428B-87E6-52AA5BE1479A}" dt="2026-04-14T06:24:58.468" v="1575" actId="6549"/>
-          <ac:spMkLst>
-            <pc:docMk/>
-            <pc:sldMk cId="3857609010" sldId="269"/>
-            <ac:spMk id="13" creationId="{09370C10-E0C8-5F1D-2F91-19C76E8FCA44}"/>
-          </ac:spMkLst>
-        </pc:spChg>
-        <pc:spChg chg="mod">
-          <ac:chgData name="Ádám Czirják" userId="688945b6dea242df" providerId="LiveId" clId="{D8E19705-0FAD-428B-87E6-52AA5BE1479A}" dt="2026-04-14T06:25:01.592" v="1576" actId="6549"/>
-          <ac:spMkLst>
-            <pc:docMk/>
-            <pc:sldMk cId="3857609010" sldId="269"/>
-            <ac:spMk id="17" creationId="{56F35D0C-3654-C65B-1C84-BBEC2772B8BC}"/>
-          </ac:spMkLst>
-        </pc:spChg>
-        <pc:spChg chg="mod">
-          <ac:chgData name="Ádám Czirják" userId="688945b6dea242df" providerId="LiveId" clId="{D8E19705-0FAD-428B-87E6-52AA5BE1479A}" dt="2026-04-14T06:25:04.475" v="1577" actId="6549"/>
-          <ac:spMkLst>
-            <pc:docMk/>
-            <pc:sldMk cId="3857609010" sldId="269"/>
-            <ac:spMk id="25" creationId="{368CEE88-3EFD-A182-7E18-E6C2E596126C}"/>
-          </ac:spMkLst>
-        </pc:spChg>
-      </pc:sldChg>
-      <pc:sldChg chg="modSp modNotesTx">
-        <pc:chgData name="Ádám Czirják" userId="688945b6dea242df" providerId="LiveId" clId="{D8E19705-0FAD-428B-87E6-52AA5BE1479A}" dt="2026-04-14T06:24:50.141" v="1574" actId="20577"/>
-        <pc:sldMkLst>
-          <pc:docMk/>
-          <pc:sldMk cId="202576114" sldId="270"/>
-        </pc:sldMkLst>
-        <pc:spChg chg="mod">
-          <ac:chgData name="Ádám Czirják" userId="688945b6dea242df" providerId="LiveId" clId="{D8E19705-0FAD-428B-87E6-52AA5BE1479A}" dt="2026-04-14T04:32:51.833" v="61" actId="20577"/>
-          <ac:spMkLst>
-            <pc:docMk/>
-            <pc:sldMk cId="202576114" sldId="270"/>
-            <ac:spMk id="24" creationId="{83AB9260-CA50-A5E7-3169-34DB607AAC27}"/>
-          </ac:spMkLst>
-        </pc:spChg>
-      </pc:sldChg>
-      <pc:sldChg chg="addSp delSp modSp add mod ord modNotesTx">
-        <pc:chgData name="Ádám Czirják" userId="688945b6dea242df" providerId="LiveId" clId="{D8E19705-0FAD-428B-87E6-52AA5BE1479A}" dt="2026-04-14T06:23:46.015" v="1430" actId="20577"/>
-        <pc:sldMkLst>
-          <pc:docMk/>
-          <pc:sldMk cId="2259520895" sldId="271"/>
-        </pc:sldMkLst>
-        <pc:spChg chg="mod">
-          <ac:chgData name="Ádám Czirják" userId="688945b6dea242df" providerId="LiveId" clId="{D8E19705-0FAD-428B-87E6-52AA5BE1479A}" dt="2026-04-14T04:45:53.168" v="217" actId="2711"/>
-          <ac:spMkLst>
-            <pc:docMk/>
-            <pc:sldMk cId="2259520895" sldId="271"/>
-            <ac:spMk id="3" creationId="{0DCD458F-8DEB-6571-FC7A-74D3934DFFA2}"/>
-          </ac:spMkLst>
-        </pc:spChg>
-        <pc:spChg chg="mod">
-          <ac:chgData name="Ádám Czirják" userId="688945b6dea242df" providerId="LiveId" clId="{D8E19705-0FAD-428B-87E6-52AA5BE1479A}" dt="2026-04-14T04:48:33.794" v="273" actId="1076"/>
-          <ac:spMkLst>
-            <pc:docMk/>
-            <pc:sldMk cId="2259520895" sldId="271"/>
-            <ac:spMk id="4" creationId="{EF18A1EC-689E-B7AE-5AFF-CA7FD0F85433}"/>
-          </ac:spMkLst>
-        </pc:spChg>
-        <pc:spChg chg="add mod">
-          <ac:chgData name="Ádám Czirják" userId="688945b6dea242df" providerId="LiveId" clId="{D8E19705-0FAD-428B-87E6-52AA5BE1479A}" dt="2026-04-14T04:57:49.695" v="431" actId="1076"/>
-          <ac:spMkLst>
-            <pc:docMk/>
-            <pc:sldMk cId="2259520895" sldId="271"/>
-            <ac:spMk id="6" creationId="{A2179647-FF87-8119-D33E-71B027F6E302}"/>
-          </ac:spMkLst>
-        </pc:spChg>
-        <pc:spChg chg="mod">
-          <ac:chgData name="Ádám Czirják" userId="688945b6dea242df" providerId="LiveId" clId="{D8E19705-0FAD-428B-87E6-52AA5BE1479A}" dt="2026-04-14T04:47:12.679" v="228" actId="14100"/>
-          <ac:spMkLst>
-            <pc:docMk/>
-            <pc:sldMk cId="2259520895" sldId="271"/>
-            <ac:spMk id="7" creationId="{83D0A176-F94A-0ED8-C588-CB64A1C0DAF3}"/>
-          </ac:spMkLst>
-        </pc:spChg>
-        <pc:spChg chg="mod">
-          <ac:chgData name="Ádám Czirják" userId="688945b6dea242df" providerId="LiveId" clId="{D8E19705-0FAD-428B-87E6-52AA5BE1479A}" dt="2026-04-14T04:57:24.440" v="428" actId="14100"/>
-          <ac:spMkLst>
-            <pc:docMk/>
-            <pc:sldMk cId="2259520895" sldId="271"/>
-            <ac:spMk id="8" creationId="{96471D23-C572-1B35-8E17-C6C7249C8028}"/>
-          </ac:spMkLst>
-        </pc:spChg>
-        <pc:spChg chg="mod">
-          <ac:chgData name="Ádám Czirják" userId="688945b6dea242df" providerId="LiveId" clId="{D8E19705-0FAD-428B-87E6-52AA5BE1479A}" dt="2026-04-14T04:58:06.851" v="433" actId="1076"/>
-          <ac:spMkLst>
-            <pc:docMk/>
-            <pc:sldMk cId="2259520895" sldId="271"/>
-            <ac:spMk id="9" creationId="{0BAF4B85-9C09-6F47-C54E-240842E39EDE}"/>
-          </ac:spMkLst>
-        </pc:spChg>
-        <pc:spChg chg="del mod">
-          <ac:chgData name="Ádám Czirják" userId="688945b6dea242df" providerId="LiveId" clId="{D8E19705-0FAD-428B-87E6-52AA5BE1479A}" dt="2026-04-14T04:47:26.623" v="230" actId="21"/>
-          <ac:spMkLst>
-            <pc:docMk/>
-            <pc:sldMk cId="2259520895" sldId="271"/>
-            <ac:spMk id="10" creationId="{34D2B632-7517-EAE0-4A19-781FCA6E3ACB}"/>
-          </ac:spMkLst>
-        </pc:spChg>
-        <pc:spChg chg="add mod">
-          <ac:chgData name="Ádám Czirják" userId="688945b6dea242df" providerId="LiveId" clId="{D8E19705-0FAD-428B-87E6-52AA5BE1479A}" dt="2026-04-14T04:55:39.966" v="412" actId="113"/>
-          <ac:spMkLst>
-            <pc:docMk/>
-            <pc:sldMk cId="2259520895" sldId="271"/>
-            <ac:spMk id="11" creationId="{E2FB6BF0-3F0F-236A-324B-897A23962B4B}"/>
-          </ac:spMkLst>
-        </pc:spChg>
-        <pc:spChg chg="mod">
-          <ac:chgData name="Ádám Czirják" userId="688945b6dea242df" providerId="LiveId" clId="{D8E19705-0FAD-428B-87E6-52AA5BE1479A}" dt="2026-04-14T05:02:23.474" v="452" actId="1076"/>
-          <ac:spMkLst>
-            <pc:docMk/>
-            <pc:sldMk cId="2259520895" sldId="271"/>
-            <ac:spMk id="12" creationId="{3CD2029A-F78D-E796-46C8-2BD58CDFA3BF}"/>
-          </ac:spMkLst>
-        </pc:spChg>
-        <pc:spChg chg="add mod">
-          <ac:chgData name="Ádám Czirják" userId="688945b6dea242df" providerId="LiveId" clId="{D8E19705-0FAD-428B-87E6-52AA5BE1479A}" dt="2026-04-14T04:59:56.892" v="445" actId="1076"/>
-          <ac:spMkLst>
-            <pc:docMk/>
-            <pc:sldMk cId="2259520895" sldId="271"/>
-            <ac:spMk id="13" creationId="{01CA1E7F-A547-B797-39CC-AA3F45E03808}"/>
-          </ac:spMkLst>
-        </pc:spChg>
-        <pc:spChg chg="mod">
-          <ac:chgData name="Ádám Czirják" userId="688945b6dea242df" providerId="LiveId" clId="{D8E19705-0FAD-428B-87E6-52AA5BE1479A}" dt="2026-04-14T05:02:19.183" v="451" actId="1076"/>
-          <ac:spMkLst>
-            <pc:docMk/>
-            <pc:sldMk cId="2259520895" sldId="271"/>
-            <ac:spMk id="14" creationId="{13CE5CD5-75E1-60E2-84DA-E909EBC01554}"/>
-          </ac:spMkLst>
-        </pc:spChg>
-        <pc:spChg chg="add mod">
-          <ac:chgData name="Ádám Czirják" userId="688945b6dea242df" providerId="LiveId" clId="{D8E19705-0FAD-428B-87E6-52AA5BE1479A}" dt="2026-04-14T05:00:24.045" v="447" actId="20577"/>
-          <ac:spMkLst>
-            <pc:docMk/>
-            <pc:sldMk cId="2259520895" sldId="271"/>
-            <ac:spMk id="15" creationId="{6B274A3D-8334-82AF-F48F-A200E4CA6B99}"/>
-          </ac:spMkLst>
-        </pc:spChg>
-        <pc:spChg chg="mod">
-          <ac:chgData name="Ádám Czirják" userId="688945b6dea242df" providerId="LiveId" clId="{D8E19705-0FAD-428B-87E6-52AA5BE1479A}" dt="2026-04-14T05:02:12.926" v="450" actId="1076"/>
-          <ac:spMkLst>
-            <pc:docMk/>
-            <pc:sldMk cId="2259520895" sldId="271"/>
-            <ac:spMk id="16" creationId="{893E3901-C787-6F80-1ED1-7193A3DD02C5}"/>
-          </ac:spMkLst>
-        </pc:spChg>
-        <pc:spChg chg="mod">
-          <ac:chgData name="Ádám Czirják" userId="688945b6dea242df" providerId="LiveId" clId="{D8E19705-0FAD-428B-87E6-52AA5BE1479A}" dt="2026-04-14T05:02:05.632" v="449" actId="1076"/>
-          <ac:spMkLst>
-            <pc:docMk/>
-            <pc:sldMk cId="2259520895" sldId="271"/>
-            <ac:spMk id="18" creationId="{0D1B529B-B88F-CD82-A4C0-2C91FFF90815}"/>
-          </ac:spMkLst>
-        </pc:spChg>
-        <pc:spChg chg="mod">
-          <ac:chgData name="Ádám Czirják" userId="688945b6dea242df" providerId="LiveId" clId="{D8E19705-0FAD-428B-87E6-52AA5BE1479A}" dt="2026-04-14T04:47:12.679" v="228" actId="14100"/>
-          <ac:spMkLst>
-            <pc:docMk/>
-            <pc:sldMk cId="2259520895" sldId="271"/>
-            <ac:spMk id="20" creationId="{64AAB152-DD4E-9246-39D7-953944CFCA4E}"/>
-          </ac:spMkLst>
-        </pc:spChg>
-        <pc:spChg chg="add del mod">
-          <ac:chgData name="Ádám Czirják" userId="688945b6dea242df" providerId="LiveId" clId="{D8E19705-0FAD-428B-87E6-52AA5BE1479A}" dt="2026-04-14T04:59:47.461" v="443" actId="1076"/>
-          <ac:spMkLst>
-            <pc:docMk/>
-            <pc:sldMk cId="2259520895" sldId="271"/>
-            <ac:spMk id="21" creationId="{E3A148C2-FC5E-AB7C-8A44-6DCCC2B2E764}"/>
-          </ac:spMkLst>
-        </pc:spChg>
-        <pc:spChg chg="add del mod">
-          <ac:chgData name="Ádám Czirják" userId="688945b6dea242df" providerId="LiveId" clId="{D8E19705-0FAD-428B-87E6-52AA5BE1479A}" dt="2026-04-14T04:50:59.212" v="319" actId="6549"/>
-          <ac:spMkLst>
-            <pc:docMk/>
-            <pc:sldMk cId="2259520895" sldId="271"/>
-            <ac:spMk id="22" creationId="{D70D8DF9-A8A6-493D-1DE1-42410B1D4826}"/>
-          </ac:spMkLst>
-        </pc:spChg>
-        <pc:spChg chg="add del mod">
-          <ac:chgData name="Ádám Czirják" userId="688945b6dea242df" providerId="LiveId" clId="{D8E19705-0FAD-428B-87E6-52AA5BE1479A}" dt="2026-04-14T04:50:20.496" v="315" actId="14100"/>
-          <ac:spMkLst>
-            <pc:docMk/>
-            <pc:sldMk cId="2259520895" sldId="271"/>
-            <ac:spMk id="23" creationId="{6CA0799F-1099-32C5-5E3D-05694ADD64AB}"/>
-          </ac:spMkLst>
-        </pc:spChg>
-        <pc:spChg chg="add del mod">
-          <ac:chgData name="Ádám Czirják" userId="688945b6dea242df" providerId="LiveId" clId="{D8E19705-0FAD-428B-87E6-52AA5BE1479A}" dt="2026-04-14T04:50:20.496" v="315" actId="14100"/>
-          <ac:spMkLst>
-            <pc:docMk/>
-            <pc:sldMk cId="2259520895" sldId="271"/>
-            <ac:spMk id="24" creationId="{6232DC99-EB96-09F8-6B8C-B99B3254CE5A}"/>
-          </ac:spMkLst>
-        </pc:spChg>
-        <pc:spChg chg="add del mod">
-          <ac:chgData name="Ádám Czirják" userId="688945b6dea242df" providerId="LiveId" clId="{D8E19705-0FAD-428B-87E6-52AA5BE1479A}" dt="2026-04-14T04:54:29.474" v="402" actId="113"/>
-          <ac:spMkLst>
-            <pc:docMk/>
-            <pc:sldMk cId="2259520895" sldId="271"/>
-            <ac:spMk id="26" creationId="{96E93ED2-BBCF-6FDE-9FE2-D07AB20FAB17}"/>
-          </ac:spMkLst>
-        </pc:spChg>
-        <pc:spChg chg="add del mod">
-          <ac:chgData name="Ádám Czirják" userId="688945b6dea242df" providerId="LiveId" clId="{D8E19705-0FAD-428B-87E6-52AA5BE1479A}" dt="2026-04-14T05:00:14.825" v="446" actId="1076"/>
-          <ac:spMkLst>
-            <pc:docMk/>
-            <pc:sldMk cId="2259520895" sldId="271"/>
-            <ac:spMk id="28" creationId="{E6284030-E9B9-235D-B989-8096372379B0}"/>
-          </ac:spMkLst>
-        </pc:spChg>
-        <pc:spChg chg="del">
-          <ac:chgData name="Ádám Czirják" userId="688945b6dea242df" providerId="LiveId" clId="{D8E19705-0FAD-428B-87E6-52AA5BE1479A}" dt="2026-04-14T04:46:07.810" v="219" actId="478"/>
-          <ac:spMkLst>
-            <pc:docMk/>
-            <pc:sldMk cId="2259520895" sldId="271"/>
-            <ac:spMk id="29" creationId="{EEBD2B88-9B52-1660-B4CC-46AD94D5BB3F}"/>
-          </ac:spMkLst>
-        </pc:spChg>
-        <pc:spChg chg="del">
-          <ac:chgData name="Ádám Czirják" userId="688945b6dea242df" providerId="LiveId" clId="{D8E19705-0FAD-428B-87E6-52AA5BE1479A}" dt="2026-04-14T04:46:00.383" v="218" actId="478"/>
-          <ac:spMkLst>
-            <pc:docMk/>
-            <pc:sldMk cId="2259520895" sldId="271"/>
-            <ac:spMk id="30" creationId="{76AB1AF6-12B8-51D1-7F3A-23F45C682C51}"/>
-          </ac:spMkLst>
-        </pc:spChg>
-        <pc:spChg chg="del">
-          <ac:chgData name="Ádám Czirják" userId="688945b6dea242df" providerId="LiveId" clId="{D8E19705-0FAD-428B-87E6-52AA5BE1479A}" dt="2026-04-14T04:46:07.810" v="219" actId="478"/>
-          <ac:spMkLst>
-            <pc:docMk/>
-            <pc:sldMk cId="2259520895" sldId="271"/>
-            <ac:spMk id="31" creationId="{84F55698-03D0-0BA7-7EF6-F9D7DF56CBE2}"/>
-          </ac:spMkLst>
-        </pc:spChg>
-        <pc:spChg chg="del">
-          <ac:chgData name="Ádám Czirják" userId="688945b6dea242df" providerId="LiveId" clId="{D8E19705-0FAD-428B-87E6-52AA5BE1479A}" dt="2026-04-14T04:46:07.810" v="219" actId="478"/>
-          <ac:spMkLst>
-            <pc:docMk/>
-            <pc:sldMk cId="2259520895" sldId="271"/>
-            <ac:spMk id="32" creationId="{473195C5-BC0C-DB8B-B622-584C93AA4A65}"/>
-          </ac:spMkLst>
-        </pc:spChg>
-        <pc:spChg chg="del">
-          <ac:chgData name="Ádám Czirják" userId="688945b6dea242df" providerId="LiveId" clId="{D8E19705-0FAD-428B-87E6-52AA5BE1479A}" dt="2026-04-14T04:46:07.810" v="219" actId="478"/>
-          <ac:spMkLst>
-            <pc:docMk/>
-            <pc:sldMk cId="2259520895" sldId="271"/>
-            <ac:spMk id="34" creationId="{E06637CF-145B-AB8D-61B3-9D9DA754E8B8}"/>
-          </ac:spMkLst>
-        </pc:spChg>
-        <pc:spChg chg="del">
-          <ac:chgData name="Ádám Czirják" userId="688945b6dea242df" providerId="LiveId" clId="{D8E19705-0FAD-428B-87E6-52AA5BE1479A}" dt="2026-04-14T04:46:07.810" v="219" actId="478"/>
-          <ac:spMkLst>
-            <pc:docMk/>
-            <pc:sldMk cId="2259520895" sldId="271"/>
-            <ac:spMk id="36" creationId="{F0D228B2-5FA8-91A0-13D4-2A076C4609D2}"/>
-          </ac:spMkLst>
-        </pc:spChg>
-        <pc:spChg chg="del">
-          <ac:chgData name="Ádám Czirják" userId="688945b6dea242df" providerId="LiveId" clId="{D8E19705-0FAD-428B-87E6-52AA5BE1479A}" dt="2026-04-14T04:46:07.810" v="219" actId="478"/>
-          <ac:spMkLst>
-            <pc:docMk/>
-            <pc:sldMk cId="2259520895" sldId="271"/>
-            <ac:spMk id="38" creationId="{538551B1-69BE-ECAD-0ED8-BA3CAFA877B5}"/>
-          </ac:spMkLst>
-        </pc:spChg>
-        <pc:spChg chg="del">
-          <ac:chgData name="Ádám Czirják" userId="688945b6dea242df" providerId="LiveId" clId="{D8E19705-0FAD-428B-87E6-52AA5BE1479A}" dt="2026-04-14T04:46:07.810" v="219" actId="478"/>
-          <ac:spMkLst>
-            <pc:docMk/>
-            <pc:sldMk cId="2259520895" sldId="271"/>
-            <ac:spMk id="40" creationId="{1AA00006-90A2-4AEC-D174-DDCE91163173}"/>
-          </ac:spMkLst>
-        </pc:spChg>
-      </pc:sldChg>
-    </pc:docChg>
-  </pc:docChgLst>
-</pc:chgInfo>
 </file>
 
 <file path=ppt/notesMasters/notesMaster1.xml><?xml version="1.0" encoding="utf-8"?>

</xml_diff>

<commit_message>
pici változtatás a pptn
</commit_message>
<xml_diff>
--- a/doc/CrossCountryWebshop_Premium (1).pptx
+++ b/doc/CrossCountryWebshop_Premium (1).pptx
@@ -122,6 +122,43 @@
     </p:ext>
   </p:extLst>
 </p:presentation>
+</file>
+
+<file path=ppt/changesInfos/changesInfo1.xml><?xml version="1.0" encoding="utf-8"?>
+<pc:chgInfo xmlns:a="http://schemas.openxmlformats.org/drawingml/2006/main" xmlns:r="http://schemas.openxmlformats.org/officeDocument/2006/relationships" xmlns:ac="http://schemas.microsoft.com/office/drawing/2013/main/command" xmlns:pc="http://schemas.microsoft.com/office/powerpoint/2013/main/command">
+  <pc:docChgLst>
+    <pc:chgData name="Ádám Czirják" userId="688945b6dea242df" providerId="LiveId" clId="{D8E19705-0FAD-428B-87E6-52AA5BE1479A}"/>
+    <pc:docChg chg="undo custSel modSld">
+      <pc:chgData name="Ádám Czirják" userId="688945b6dea242df" providerId="LiveId" clId="{D8E19705-0FAD-428B-87E6-52AA5BE1479A}" dt="2026-04-15T17:19:57.485" v="33" actId="20577"/>
+      <pc:docMkLst>
+        <pc:docMk/>
+      </pc:docMkLst>
+      <pc:sldChg chg="modSp mod">
+        <pc:chgData name="Ádám Czirják" userId="688945b6dea242df" providerId="LiveId" clId="{D8E19705-0FAD-428B-87E6-52AA5BE1479A}" dt="2026-04-15T17:19:57.485" v="33" actId="20577"/>
+        <pc:sldMkLst>
+          <pc:docMk/>
+          <pc:sldMk cId="0" sldId="258"/>
+        </pc:sldMkLst>
+        <pc:spChg chg="mod">
+          <ac:chgData name="Ádám Czirják" userId="688945b6dea242df" providerId="LiveId" clId="{D8E19705-0FAD-428B-87E6-52AA5BE1479A}" dt="2026-04-15T17:19:57.485" v="33" actId="20577"/>
+          <ac:spMkLst>
+            <pc:docMk/>
+            <pc:sldMk cId="0" sldId="258"/>
+            <ac:spMk id="21" creationId="{00000000-0000-0000-0000-000000000000}"/>
+          </ac:spMkLst>
+        </pc:spChg>
+        <pc:spChg chg="mod">
+          <ac:chgData name="Ádám Czirják" userId="688945b6dea242df" providerId="LiveId" clId="{D8E19705-0FAD-428B-87E6-52AA5BE1479A}" dt="2026-04-15T17:14:18.138" v="14" actId="20577"/>
+          <ac:spMkLst>
+            <pc:docMk/>
+            <pc:sldMk cId="0" sldId="258"/>
+            <ac:spMk id="28" creationId="{00000000-0000-0000-0000-000000000000}"/>
+          </ac:spMkLst>
+        </pc:spChg>
+      </pc:sldChg>
+    </pc:docChg>
+  </pc:docChgLst>
+</pc:chgInfo>
 </file>
 
 <file path=ppt/notesMasters/notesMaster1.xml><?xml version="1.0" encoding="utf-8"?>
@@ -9282,7 +9319,7 @@
         </p:nvSpPr>
         <p:spPr>
           <a:xfrm>
-            <a:off x="512064" y="2347722"/>
+            <a:off x="514174" y="3684728"/>
             <a:ext cx="2329610" cy="438912"/>
           </a:xfrm>
           <a:prstGeom prst="rect">
@@ -9299,15 +9336,13 @@
               <a:buNone/>
             </a:pPr>
             <a:r>
-              <a:rPr lang="en-US" sz="1600" dirty="0">
+              <a:rPr lang="hu-HU" sz="1600" dirty="0">
                 <a:solidFill>
                   <a:srgbClr val="C5D5E8"/>
                 </a:solidFill>
                 <a:latin typeface="Trebuchet MS" pitchFamily="34" charset="0"/>
-                <a:ea typeface="Trebuchet MS" pitchFamily="34" charset="-122"/>
-                <a:cs typeface="Trebuchet MS" pitchFamily="34" charset="-120"/>
               </a:rPr>
-              <a:t>API integráció</a:t>
+              <a:t>Dokumentáció</a:t>
             </a:r>
             <a:endParaRPr lang="en-US" sz="1600" dirty="0"/>
           </a:p>
@@ -9321,7 +9356,7 @@
         </p:nvSpPr>
         <p:spPr>
           <a:xfrm>
-            <a:off x="514174" y="2805836"/>
+            <a:off x="484631" y="2507184"/>
             <a:ext cx="2329610" cy="438912"/>
           </a:xfrm>
           <a:prstGeom prst="rect">
@@ -9382,7 +9417,7 @@
         </p:nvSpPr>
         <p:spPr>
           <a:xfrm>
-            <a:off x="512064" y="3281324"/>
+            <a:off x="512064" y="3118104"/>
             <a:ext cx="2329610" cy="438912"/>
           </a:xfrm>
           <a:prstGeom prst="rect">
@@ -9410,7 +9445,7 @@
               <a:t>UI / UX</a:t>
             </a:r>
             <a:r>
-              <a:rPr lang="hu-HU" sz="1600">
+              <a:rPr lang="hu-HU" sz="1600" dirty="0">
                 <a:solidFill>
                   <a:srgbClr val="C5D5E8"/>
                 </a:solidFill>
@@ -9683,7 +9718,7 @@
         </p:nvSpPr>
         <p:spPr>
           <a:xfrm>
-            <a:off x="3364992" y="2347722"/>
+            <a:off x="3364992" y="2417705"/>
             <a:ext cx="2231136" cy="438912"/>
           </a:xfrm>
           <a:prstGeom prst="rect">
@@ -9910,7 +9945,7 @@
         </p:nvSpPr>
         <p:spPr>
           <a:xfrm>
-            <a:off x="6217920" y="2375506"/>
+            <a:off x="6217920" y="2444879"/>
             <a:ext cx="2414016" cy="438912"/>
           </a:xfrm>
           <a:prstGeom prst="rect">
@@ -9960,8 +9995,8 @@
         </p:nvSpPr>
         <p:spPr>
           <a:xfrm>
-            <a:off x="6215671" y="2898648"/>
-            <a:ext cx="2443698" cy="438912"/>
+            <a:off x="6245353" y="3040380"/>
+            <a:ext cx="2697479" cy="438912"/>
           </a:xfrm>
           <a:prstGeom prst="rect">
             <a:avLst/>
@@ -9985,10 +10020,15 @@
                 <a:ea typeface="Trebuchet MS" pitchFamily="34" charset="-122"/>
                 <a:cs typeface="Trebuchet MS" pitchFamily="34" charset="-120"/>
               </a:rPr>
-              <a:t>M</a:t>
-            </a:r>
-            <a:r>
-              <a:rPr lang="en-US" sz="1600" dirty="0" err="1">
+              <a:t>Docker-alapú </a:t>
+            </a:r>
+          </a:p>
+          <a:p>
+            <a:pPr marL="0" indent="0">
+              <a:buNone/>
+            </a:pPr>
+            <a:r>
+              <a:rPr lang="hu-HU" sz="1600" dirty="0" err="1">
                 <a:solidFill>
                   <a:srgbClr val="C5D5E8"/>
                 </a:solidFill>
@@ -9996,29 +10036,7 @@
                 <a:ea typeface="Trebuchet MS" pitchFamily="34" charset="-122"/>
                 <a:cs typeface="Trebuchet MS" pitchFamily="34" charset="-120"/>
               </a:rPr>
-              <a:t>iddleware</a:t>
-            </a:r>
-            <a:r>
-              <a:rPr lang="hu-HU" sz="1600" dirty="0">
-                <a:solidFill>
-                  <a:srgbClr val="C5D5E8"/>
-                </a:solidFill>
-                <a:latin typeface="Trebuchet MS" pitchFamily="34" charset="0"/>
-                <a:ea typeface="Trebuchet MS" pitchFamily="34" charset="-122"/>
-                <a:cs typeface="Trebuchet MS" pitchFamily="34" charset="-120"/>
-              </a:rPr>
-              <a:t> kialakítása</a:t>
-            </a:r>
-            <a:r>
-              <a:rPr lang="en-US" sz="1600" dirty="0">
-                <a:solidFill>
-                  <a:srgbClr val="C5D5E8"/>
-                </a:solidFill>
-                <a:latin typeface="Trebuchet MS" pitchFamily="34" charset="0"/>
-                <a:ea typeface="Trebuchet MS" pitchFamily="34" charset="-122"/>
-                <a:cs typeface="Trebuchet MS" pitchFamily="34" charset="-120"/>
-              </a:rPr>
-              <a:t> </a:t>
+              <a:t>konténerizáció</a:t>
             </a:r>
             <a:endParaRPr lang="hu-HU" sz="1600" dirty="0">
               <a:solidFill>
@@ -10028,45 +10046,6 @@
               <a:ea typeface="Trebuchet MS" pitchFamily="34" charset="-122"/>
               <a:cs typeface="Trebuchet MS" pitchFamily="34" charset="-120"/>
             </a:endParaRPr>
-          </a:p>
-        </p:txBody>
-      </p:sp>
-      <p:sp>
-        <p:nvSpPr>
-          <p:cNvPr id="40" name="Text 38"/>
-          <p:cNvSpPr/>
-          <p:nvPr/>
-        </p:nvSpPr>
-        <p:spPr>
-          <a:xfrm>
-            <a:off x="6217920" y="3374136"/>
-            <a:ext cx="2414016" cy="438912"/>
-          </a:xfrm>
-          <a:prstGeom prst="rect">
-            <a:avLst/>
-          </a:prstGeom>
-          <a:noFill/>
-          <a:ln/>
-        </p:spPr>
-        <p:txBody>
-          <a:bodyPr wrap="square" lIns="0" tIns="0" rIns="0" bIns="0" rtlCol="0" anchor="ctr"/>
-          <a:lstStyle/>
-          <a:p>
-            <a:pPr marL="0" indent="0">
-              <a:buNone/>
-            </a:pPr>
-            <a:r>
-              <a:rPr lang="en-US" sz="1600" dirty="0">
-                <a:solidFill>
-                  <a:srgbClr val="C5D5E8"/>
-                </a:solidFill>
-                <a:latin typeface="Trebuchet MS" pitchFamily="34" charset="0"/>
-                <a:ea typeface="Trebuchet MS" pitchFamily="34" charset="-122"/>
-                <a:cs typeface="Trebuchet MS" pitchFamily="34" charset="-120"/>
-              </a:rPr>
-              <a:t>Autentikáció</a:t>
-            </a:r>
-            <a:endParaRPr lang="en-US" sz="1600" dirty="0"/>
           </a:p>
         </p:txBody>
       </p:sp>
@@ -10763,26 +10742,6 @@
                 <a:ea typeface="Trebuchet MS" pitchFamily="34" charset="-122"/>
                 <a:cs typeface="Trebuchet MS" pitchFamily="34" charset="-120"/>
               </a:rPr>
-              <a:t>Express / Node.js</a:t>
-            </a:r>
-            <a:endParaRPr lang="en-US" sz="1400" dirty="0"/>
-          </a:p>
-          <a:p>
-            <a:pPr marL="0" indent="0" algn="ctr">
-              <a:lnSpc>
-                <a:spcPct val="140000"/>
-              </a:lnSpc>
-              <a:buNone/>
-            </a:pPr>
-            <a:r>
-              <a:rPr lang="en-US" sz="1400" dirty="0">
-                <a:solidFill>
-                  <a:srgbClr val="C5D5E8"/>
-                </a:solidFill>
-                <a:latin typeface="Trebuchet MS" pitchFamily="34" charset="0"/>
-                <a:ea typeface="Trebuchet MS" pitchFamily="34" charset="-122"/>
-                <a:cs typeface="Trebuchet MS" pitchFamily="34" charset="-120"/>
-              </a:rPr>
               <a:t>Odin </a:t>
             </a:r>
             <a:endParaRPr lang="hu-HU" sz="1400" dirty="0">
@@ -10819,6 +10778,40 @@
               </a:rPr>
               <a:t> szerver</a:t>
             </a:r>
+          </a:p>
+          <a:p>
+            <a:pPr marL="0" indent="0" algn="ctr">
+              <a:lnSpc>
+                <a:spcPct val="140000"/>
+              </a:lnSpc>
+              <a:buNone/>
+            </a:pPr>
+            <a:r>
+              <a:rPr lang="hu-HU" sz="1400" dirty="0" err="1">
+                <a:solidFill>
+                  <a:srgbClr val="C5D5E8"/>
+                </a:solidFill>
+                <a:latin typeface="Trebuchet MS" pitchFamily="34" charset="0"/>
+              </a:rPr>
+              <a:t>libpq</a:t>
+            </a:r>
+            <a:r>
+              <a:rPr lang="hu-HU" sz="1400" dirty="0">
+                <a:solidFill>
+                  <a:srgbClr val="C5D5E8"/>
+                </a:solidFill>
+                <a:latin typeface="Trebuchet MS" pitchFamily="34" charset="0"/>
+              </a:rPr>
+              <a:t> könyvtár</a:t>
+            </a:r>
+          </a:p>
+          <a:p>
+            <a:pPr marL="0" indent="0" algn="ctr">
+              <a:lnSpc>
+                <a:spcPct val="140000"/>
+              </a:lnSpc>
+              <a:buNone/>
+            </a:pPr>
             <a:endParaRPr lang="en-US" sz="1400" dirty="0"/>
           </a:p>
         </p:txBody>
@@ -11029,34 +11022,7 @@
                 <a:ea typeface="Trebuchet MS" pitchFamily="34" charset="-122"/>
                 <a:cs typeface="Trebuchet MS" pitchFamily="34" charset="-120"/>
               </a:rPr>
-              <a:t>MySQL </a:t>
-            </a:r>
-            <a:endParaRPr lang="hu-HU" sz="1400" dirty="0">
-              <a:solidFill>
-                <a:srgbClr val="C5D5E8"/>
-              </a:solidFill>
-              <a:latin typeface="Trebuchet MS" pitchFamily="34" charset="0"/>
-              <a:ea typeface="Trebuchet MS" pitchFamily="34" charset="-122"/>
-              <a:cs typeface="Trebuchet MS" pitchFamily="34" charset="-120"/>
-            </a:endParaRPr>
-          </a:p>
-          <a:p>
-            <a:pPr marL="0" indent="0" algn="ctr">
-              <a:lnSpc>
-                <a:spcPct val="140000"/>
-              </a:lnSpc>
-              <a:buNone/>
-            </a:pPr>
-            <a:r>
-              <a:rPr lang="en-US" sz="1400" dirty="0">
-                <a:solidFill>
-                  <a:srgbClr val="C5D5E8"/>
-                </a:solidFill>
-                <a:latin typeface="Trebuchet MS" pitchFamily="34" charset="0"/>
-                <a:ea typeface="Trebuchet MS" pitchFamily="34" charset="-122"/>
-                <a:cs typeface="Trebuchet MS" pitchFamily="34" charset="-120"/>
-              </a:rPr>
-              <a:t> PostgreSQL</a:t>
+              <a:t>PostgreSQL</a:t>
             </a:r>
             <a:endParaRPr lang="en-US" sz="1400" dirty="0"/>
           </a:p>
@@ -12716,13 +12682,13 @@
   <p:clrMapOvr>
     <a:masterClrMapping/>
   </p:clrMapOvr>
-  <mc:AlternateContent xmlns:mc="http://schemas.openxmlformats.org/markup-compatibility/2006">
-    <mc:Choice xmlns:p14="http://schemas.microsoft.com/office/powerpoint/2010/main" Requires="p14">
+  <mc:AlternateContent xmlns:mc="http://schemas.openxmlformats.org/markup-compatibility/2006" xmlns:p14="http://schemas.microsoft.com/office/powerpoint/2010/main">
+    <mc:Choice Requires="p14">
       <p:transition spd="med" p14:dur="700">
         <p:fade/>
       </p:transition>
     </mc:Choice>
-    <mc:Fallback>
+    <mc:Fallback xmlns="">
       <p:transition spd="med">
         <p:fade/>
       </p:transition>

</xml_diff>

<commit_message>
felesleges rest api tartalomjegyzék törlése
</commit_message>
<xml_diff>
--- a/doc/CrossCountryWebshop_Premium (1).pptx
+++ b/doc/CrossCountryWebshop_Premium (1).pptx
@@ -15,8 +15,8 @@
     <p:sldId id="271" r:id="rId9"/>
     <p:sldId id="261" r:id="rId10"/>
     <p:sldId id="270" r:id="rId11"/>
-    <p:sldId id="269" r:id="rId12"/>
-    <p:sldId id="262" r:id="rId13"/>
+    <p:sldId id="262" r:id="rId12"/>
+    <p:sldId id="269" r:id="rId13"/>
     <p:sldId id="260" r:id="rId14"/>
     <p:sldId id="266" r:id="rId15"/>
     <p:sldId id="264" r:id="rId16"/>
@@ -128,13 +128,20 @@
 <pc:chgInfo xmlns:a="http://schemas.openxmlformats.org/drawingml/2006/main" xmlns:r="http://schemas.openxmlformats.org/officeDocument/2006/relationships" xmlns:ac="http://schemas.microsoft.com/office/drawing/2013/main/command" xmlns:pc="http://schemas.microsoft.com/office/powerpoint/2013/main/command">
   <pc:docChgLst>
     <pc:chgData name="Ádám Czirják" userId="688945b6dea242df" providerId="LiveId" clId="{D8E19705-0FAD-428B-87E6-52AA5BE1479A}"/>
-    <pc:docChg chg="undo custSel modSld">
-      <pc:chgData name="Ádám Czirják" userId="688945b6dea242df" providerId="LiveId" clId="{D8E19705-0FAD-428B-87E6-52AA5BE1479A}" dt="2026-04-15T17:19:57.485" v="33" actId="20577"/>
+    <pc:docChg chg="undo custSel modSld sldOrd">
+      <pc:chgData name="Ádám Czirják" userId="688945b6dea242df" providerId="LiveId" clId="{D8E19705-0FAD-428B-87E6-52AA5BE1479A}" dt="2026-04-17T10:55:59.859" v="621" actId="6549"/>
       <pc:docMkLst>
         <pc:docMk/>
       </pc:docMkLst>
-      <pc:sldChg chg="modSp mod">
-        <pc:chgData name="Ádám Czirják" userId="688945b6dea242df" providerId="LiveId" clId="{D8E19705-0FAD-428B-87E6-52AA5BE1479A}" dt="2026-04-15T17:19:57.485" v="33" actId="20577"/>
+      <pc:sldChg chg="modNotesTx">
+        <pc:chgData name="Ádám Czirják" userId="688945b6dea242df" providerId="LiveId" clId="{D8E19705-0FAD-428B-87E6-52AA5BE1479A}" dt="2026-04-16T20:20:29.441" v="154" actId="20577"/>
+        <pc:sldMkLst>
+          <pc:docMk/>
+          <pc:sldMk cId="0" sldId="257"/>
+        </pc:sldMkLst>
+      </pc:sldChg>
+      <pc:sldChg chg="modSp mod modNotesTx">
+        <pc:chgData name="Ádám Czirják" userId="688945b6dea242df" providerId="LiveId" clId="{D8E19705-0FAD-428B-87E6-52AA5BE1479A}" dt="2026-04-16T20:20:58.519" v="204" actId="20577"/>
         <pc:sldMkLst>
           <pc:docMk/>
           <pc:sldMk cId="0" sldId="258"/>
@@ -155,6 +162,48 @@
             <ac:spMk id="28" creationId="{00000000-0000-0000-0000-000000000000}"/>
           </ac:spMkLst>
         </pc:spChg>
+      </pc:sldChg>
+      <pc:sldChg chg="ord modNotesTx">
+        <pc:chgData name="Ádám Czirják" userId="688945b6dea242df" providerId="LiveId" clId="{D8E19705-0FAD-428B-87E6-52AA5BE1479A}" dt="2026-04-17T10:55:32.240" v="620"/>
+        <pc:sldMkLst>
+          <pc:docMk/>
+          <pc:sldMk cId="0" sldId="262"/>
+        </pc:sldMkLst>
+      </pc:sldChg>
+      <pc:sldChg chg="modNotesTx">
+        <pc:chgData name="Ádám Czirják" userId="688945b6dea242df" providerId="LiveId" clId="{D8E19705-0FAD-428B-87E6-52AA5BE1479A}" dt="2026-04-17T10:55:59.859" v="621" actId="6549"/>
+        <pc:sldMkLst>
+          <pc:docMk/>
+          <pc:sldMk cId="0" sldId="264"/>
+        </pc:sldMkLst>
+      </pc:sldChg>
+      <pc:sldChg chg="modNotesTx">
+        <pc:chgData name="Ádám Czirják" userId="688945b6dea242df" providerId="LiveId" clId="{D8E19705-0FAD-428B-87E6-52AA5BE1479A}" dt="2026-04-16T20:21:20.673" v="262" actId="20577"/>
+        <pc:sldMkLst>
+          <pc:docMk/>
+          <pc:sldMk cId="0" sldId="265"/>
+        </pc:sldMkLst>
+      </pc:sldChg>
+      <pc:sldChg chg="modNotesTx">
+        <pc:chgData name="Ádám Czirják" userId="688945b6dea242df" providerId="LiveId" clId="{D8E19705-0FAD-428B-87E6-52AA5BE1479A}" dt="2026-04-16T20:23:14.664" v="537" actId="20577"/>
+        <pc:sldMkLst>
+          <pc:docMk/>
+          <pc:sldMk cId="0" sldId="266"/>
+        </pc:sldMkLst>
+      </pc:sldChg>
+      <pc:sldChg chg="modNotesTx">
+        <pc:chgData name="Ádám Czirják" userId="688945b6dea242df" providerId="LiveId" clId="{D8E19705-0FAD-428B-87E6-52AA5BE1479A}" dt="2026-04-16T20:22:23.413" v="425" actId="20577"/>
+        <pc:sldMkLst>
+          <pc:docMk/>
+          <pc:sldMk cId="3857609010" sldId="269"/>
+        </pc:sldMkLst>
+      </pc:sldChg>
+      <pc:sldChg chg="modNotesTx">
+        <pc:chgData name="Ádám Czirják" userId="688945b6dea242df" providerId="LiveId" clId="{D8E19705-0FAD-428B-87E6-52AA5BE1479A}" dt="2026-04-16T20:21:54.059" v="390" actId="20577"/>
+        <pc:sldMkLst>
+          <pc:docMk/>
+          <pc:sldMk cId="2259520895" sldId="271"/>
+        </pc:sldMkLst>
       </pc:sldChg>
     </pc:docChg>
   </pc:docChgLst>
@@ -519,6 +568,14 @@
           <a:bodyPr/>
           <a:lstStyle/>
           <a:p>
+            <a:r>
+              <a:rPr lang="hu-HU" dirty="0"/>
+              <a:t>Angol, bejelentkezés, regisztráció, esetleg </a:t>
+            </a:r>
+            <a:r>
+              <a:rPr lang="hu-HU" dirty="0" err="1"/>
+              <a:t>order</a:t>
+            </a:r>
             <a:endParaRPr lang="en-US" dirty="0"/>
           </a:p>
         </p:txBody>
@@ -792,6 +849,10 @@
           <a:bodyPr/>
           <a:lstStyle/>
           <a:p>
+            <a:r>
+              <a:rPr lang="hu-HU" dirty="0"/>
+              <a:t>Egyszerű cél, Velünk egykorú vállalkozó kedvű fiatalok, érdekel, szeretem és élvezem is csinálni szabad időmben</a:t>
+            </a:r>
             <a:endParaRPr lang="en-US" dirty="0"/>
           </a:p>
         </p:txBody>
@@ -883,6 +944,26 @@
           <a:bodyPr/>
           <a:lstStyle/>
           <a:p>
+            <a:r>
+              <a:rPr lang="hu-HU" dirty="0"/>
+              <a:t>Viszonylag hozzánk illő feladatok, </a:t>
+            </a:r>
+            <a:r>
+              <a:rPr lang="hu-HU" dirty="0" err="1"/>
+              <a:t>docker</a:t>
+            </a:r>
+            <a:r>
+              <a:rPr lang="hu-HU" dirty="0"/>
+              <a:t>, </a:t>
+            </a:r>
+            <a:r>
+              <a:rPr lang="hu-HU" dirty="0" err="1"/>
+              <a:t>git</a:t>
+            </a:r>
+            <a:r>
+              <a:rPr lang="hu-HU" dirty="0"/>
+              <a:t> kihasználás</a:t>
+            </a:r>
             <a:endParaRPr lang="en-US" dirty="0"/>
           </a:p>
         </p:txBody>
@@ -974,6 +1055,34 @@
           <a:bodyPr/>
           <a:lstStyle/>
           <a:p>
+            <a:r>
+              <a:rPr lang="hu-HU" dirty="0"/>
+              <a:t>Ismert </a:t>
+            </a:r>
+            <a:r>
+              <a:rPr lang="hu-HU" dirty="0" err="1"/>
+              <a:t>stack</a:t>
+            </a:r>
+            <a:r>
+              <a:rPr lang="hu-HU" dirty="0"/>
+              <a:t>, a </a:t>
+            </a:r>
+            <a:r>
+              <a:rPr lang="hu-HU" dirty="0" err="1"/>
+              <a:t>component</a:t>
+            </a:r>
+            <a:r>
+              <a:rPr lang="hu-HU" dirty="0"/>
+              <a:t> </a:t>
+            </a:r>
+            <a:r>
+              <a:rPr lang="hu-HU" dirty="0" err="1"/>
+              <a:t>libraryvel</a:t>
+            </a:r>
+            <a:r>
+              <a:rPr lang="hu-HU" dirty="0"/>
+              <a:t>, </a:t>
+            </a:r>
             <a:endParaRPr lang="en-US" dirty="0"/>
           </a:p>
         </p:txBody>
@@ -1083,6 +1192,26 @@
           <a:bodyPr/>
           <a:lstStyle/>
           <a:p>
+            <a:r>
+              <a:rPr lang="hu-HU" dirty="0"/>
+              <a:t>Egyszerű, de stabil funkciók teljes </a:t>
+            </a:r>
+            <a:r>
+              <a:rPr lang="hu-HU" dirty="0" err="1"/>
+              <a:t>crud</a:t>
+            </a:r>
+            <a:r>
+              <a:rPr lang="hu-HU" dirty="0"/>
+              <a:t> az </a:t>
+            </a:r>
+            <a:r>
+              <a:rPr lang="hu-HU" dirty="0" err="1"/>
+              <a:t>alk</a:t>
+            </a:r>
+            <a:r>
+              <a:rPr lang="hu-HU" dirty="0"/>
+              <a:t>. szegmenseire</a:t>
+            </a:r>
             <a:endParaRPr lang="en-US" dirty="0"/>
           </a:p>
         </p:txBody>
@@ -1340,6 +1469,124 @@
   <p:cSld>
     <p:spTree>
       <p:nvGrpSpPr>
+        <p:cNvPr id="1" name=""/>
+        <p:cNvGrpSpPr/>
+        <p:nvPr/>
+      </p:nvGrpSpPr>
+      <p:grpSpPr>
+        <a:xfrm>
+          <a:off x="0" y="0"/>
+          <a:ext cx="0" cy="0"/>
+          <a:chOff x="0" y="0"/>
+          <a:chExt cx="0" cy="0"/>
+        </a:xfrm>
+      </p:grpSpPr>
+      <p:sp>
+        <p:nvSpPr>
+          <p:cNvPr id="2" name="Slide Image Placeholder 1"/>
+          <p:cNvSpPr>
+            <a:spLocks noGrp="1" noRot="1" noChangeAspect="1"/>
+          </p:cNvSpPr>
+          <p:nvPr>
+            <p:ph type="sldImg"/>
+          </p:nvPr>
+        </p:nvSpPr>
+        <p:spPr/>
+        <p:txBody>
+          <a:bodyPr/>
+          <a:lstStyle/>
+          <a:p>
+            <a:endParaRPr lang="hu-HU"/>
+          </a:p>
+        </p:txBody>
+      </p:sp>
+      <p:sp>
+        <p:nvSpPr>
+          <p:cNvPr id="3" name="Notes Placeholder 2"/>
+          <p:cNvSpPr>
+            <a:spLocks noGrp="1"/>
+          </p:cNvSpPr>
+          <p:nvPr>
+            <p:ph type="body" idx="1"/>
+          </p:nvPr>
+        </p:nvSpPr>
+        <p:spPr/>
+        <p:txBody>
+          <a:bodyPr/>
+          <a:lstStyle/>
+          <a:p>
+            <a:r>
+              <a:rPr lang="hu-HU" dirty="0"/>
+              <a:t>Edge </a:t>
+            </a:r>
+            <a:r>
+              <a:rPr lang="hu-HU" dirty="0" err="1"/>
+              <a:t>cases</a:t>
+            </a:r>
+            <a:r>
+              <a:rPr lang="hu-HU" dirty="0"/>
+              <a:t>, intelligens, </a:t>
+            </a:r>
+            <a:r>
+              <a:rPr lang="hu-HU" dirty="0" err="1"/>
+              <a:t>token</a:t>
+            </a:r>
+            <a:r>
+              <a:rPr lang="hu-HU" dirty="0"/>
+              <a:t>, </a:t>
+            </a:r>
+            <a:r>
+              <a:rPr lang="hu-HU" dirty="0" err="1"/>
+              <a:t>content-type</a:t>
+            </a:r>
+            <a:r>
+              <a:rPr lang="hu-HU" dirty="0"/>
+              <a:t> </a:t>
+            </a:r>
+          </a:p>
+        </p:txBody>
+      </p:sp>
+      <p:sp>
+        <p:nvSpPr>
+          <p:cNvPr id="4" name="Slide Number Placeholder 3"/>
+          <p:cNvSpPr>
+            <a:spLocks noGrp="1"/>
+          </p:cNvSpPr>
+          <p:nvPr>
+            <p:ph type="sldNum" sz="quarter" idx="10"/>
+          </p:nvPr>
+        </p:nvSpPr>
+        <p:spPr/>
+        <p:txBody>
+          <a:bodyPr/>
+          <a:lstStyle/>
+          <a:p>
+            <a:fld id="{F7021451-1387-4CA6-816F-3879F97B5CBC}" type="slidenum">
+              <a:rPr lang="en-US"/>
+              <a:t>8</a:t>
+            </a:fld>
+            <a:endParaRPr lang="en-US"/>
+          </a:p>
+        </p:txBody>
+      </p:sp>
+    </p:spTree>
+    <p:extLst>
+      <p:ext uri="{BB962C8B-B14F-4D97-AF65-F5344CB8AC3E}">
+        <p14:creationId xmlns:p14="http://schemas.microsoft.com/office/powerpoint/2010/main" val="1024086991"/>
+      </p:ext>
+    </p:extLst>
+  </p:cSld>
+  <p:clrMapOvr>
+    <a:masterClrMapping/>
+  </p:clrMapOvr>
+</p:notes>
+</file>
+
+<file path=ppt/notesSlides/notesSlide9.xml><?xml version="1.0" encoding="utf-8"?>
+<p:notes xmlns:a="http://schemas.openxmlformats.org/drawingml/2006/main" xmlns:r="http://schemas.openxmlformats.org/officeDocument/2006/relationships" xmlns:p="http://schemas.openxmlformats.org/presentationml/2006/main">
+  <p:cSld>
+    <p:spTree>
+      <p:nvGrpSpPr>
         <p:cNvPr id="1" name="">
           <a:extLst>
             <a:ext uri="{FF2B5EF4-FFF2-40B4-BE49-F238E27FC236}">
@@ -1404,6 +1651,30 @@
           <a:bodyPr/>
           <a:lstStyle/>
           <a:p>
+            <a:r>
+              <a:rPr lang="hu-HU" dirty="0"/>
+              <a:t>Irányítás, </a:t>
+            </a:r>
+            <a:r>
+              <a:rPr lang="hu-HU" dirty="0" err="1"/>
+              <a:t>admin</a:t>
+            </a:r>
+            <a:r>
+              <a:rPr lang="hu-HU" dirty="0"/>
+              <a:t> </a:t>
+            </a:r>
+            <a:r>
+              <a:rPr lang="hu-HU" dirty="0" err="1"/>
+              <a:t>role</a:t>
+            </a:r>
+            <a:r>
+              <a:rPr lang="hu-HU" dirty="0"/>
+              <a:t>, </a:t>
+            </a:r>
+            <a:r>
+              <a:rPr lang="hu-HU" dirty="0" err="1"/>
+              <a:t>token</a:t>
+            </a:r>
             <a:endParaRPr lang="en-US" dirty="0"/>
           </a:p>
         </p:txBody>
@@ -1431,7 +1702,7 @@
           <a:p>
             <a:fld id="{F7021451-1387-4CA6-816F-3879F97B5CBC}" type="slidenum">
               <a:rPr lang="en-US"/>
-              <a:t>8</a:t>
+              <a:t>9</a:t>
             </a:fld>
             <a:endParaRPr lang="en-US"/>
           </a:p>
@@ -1441,97 +1712,6 @@
     <p:extLst>
       <p:ext uri="{BB962C8B-B14F-4D97-AF65-F5344CB8AC3E}">
         <p14:creationId xmlns:p14="http://schemas.microsoft.com/office/powerpoint/2010/main" val="3351071054"/>
-      </p:ext>
-    </p:extLst>
-  </p:cSld>
-  <p:clrMapOvr>
-    <a:masterClrMapping/>
-  </p:clrMapOvr>
-</p:notes>
-</file>
-
-<file path=ppt/notesSlides/notesSlide9.xml><?xml version="1.0" encoding="utf-8"?>
-<p:notes xmlns:a="http://schemas.openxmlformats.org/drawingml/2006/main" xmlns:r="http://schemas.openxmlformats.org/officeDocument/2006/relationships" xmlns:p="http://schemas.openxmlformats.org/presentationml/2006/main">
-  <p:cSld>
-    <p:spTree>
-      <p:nvGrpSpPr>
-        <p:cNvPr id="1" name=""/>
-        <p:cNvGrpSpPr/>
-        <p:nvPr/>
-      </p:nvGrpSpPr>
-      <p:grpSpPr>
-        <a:xfrm>
-          <a:off x="0" y="0"/>
-          <a:ext cx="0" cy="0"/>
-          <a:chOff x="0" y="0"/>
-          <a:chExt cx="0" cy="0"/>
-        </a:xfrm>
-      </p:grpSpPr>
-      <p:sp>
-        <p:nvSpPr>
-          <p:cNvPr id="2" name="Slide Image Placeholder 1"/>
-          <p:cNvSpPr>
-            <a:spLocks noGrp="1" noRot="1" noChangeAspect="1"/>
-          </p:cNvSpPr>
-          <p:nvPr>
-            <p:ph type="sldImg"/>
-          </p:nvPr>
-        </p:nvSpPr>
-        <p:spPr/>
-        <p:txBody>
-          <a:bodyPr/>
-          <a:lstStyle/>
-          <a:p>
-            <a:endParaRPr lang="hu-HU"/>
-          </a:p>
-        </p:txBody>
-      </p:sp>
-      <p:sp>
-        <p:nvSpPr>
-          <p:cNvPr id="3" name="Notes Placeholder 2"/>
-          <p:cNvSpPr>
-            <a:spLocks noGrp="1"/>
-          </p:cNvSpPr>
-          <p:nvPr>
-            <p:ph type="body" idx="1"/>
-          </p:nvPr>
-        </p:nvSpPr>
-        <p:spPr/>
-        <p:txBody>
-          <a:bodyPr/>
-          <a:lstStyle/>
-          <a:p>
-            <a:endParaRPr lang="hu-HU" dirty="0"/>
-          </a:p>
-        </p:txBody>
-      </p:sp>
-      <p:sp>
-        <p:nvSpPr>
-          <p:cNvPr id="4" name="Slide Number Placeholder 3"/>
-          <p:cNvSpPr>
-            <a:spLocks noGrp="1"/>
-          </p:cNvSpPr>
-          <p:nvPr>
-            <p:ph type="sldNum" sz="quarter" idx="10"/>
-          </p:nvPr>
-        </p:nvSpPr>
-        <p:spPr/>
-        <p:txBody>
-          <a:bodyPr/>
-          <a:lstStyle/>
-          <a:p>
-            <a:fld id="{F7021451-1387-4CA6-816F-3879F97B5CBC}" type="slidenum">
-              <a:rPr lang="en-US"/>
-              <a:t>9</a:t>
-            </a:fld>
-            <a:endParaRPr lang="en-US"/>
-          </a:p>
-        </p:txBody>
-      </p:sp>
-    </p:spTree>
-    <p:extLst>
-      <p:ext uri="{BB962C8B-B14F-4D97-AF65-F5344CB8AC3E}">
-        <p14:creationId xmlns:p14="http://schemas.microsoft.com/office/powerpoint/2010/main" val="1024086991"/>
       </p:ext>
     </p:extLst>
   </p:cSld>
@@ -15970,6 +16150,791 @@
 
 <file path=ppt/slides/slide8.xml><?xml version="1.0" encoding="utf-8"?>
 <p:sld xmlns:a="http://schemas.openxmlformats.org/drawingml/2006/main" xmlns:r="http://schemas.openxmlformats.org/officeDocument/2006/relationships" xmlns:p="http://schemas.openxmlformats.org/presentationml/2006/main">
+  <p:cSld name="Slide 7">
+    <p:bg>
+      <p:bgPr>
+        <a:solidFill>
+          <a:srgbClr val="0B1628"/>
+        </a:solidFill>
+        <a:effectLst/>
+      </p:bgPr>
+    </p:bg>
+    <p:spTree>
+      <p:nvGrpSpPr>
+        <p:cNvPr id="1" name=""/>
+        <p:cNvGrpSpPr/>
+        <p:nvPr/>
+      </p:nvGrpSpPr>
+      <p:grpSpPr>
+        <a:xfrm>
+          <a:off x="0" y="0"/>
+          <a:ext cx="0" cy="0"/>
+          <a:chOff x="0" y="0"/>
+          <a:chExt cx="0" cy="0"/>
+        </a:xfrm>
+      </p:grpSpPr>
+      <p:sp>
+        <p:nvSpPr>
+          <p:cNvPr id="2" name="Shape 0"/>
+          <p:cNvSpPr/>
+          <p:nvPr/>
+        </p:nvSpPr>
+        <p:spPr>
+          <a:xfrm>
+            <a:off x="457200" y="256032"/>
+            <a:ext cx="54864" cy="713232"/>
+          </a:xfrm>
+          <a:prstGeom prst="rect">
+            <a:avLst/>
+          </a:prstGeom>
+          <a:solidFill>
+            <a:srgbClr val="E9A227"/>
+          </a:solidFill>
+          <a:ln w="12700">
+            <a:solidFill>
+              <a:srgbClr val="E9A227"/>
+            </a:solidFill>
+            <a:prstDash val="solid"/>
+          </a:ln>
+        </p:spPr>
+        <p:txBody>
+          <a:bodyPr/>
+          <a:lstStyle/>
+          <a:p>
+            <a:endParaRPr lang="hu-HU"/>
+          </a:p>
+        </p:txBody>
+      </p:sp>
+      <p:sp>
+        <p:nvSpPr>
+          <p:cNvPr id="3" name="Text 1"/>
+          <p:cNvSpPr/>
+          <p:nvPr/>
+        </p:nvSpPr>
+        <p:spPr>
+          <a:xfrm>
+            <a:off x="658368" y="201168"/>
+            <a:ext cx="4187952" cy="822960"/>
+          </a:xfrm>
+          <a:prstGeom prst="rect">
+            <a:avLst/>
+          </a:prstGeom>
+          <a:noFill/>
+          <a:ln/>
+        </p:spPr>
+        <p:txBody>
+          <a:bodyPr wrap="square" lIns="0" tIns="0" rIns="0" bIns="0" rtlCol="0" anchor="ctr"/>
+          <a:lstStyle/>
+          <a:p>
+            <a:pPr marL="0" indent="0">
+              <a:buNone/>
+            </a:pPr>
+            <a:r>
+              <a:rPr lang="en-US" sz="2000" b="1" dirty="0">
+                <a:solidFill>
+                  <a:srgbClr val="FFFFFF"/>
+                </a:solidFill>
+                <a:latin typeface="Palatino Linotype" pitchFamily="34" charset="0"/>
+                <a:ea typeface="Palatino Linotype" pitchFamily="34" charset="-122"/>
+                <a:cs typeface="Palatino Linotype" pitchFamily="34" charset="-120"/>
+              </a:rPr>
+              <a:t>Végponthívás a kliens oldalon</a:t>
+            </a:r>
+            <a:endParaRPr lang="en-US" sz="2000" dirty="0"/>
+          </a:p>
+        </p:txBody>
+      </p:sp>
+      <p:sp>
+        <p:nvSpPr>
+          <p:cNvPr id="4" name="Shape 2"/>
+          <p:cNvSpPr/>
+          <p:nvPr/>
+        </p:nvSpPr>
+        <p:spPr>
+          <a:xfrm>
+            <a:off x="0" y="1097280"/>
+            <a:ext cx="9144000" cy="16459"/>
+          </a:xfrm>
+          <a:prstGeom prst="rect">
+            <a:avLst/>
+          </a:prstGeom>
+          <a:solidFill>
+            <a:srgbClr val="1F3050"/>
+          </a:solidFill>
+          <a:ln w="12700">
+            <a:solidFill>
+              <a:srgbClr val="1F3050"/>
+            </a:solidFill>
+            <a:prstDash val="solid"/>
+          </a:ln>
+        </p:spPr>
+        <p:txBody>
+          <a:bodyPr/>
+          <a:lstStyle/>
+          <a:p>
+            <a:endParaRPr lang="hu-HU"/>
+          </a:p>
+        </p:txBody>
+      </p:sp>
+      <p:sp>
+        <p:nvSpPr>
+          <p:cNvPr id="5" name="Shape 3"/>
+          <p:cNvSpPr/>
+          <p:nvPr/>
+        </p:nvSpPr>
+        <p:spPr>
+          <a:xfrm>
+            <a:off x="0" y="5102352"/>
+            <a:ext cx="9144000" cy="41148"/>
+          </a:xfrm>
+          <a:prstGeom prst="rect">
+            <a:avLst/>
+          </a:prstGeom>
+          <a:solidFill>
+            <a:srgbClr val="1F3050"/>
+          </a:solidFill>
+          <a:ln w="12700">
+            <a:solidFill>
+              <a:srgbClr val="1F3050"/>
+            </a:solidFill>
+            <a:prstDash val="solid"/>
+          </a:ln>
+        </p:spPr>
+        <p:txBody>
+          <a:bodyPr/>
+          <a:lstStyle/>
+          <a:p>
+            <a:endParaRPr lang="hu-HU"/>
+          </a:p>
+        </p:txBody>
+      </p:sp>
+      <p:pic>
+        <p:nvPicPr>
+          <p:cNvPr id="7" name="Image 0" descr="/home/claude/unpacked_clean/ppt/media/image3.png"/>
+          <p:cNvPicPr>
+            <a:picLocks noChangeAspect="1"/>
+          </p:cNvPicPr>
+          <p:nvPr/>
+        </p:nvPicPr>
+        <p:blipFill>
+          <a:blip r:embed="rId3"/>
+          <a:stretch>
+            <a:fillRect/>
+          </a:stretch>
+        </p:blipFill>
+        <p:spPr>
+          <a:xfrm>
+            <a:off x="5189220" y="201168"/>
+            <a:ext cx="3657600" cy="4756709"/>
+          </a:xfrm>
+          <a:prstGeom prst="rect">
+            <a:avLst/>
+          </a:prstGeom>
+          <a:effectLst>
+            <a:outerShdw blurRad="228600" dist="50800" dir="8100000" algn="bl" rotWithShape="0">
+              <a:srgbClr val="000000">
+                <a:alpha val="55000"/>
+              </a:srgbClr>
+            </a:outerShdw>
+          </a:effectLst>
+        </p:spPr>
+      </p:pic>
+      <p:sp>
+        <p:nvSpPr>
+          <p:cNvPr id="9" name="Shape 6"/>
+          <p:cNvSpPr/>
+          <p:nvPr/>
+        </p:nvSpPr>
+        <p:spPr>
+          <a:xfrm>
+            <a:off x="457200" y="1261872"/>
+            <a:ext cx="4389120" cy="658368"/>
+          </a:xfrm>
+          <a:prstGeom prst="rect">
+            <a:avLst/>
+          </a:prstGeom>
+          <a:solidFill>
+            <a:srgbClr val="1A2B42"/>
+          </a:solidFill>
+          <a:ln w="9525">
+            <a:solidFill>
+              <a:srgbClr val="1F3050"/>
+            </a:solidFill>
+            <a:prstDash val="solid"/>
+          </a:ln>
+          <a:effectLst>
+            <a:outerShdw blurRad="101600" dist="25400" dir="8100000" algn="bl" rotWithShape="0">
+              <a:srgbClr val="000000">
+                <a:alpha val="30000"/>
+              </a:srgbClr>
+            </a:outerShdw>
+          </a:effectLst>
+        </p:spPr>
+        <p:txBody>
+          <a:bodyPr/>
+          <a:lstStyle/>
+          <a:p>
+            <a:endParaRPr lang="hu-HU"/>
+          </a:p>
+        </p:txBody>
+      </p:sp>
+      <p:sp>
+        <p:nvSpPr>
+          <p:cNvPr id="10" name="Shape 7"/>
+          <p:cNvSpPr/>
+          <p:nvPr/>
+        </p:nvSpPr>
+        <p:spPr>
+          <a:xfrm>
+            <a:off x="457200" y="1261872"/>
+            <a:ext cx="45720" cy="658368"/>
+          </a:xfrm>
+          <a:prstGeom prst="rect">
+            <a:avLst/>
+          </a:prstGeom>
+          <a:solidFill>
+            <a:srgbClr val="E9A227"/>
+          </a:solidFill>
+          <a:ln w="12700">
+            <a:solidFill>
+              <a:srgbClr val="E9A227"/>
+            </a:solidFill>
+            <a:prstDash val="solid"/>
+          </a:ln>
+        </p:spPr>
+        <p:txBody>
+          <a:bodyPr/>
+          <a:lstStyle/>
+          <a:p>
+            <a:endParaRPr lang="hu-HU"/>
+          </a:p>
+        </p:txBody>
+      </p:sp>
+      <p:sp>
+        <p:nvSpPr>
+          <p:cNvPr id="11" name="Text 8"/>
+          <p:cNvSpPr/>
+          <p:nvPr/>
+        </p:nvSpPr>
+        <p:spPr>
+          <a:xfrm>
+            <a:off x="640080" y="1325880"/>
+            <a:ext cx="4069080" cy="274320"/>
+          </a:xfrm>
+          <a:prstGeom prst="rect">
+            <a:avLst/>
+          </a:prstGeom>
+          <a:noFill/>
+          <a:ln/>
+        </p:spPr>
+        <p:txBody>
+          <a:bodyPr wrap="square" lIns="0" tIns="0" rIns="0" bIns="0" rtlCol="0" anchor="ctr"/>
+          <a:lstStyle/>
+          <a:p>
+            <a:pPr marL="0" indent="0">
+              <a:buNone/>
+            </a:pPr>
+            <a:r>
+              <a:rPr lang="en-US" b="1" dirty="0">
+                <a:solidFill>
+                  <a:srgbClr val="FFFFFF"/>
+                </a:solidFill>
+                <a:latin typeface="Trebuchet MS" pitchFamily="34" charset="0"/>
+                <a:ea typeface="Trebuchet MS" pitchFamily="34" charset="-122"/>
+                <a:cs typeface="Trebuchet MS" pitchFamily="34" charset="-120"/>
+              </a:rPr>
+              <a:t>DRY elv</a:t>
+            </a:r>
+            <a:endParaRPr lang="en-US" dirty="0"/>
+          </a:p>
+        </p:txBody>
+      </p:sp>
+      <p:sp>
+        <p:nvSpPr>
+          <p:cNvPr id="12" name="Text 9"/>
+          <p:cNvSpPr/>
+          <p:nvPr/>
+        </p:nvSpPr>
+        <p:spPr>
+          <a:xfrm>
+            <a:off x="640080" y="1627632"/>
+            <a:ext cx="4069080" cy="237744"/>
+          </a:xfrm>
+          <a:prstGeom prst="rect">
+            <a:avLst/>
+          </a:prstGeom>
+          <a:noFill/>
+          <a:ln/>
+        </p:spPr>
+        <p:txBody>
+          <a:bodyPr wrap="square" lIns="0" tIns="0" rIns="0" bIns="0" rtlCol="0" anchor="ctr"/>
+          <a:lstStyle/>
+          <a:p>
+            <a:pPr marL="0" indent="0">
+              <a:buNone/>
+            </a:pPr>
+            <a:endParaRPr lang="en-US" sz="1400" dirty="0"/>
+          </a:p>
+        </p:txBody>
+      </p:sp>
+      <p:sp>
+        <p:nvSpPr>
+          <p:cNvPr id="13" name="Shape 10"/>
+          <p:cNvSpPr/>
+          <p:nvPr/>
+        </p:nvSpPr>
+        <p:spPr>
+          <a:xfrm>
+            <a:off x="457200" y="2029968"/>
+            <a:ext cx="4389120" cy="658368"/>
+          </a:xfrm>
+          <a:prstGeom prst="rect">
+            <a:avLst/>
+          </a:prstGeom>
+          <a:solidFill>
+            <a:srgbClr val="1A2B42"/>
+          </a:solidFill>
+          <a:ln w="9525">
+            <a:solidFill>
+              <a:srgbClr val="1F3050"/>
+            </a:solidFill>
+            <a:prstDash val="solid"/>
+          </a:ln>
+          <a:effectLst>
+            <a:outerShdw blurRad="101600" dist="25400" dir="8100000" algn="bl" rotWithShape="0">
+              <a:srgbClr val="000000">
+                <a:alpha val="30000"/>
+              </a:srgbClr>
+            </a:outerShdw>
+          </a:effectLst>
+        </p:spPr>
+        <p:txBody>
+          <a:bodyPr/>
+          <a:lstStyle/>
+          <a:p>
+            <a:endParaRPr lang="hu-HU"/>
+          </a:p>
+        </p:txBody>
+      </p:sp>
+      <p:sp>
+        <p:nvSpPr>
+          <p:cNvPr id="14" name="Shape 11"/>
+          <p:cNvSpPr/>
+          <p:nvPr/>
+        </p:nvSpPr>
+        <p:spPr>
+          <a:xfrm>
+            <a:off x="457200" y="2029968"/>
+            <a:ext cx="45720" cy="658368"/>
+          </a:xfrm>
+          <a:prstGeom prst="rect">
+            <a:avLst/>
+          </a:prstGeom>
+          <a:solidFill>
+            <a:srgbClr val="E9A227"/>
+          </a:solidFill>
+          <a:ln w="12700">
+            <a:solidFill>
+              <a:srgbClr val="E9A227"/>
+            </a:solidFill>
+            <a:prstDash val="solid"/>
+          </a:ln>
+        </p:spPr>
+        <p:txBody>
+          <a:bodyPr/>
+          <a:lstStyle/>
+          <a:p>
+            <a:endParaRPr lang="hu-HU"/>
+          </a:p>
+        </p:txBody>
+      </p:sp>
+      <p:sp>
+        <p:nvSpPr>
+          <p:cNvPr id="15" name="Text 12"/>
+          <p:cNvSpPr/>
+          <p:nvPr/>
+        </p:nvSpPr>
+        <p:spPr>
+          <a:xfrm>
+            <a:off x="640080" y="2093976"/>
+            <a:ext cx="4069080" cy="274320"/>
+          </a:xfrm>
+          <a:prstGeom prst="rect">
+            <a:avLst/>
+          </a:prstGeom>
+          <a:noFill/>
+          <a:ln/>
+        </p:spPr>
+        <p:txBody>
+          <a:bodyPr wrap="square" lIns="0" tIns="0" rIns="0" bIns="0" rtlCol="0" anchor="ctr"/>
+          <a:lstStyle/>
+          <a:p>
+            <a:pPr marL="0" indent="0">
+              <a:buNone/>
+            </a:pPr>
+            <a:r>
+              <a:rPr lang="en-US" b="1" dirty="0">
+                <a:solidFill>
+                  <a:srgbClr val="FFFFFF"/>
+                </a:solidFill>
+                <a:latin typeface="Trebuchet MS" pitchFamily="34" charset="0"/>
+                <a:ea typeface="Trebuchet MS" pitchFamily="34" charset="-122"/>
+                <a:cs typeface="Trebuchet MS" pitchFamily="34" charset="-120"/>
+              </a:rPr>
+              <a:t>Auto</a:t>
+            </a:r>
+            <a:r>
+              <a:rPr lang="hu-HU" b="1" dirty="0" err="1">
+                <a:solidFill>
+                  <a:srgbClr val="FFFFFF"/>
+                </a:solidFill>
+                <a:latin typeface="Trebuchet MS" pitchFamily="34" charset="0"/>
+                <a:ea typeface="Trebuchet MS" pitchFamily="34" charset="-122"/>
+                <a:cs typeface="Trebuchet MS" pitchFamily="34" charset="-120"/>
+              </a:rPr>
+              <a:t>matikus</a:t>
+            </a:r>
+            <a:r>
+              <a:rPr lang="en-US" b="1" dirty="0">
+                <a:solidFill>
+                  <a:srgbClr val="FFFFFF"/>
+                </a:solidFill>
+                <a:latin typeface="Trebuchet MS" pitchFamily="34" charset="0"/>
+                <a:ea typeface="Trebuchet MS" pitchFamily="34" charset="-122"/>
+                <a:cs typeface="Trebuchet MS" pitchFamily="34" charset="-120"/>
+              </a:rPr>
+              <a:t> token kezelés</a:t>
+            </a:r>
+            <a:endParaRPr lang="en-US" dirty="0"/>
+          </a:p>
+        </p:txBody>
+      </p:sp>
+      <p:sp>
+        <p:nvSpPr>
+          <p:cNvPr id="16" name="Text 13"/>
+          <p:cNvSpPr/>
+          <p:nvPr/>
+        </p:nvSpPr>
+        <p:spPr>
+          <a:xfrm>
+            <a:off x="640080" y="2395728"/>
+            <a:ext cx="4069080" cy="237744"/>
+          </a:xfrm>
+          <a:prstGeom prst="rect">
+            <a:avLst/>
+          </a:prstGeom>
+          <a:noFill/>
+          <a:ln/>
+        </p:spPr>
+        <p:txBody>
+          <a:bodyPr wrap="square" lIns="0" tIns="0" rIns="0" bIns="0" rtlCol="0" anchor="ctr"/>
+          <a:lstStyle/>
+          <a:p>
+            <a:pPr marL="0" indent="0">
+              <a:buNone/>
+            </a:pPr>
+            <a:endParaRPr lang="en-US" sz="1400" dirty="0"/>
+          </a:p>
+        </p:txBody>
+      </p:sp>
+      <p:sp>
+        <p:nvSpPr>
+          <p:cNvPr id="17" name="Shape 14"/>
+          <p:cNvSpPr/>
+          <p:nvPr/>
+        </p:nvSpPr>
+        <p:spPr>
+          <a:xfrm>
+            <a:off x="457200" y="2798064"/>
+            <a:ext cx="4389120" cy="658368"/>
+          </a:xfrm>
+          <a:prstGeom prst="rect">
+            <a:avLst/>
+          </a:prstGeom>
+          <a:solidFill>
+            <a:srgbClr val="1A2B42"/>
+          </a:solidFill>
+          <a:ln w="9525">
+            <a:solidFill>
+              <a:srgbClr val="1F3050"/>
+            </a:solidFill>
+            <a:prstDash val="solid"/>
+          </a:ln>
+          <a:effectLst>
+            <a:outerShdw blurRad="101600" dist="25400" dir="8100000" algn="bl" rotWithShape="0">
+              <a:srgbClr val="000000">
+                <a:alpha val="30000"/>
+              </a:srgbClr>
+            </a:outerShdw>
+          </a:effectLst>
+        </p:spPr>
+        <p:txBody>
+          <a:bodyPr/>
+          <a:lstStyle/>
+          <a:p>
+            <a:endParaRPr lang="hu-HU"/>
+          </a:p>
+        </p:txBody>
+      </p:sp>
+      <p:sp>
+        <p:nvSpPr>
+          <p:cNvPr id="18" name="Shape 15"/>
+          <p:cNvSpPr/>
+          <p:nvPr/>
+        </p:nvSpPr>
+        <p:spPr>
+          <a:xfrm>
+            <a:off x="457200" y="2798064"/>
+            <a:ext cx="45720" cy="658368"/>
+          </a:xfrm>
+          <a:prstGeom prst="rect">
+            <a:avLst/>
+          </a:prstGeom>
+          <a:solidFill>
+            <a:srgbClr val="E9A227"/>
+          </a:solidFill>
+          <a:ln w="12700">
+            <a:solidFill>
+              <a:srgbClr val="E9A227"/>
+            </a:solidFill>
+            <a:prstDash val="solid"/>
+          </a:ln>
+        </p:spPr>
+        <p:txBody>
+          <a:bodyPr/>
+          <a:lstStyle/>
+          <a:p>
+            <a:endParaRPr lang="hu-HU"/>
+          </a:p>
+        </p:txBody>
+      </p:sp>
+      <p:sp>
+        <p:nvSpPr>
+          <p:cNvPr id="19" name="Text 16"/>
+          <p:cNvSpPr/>
+          <p:nvPr/>
+        </p:nvSpPr>
+        <p:spPr>
+          <a:xfrm>
+            <a:off x="640080" y="2862072"/>
+            <a:ext cx="4069080" cy="274320"/>
+          </a:xfrm>
+          <a:prstGeom prst="rect">
+            <a:avLst/>
+          </a:prstGeom>
+          <a:noFill/>
+          <a:ln/>
+        </p:spPr>
+        <p:txBody>
+          <a:bodyPr wrap="square" lIns="0" tIns="0" rIns="0" bIns="0" rtlCol="0" anchor="ctr"/>
+          <a:lstStyle/>
+          <a:p>
+            <a:pPr marL="0" indent="0">
+              <a:buNone/>
+            </a:pPr>
+            <a:r>
+              <a:rPr lang="en-US" b="1" dirty="0">
+                <a:solidFill>
+                  <a:srgbClr val="FFFFFF"/>
+                </a:solidFill>
+                <a:latin typeface="Trebuchet MS" pitchFamily="34" charset="0"/>
+                <a:ea typeface="Trebuchet MS" pitchFamily="34" charset="-122"/>
+                <a:cs typeface="Trebuchet MS" pitchFamily="34" charset="-120"/>
+              </a:rPr>
+              <a:t>Content-Type</a:t>
+            </a:r>
+            <a:endParaRPr lang="en-US" dirty="0"/>
+          </a:p>
+        </p:txBody>
+      </p:sp>
+      <p:sp>
+        <p:nvSpPr>
+          <p:cNvPr id="20" name="Text 17"/>
+          <p:cNvSpPr/>
+          <p:nvPr/>
+        </p:nvSpPr>
+        <p:spPr>
+          <a:xfrm>
+            <a:off x="640080" y="3163824"/>
+            <a:ext cx="4069080" cy="237744"/>
+          </a:xfrm>
+          <a:prstGeom prst="rect">
+            <a:avLst/>
+          </a:prstGeom>
+          <a:noFill/>
+          <a:ln/>
+        </p:spPr>
+        <p:txBody>
+          <a:bodyPr wrap="square" lIns="0" tIns="0" rIns="0" bIns="0" rtlCol="0" anchor="ctr"/>
+          <a:lstStyle/>
+          <a:p>
+            <a:pPr marL="0" indent="0">
+              <a:buNone/>
+            </a:pPr>
+            <a:endParaRPr lang="en-US" sz="1400" dirty="0"/>
+          </a:p>
+        </p:txBody>
+      </p:sp>
+      <p:sp>
+        <p:nvSpPr>
+          <p:cNvPr id="21" name="Shape 18"/>
+          <p:cNvSpPr/>
+          <p:nvPr/>
+        </p:nvSpPr>
+        <p:spPr>
+          <a:xfrm>
+            <a:off x="457200" y="3566160"/>
+            <a:ext cx="4389120" cy="658368"/>
+          </a:xfrm>
+          <a:prstGeom prst="rect">
+            <a:avLst/>
+          </a:prstGeom>
+          <a:solidFill>
+            <a:srgbClr val="1A2B42"/>
+          </a:solidFill>
+          <a:ln w="9525">
+            <a:solidFill>
+              <a:srgbClr val="1F3050"/>
+            </a:solidFill>
+            <a:prstDash val="solid"/>
+          </a:ln>
+          <a:effectLst>
+            <a:outerShdw blurRad="101600" dist="25400" dir="8100000" algn="bl" rotWithShape="0">
+              <a:srgbClr val="000000">
+                <a:alpha val="30000"/>
+              </a:srgbClr>
+            </a:outerShdw>
+          </a:effectLst>
+        </p:spPr>
+        <p:txBody>
+          <a:bodyPr/>
+          <a:lstStyle/>
+          <a:p>
+            <a:endParaRPr lang="hu-HU"/>
+          </a:p>
+        </p:txBody>
+      </p:sp>
+      <p:sp>
+        <p:nvSpPr>
+          <p:cNvPr id="22" name="Shape 19"/>
+          <p:cNvSpPr/>
+          <p:nvPr/>
+        </p:nvSpPr>
+        <p:spPr>
+          <a:xfrm>
+            <a:off x="457200" y="3566160"/>
+            <a:ext cx="45720" cy="658368"/>
+          </a:xfrm>
+          <a:prstGeom prst="rect">
+            <a:avLst/>
+          </a:prstGeom>
+          <a:solidFill>
+            <a:srgbClr val="E9A227"/>
+          </a:solidFill>
+          <a:ln w="12700">
+            <a:solidFill>
+              <a:srgbClr val="E9A227"/>
+            </a:solidFill>
+            <a:prstDash val="solid"/>
+          </a:ln>
+        </p:spPr>
+        <p:txBody>
+          <a:bodyPr/>
+          <a:lstStyle/>
+          <a:p>
+            <a:endParaRPr lang="hu-HU"/>
+          </a:p>
+        </p:txBody>
+      </p:sp>
+      <p:sp>
+        <p:nvSpPr>
+          <p:cNvPr id="23" name="Text 20"/>
+          <p:cNvSpPr/>
+          <p:nvPr/>
+        </p:nvSpPr>
+        <p:spPr>
+          <a:xfrm>
+            <a:off x="640080" y="3630168"/>
+            <a:ext cx="4069080" cy="274320"/>
+          </a:xfrm>
+          <a:prstGeom prst="rect">
+            <a:avLst/>
+          </a:prstGeom>
+          <a:noFill/>
+          <a:ln/>
+        </p:spPr>
+        <p:txBody>
+          <a:bodyPr wrap="square" lIns="0" tIns="0" rIns="0" bIns="0" rtlCol="0" anchor="ctr"/>
+          <a:lstStyle/>
+          <a:p>
+            <a:pPr marL="0" indent="0">
+              <a:buNone/>
+            </a:pPr>
+            <a:r>
+              <a:rPr lang="en-US" b="1" dirty="0">
+                <a:solidFill>
+                  <a:srgbClr val="FFFFFF"/>
+                </a:solidFill>
+                <a:latin typeface="Trebuchet MS" pitchFamily="34" charset="0"/>
+                <a:ea typeface="Trebuchet MS" pitchFamily="34" charset="-122"/>
+                <a:cs typeface="Trebuchet MS" pitchFamily="34" charset="-120"/>
+              </a:rPr>
+              <a:t>Token lejárat</a:t>
+            </a:r>
+            <a:endParaRPr lang="en-US" dirty="0"/>
+          </a:p>
+        </p:txBody>
+      </p:sp>
+      <p:sp>
+        <p:nvSpPr>
+          <p:cNvPr id="24" name="Text 21"/>
+          <p:cNvSpPr/>
+          <p:nvPr/>
+        </p:nvSpPr>
+        <p:spPr>
+          <a:xfrm>
+            <a:off x="640080" y="3931920"/>
+            <a:ext cx="4069080" cy="237744"/>
+          </a:xfrm>
+          <a:prstGeom prst="rect">
+            <a:avLst/>
+          </a:prstGeom>
+          <a:noFill/>
+          <a:ln/>
+        </p:spPr>
+        <p:txBody>
+          <a:bodyPr wrap="square" lIns="0" tIns="0" rIns="0" bIns="0" rtlCol="0" anchor="ctr"/>
+          <a:lstStyle/>
+          <a:p>
+            <a:pPr marL="0" indent="0">
+              <a:buNone/>
+            </a:pPr>
+            <a:endParaRPr lang="en-US" sz="1400" dirty="0"/>
+          </a:p>
+        </p:txBody>
+      </p:sp>
+    </p:spTree>
+  </p:cSld>
+  <p:clrMapOvr>
+    <a:masterClrMapping/>
+  </p:clrMapOvr>
+  <mc:AlternateContent xmlns:mc="http://schemas.openxmlformats.org/markup-compatibility/2006" xmlns:p14="http://schemas.microsoft.com/office/powerpoint/2010/main">
+    <mc:Choice Requires="p14">
+      <p:transition spd="med" p14:dur="700">
+        <p:fade/>
+      </p:transition>
+    </mc:Choice>
+    <mc:Fallback xmlns="">
+      <p:transition spd="med">
+        <p:fade/>
+      </p:transition>
+    </mc:Fallback>
+  </mc:AlternateContent>
+</p:sld>
+</file>
+
+<file path=ppt/slides/slide9.xml><?xml version="1.0" encoding="utf-8"?>
+<p:sld xmlns:a="http://schemas.openxmlformats.org/drawingml/2006/main" xmlns:r="http://schemas.openxmlformats.org/officeDocument/2006/relationships" xmlns:p="http://schemas.openxmlformats.org/presentationml/2006/main">
   <p:cSld>
     <p:bg>
       <p:bgPr>
@@ -16794,791 +17759,6 @@
         <p14:creationId xmlns:p14="http://schemas.microsoft.com/office/powerpoint/2010/main" val="3857609010"/>
       </p:ext>
     </p:extLst>
-  </p:cSld>
-  <p:clrMapOvr>
-    <a:masterClrMapping/>
-  </p:clrMapOvr>
-  <mc:AlternateContent xmlns:mc="http://schemas.openxmlformats.org/markup-compatibility/2006" xmlns:p14="http://schemas.microsoft.com/office/powerpoint/2010/main">
-    <mc:Choice Requires="p14">
-      <p:transition spd="med" p14:dur="700">
-        <p:fade/>
-      </p:transition>
-    </mc:Choice>
-    <mc:Fallback xmlns="">
-      <p:transition spd="med">
-        <p:fade/>
-      </p:transition>
-    </mc:Fallback>
-  </mc:AlternateContent>
-</p:sld>
-</file>
-
-<file path=ppt/slides/slide9.xml><?xml version="1.0" encoding="utf-8"?>
-<p:sld xmlns:a="http://schemas.openxmlformats.org/drawingml/2006/main" xmlns:r="http://schemas.openxmlformats.org/officeDocument/2006/relationships" xmlns:p="http://schemas.openxmlformats.org/presentationml/2006/main">
-  <p:cSld name="Slide 7">
-    <p:bg>
-      <p:bgPr>
-        <a:solidFill>
-          <a:srgbClr val="0B1628"/>
-        </a:solidFill>
-        <a:effectLst/>
-      </p:bgPr>
-    </p:bg>
-    <p:spTree>
-      <p:nvGrpSpPr>
-        <p:cNvPr id="1" name=""/>
-        <p:cNvGrpSpPr/>
-        <p:nvPr/>
-      </p:nvGrpSpPr>
-      <p:grpSpPr>
-        <a:xfrm>
-          <a:off x="0" y="0"/>
-          <a:ext cx="0" cy="0"/>
-          <a:chOff x="0" y="0"/>
-          <a:chExt cx="0" cy="0"/>
-        </a:xfrm>
-      </p:grpSpPr>
-      <p:sp>
-        <p:nvSpPr>
-          <p:cNvPr id="2" name="Shape 0"/>
-          <p:cNvSpPr/>
-          <p:nvPr/>
-        </p:nvSpPr>
-        <p:spPr>
-          <a:xfrm>
-            <a:off x="457200" y="256032"/>
-            <a:ext cx="54864" cy="713232"/>
-          </a:xfrm>
-          <a:prstGeom prst="rect">
-            <a:avLst/>
-          </a:prstGeom>
-          <a:solidFill>
-            <a:srgbClr val="E9A227"/>
-          </a:solidFill>
-          <a:ln w="12700">
-            <a:solidFill>
-              <a:srgbClr val="E9A227"/>
-            </a:solidFill>
-            <a:prstDash val="solid"/>
-          </a:ln>
-        </p:spPr>
-        <p:txBody>
-          <a:bodyPr/>
-          <a:lstStyle/>
-          <a:p>
-            <a:endParaRPr lang="hu-HU"/>
-          </a:p>
-        </p:txBody>
-      </p:sp>
-      <p:sp>
-        <p:nvSpPr>
-          <p:cNvPr id="3" name="Text 1"/>
-          <p:cNvSpPr/>
-          <p:nvPr/>
-        </p:nvSpPr>
-        <p:spPr>
-          <a:xfrm>
-            <a:off x="658368" y="201168"/>
-            <a:ext cx="4187952" cy="822960"/>
-          </a:xfrm>
-          <a:prstGeom prst="rect">
-            <a:avLst/>
-          </a:prstGeom>
-          <a:noFill/>
-          <a:ln/>
-        </p:spPr>
-        <p:txBody>
-          <a:bodyPr wrap="square" lIns="0" tIns="0" rIns="0" bIns="0" rtlCol="0" anchor="ctr"/>
-          <a:lstStyle/>
-          <a:p>
-            <a:pPr marL="0" indent="0">
-              <a:buNone/>
-            </a:pPr>
-            <a:r>
-              <a:rPr lang="en-US" sz="2000" b="1" dirty="0">
-                <a:solidFill>
-                  <a:srgbClr val="FFFFFF"/>
-                </a:solidFill>
-                <a:latin typeface="Palatino Linotype" pitchFamily="34" charset="0"/>
-                <a:ea typeface="Palatino Linotype" pitchFamily="34" charset="-122"/>
-                <a:cs typeface="Palatino Linotype" pitchFamily="34" charset="-120"/>
-              </a:rPr>
-              <a:t>Végponthívás a kliens oldalon</a:t>
-            </a:r>
-            <a:endParaRPr lang="en-US" sz="2000" dirty="0"/>
-          </a:p>
-        </p:txBody>
-      </p:sp>
-      <p:sp>
-        <p:nvSpPr>
-          <p:cNvPr id="4" name="Shape 2"/>
-          <p:cNvSpPr/>
-          <p:nvPr/>
-        </p:nvSpPr>
-        <p:spPr>
-          <a:xfrm>
-            <a:off x="0" y="1097280"/>
-            <a:ext cx="9144000" cy="16459"/>
-          </a:xfrm>
-          <a:prstGeom prst="rect">
-            <a:avLst/>
-          </a:prstGeom>
-          <a:solidFill>
-            <a:srgbClr val="1F3050"/>
-          </a:solidFill>
-          <a:ln w="12700">
-            <a:solidFill>
-              <a:srgbClr val="1F3050"/>
-            </a:solidFill>
-            <a:prstDash val="solid"/>
-          </a:ln>
-        </p:spPr>
-        <p:txBody>
-          <a:bodyPr/>
-          <a:lstStyle/>
-          <a:p>
-            <a:endParaRPr lang="hu-HU"/>
-          </a:p>
-        </p:txBody>
-      </p:sp>
-      <p:sp>
-        <p:nvSpPr>
-          <p:cNvPr id="5" name="Shape 3"/>
-          <p:cNvSpPr/>
-          <p:nvPr/>
-        </p:nvSpPr>
-        <p:spPr>
-          <a:xfrm>
-            <a:off x="0" y="5102352"/>
-            <a:ext cx="9144000" cy="41148"/>
-          </a:xfrm>
-          <a:prstGeom prst="rect">
-            <a:avLst/>
-          </a:prstGeom>
-          <a:solidFill>
-            <a:srgbClr val="1F3050"/>
-          </a:solidFill>
-          <a:ln w="12700">
-            <a:solidFill>
-              <a:srgbClr val="1F3050"/>
-            </a:solidFill>
-            <a:prstDash val="solid"/>
-          </a:ln>
-        </p:spPr>
-        <p:txBody>
-          <a:bodyPr/>
-          <a:lstStyle/>
-          <a:p>
-            <a:endParaRPr lang="hu-HU"/>
-          </a:p>
-        </p:txBody>
-      </p:sp>
-      <p:pic>
-        <p:nvPicPr>
-          <p:cNvPr id="7" name="Image 0" descr="/home/claude/unpacked_clean/ppt/media/image3.png"/>
-          <p:cNvPicPr>
-            <a:picLocks noChangeAspect="1"/>
-          </p:cNvPicPr>
-          <p:nvPr/>
-        </p:nvPicPr>
-        <p:blipFill>
-          <a:blip r:embed="rId3"/>
-          <a:stretch>
-            <a:fillRect/>
-          </a:stretch>
-        </p:blipFill>
-        <p:spPr>
-          <a:xfrm>
-            <a:off x="5189220" y="201168"/>
-            <a:ext cx="3657600" cy="4756709"/>
-          </a:xfrm>
-          <a:prstGeom prst="rect">
-            <a:avLst/>
-          </a:prstGeom>
-          <a:effectLst>
-            <a:outerShdw blurRad="228600" dist="50800" dir="8100000" algn="bl" rotWithShape="0">
-              <a:srgbClr val="000000">
-                <a:alpha val="55000"/>
-              </a:srgbClr>
-            </a:outerShdw>
-          </a:effectLst>
-        </p:spPr>
-      </p:pic>
-      <p:sp>
-        <p:nvSpPr>
-          <p:cNvPr id="9" name="Shape 6"/>
-          <p:cNvSpPr/>
-          <p:nvPr/>
-        </p:nvSpPr>
-        <p:spPr>
-          <a:xfrm>
-            <a:off x="457200" y="1261872"/>
-            <a:ext cx="4389120" cy="658368"/>
-          </a:xfrm>
-          <a:prstGeom prst="rect">
-            <a:avLst/>
-          </a:prstGeom>
-          <a:solidFill>
-            <a:srgbClr val="1A2B42"/>
-          </a:solidFill>
-          <a:ln w="9525">
-            <a:solidFill>
-              <a:srgbClr val="1F3050"/>
-            </a:solidFill>
-            <a:prstDash val="solid"/>
-          </a:ln>
-          <a:effectLst>
-            <a:outerShdw blurRad="101600" dist="25400" dir="8100000" algn="bl" rotWithShape="0">
-              <a:srgbClr val="000000">
-                <a:alpha val="30000"/>
-              </a:srgbClr>
-            </a:outerShdw>
-          </a:effectLst>
-        </p:spPr>
-        <p:txBody>
-          <a:bodyPr/>
-          <a:lstStyle/>
-          <a:p>
-            <a:endParaRPr lang="hu-HU"/>
-          </a:p>
-        </p:txBody>
-      </p:sp>
-      <p:sp>
-        <p:nvSpPr>
-          <p:cNvPr id="10" name="Shape 7"/>
-          <p:cNvSpPr/>
-          <p:nvPr/>
-        </p:nvSpPr>
-        <p:spPr>
-          <a:xfrm>
-            <a:off x="457200" y="1261872"/>
-            <a:ext cx="45720" cy="658368"/>
-          </a:xfrm>
-          <a:prstGeom prst="rect">
-            <a:avLst/>
-          </a:prstGeom>
-          <a:solidFill>
-            <a:srgbClr val="E9A227"/>
-          </a:solidFill>
-          <a:ln w="12700">
-            <a:solidFill>
-              <a:srgbClr val="E9A227"/>
-            </a:solidFill>
-            <a:prstDash val="solid"/>
-          </a:ln>
-        </p:spPr>
-        <p:txBody>
-          <a:bodyPr/>
-          <a:lstStyle/>
-          <a:p>
-            <a:endParaRPr lang="hu-HU"/>
-          </a:p>
-        </p:txBody>
-      </p:sp>
-      <p:sp>
-        <p:nvSpPr>
-          <p:cNvPr id="11" name="Text 8"/>
-          <p:cNvSpPr/>
-          <p:nvPr/>
-        </p:nvSpPr>
-        <p:spPr>
-          <a:xfrm>
-            <a:off x="640080" y="1325880"/>
-            <a:ext cx="4069080" cy="274320"/>
-          </a:xfrm>
-          <a:prstGeom prst="rect">
-            <a:avLst/>
-          </a:prstGeom>
-          <a:noFill/>
-          <a:ln/>
-        </p:spPr>
-        <p:txBody>
-          <a:bodyPr wrap="square" lIns="0" tIns="0" rIns="0" bIns="0" rtlCol="0" anchor="ctr"/>
-          <a:lstStyle/>
-          <a:p>
-            <a:pPr marL="0" indent="0">
-              <a:buNone/>
-            </a:pPr>
-            <a:r>
-              <a:rPr lang="en-US" b="1" dirty="0">
-                <a:solidFill>
-                  <a:srgbClr val="FFFFFF"/>
-                </a:solidFill>
-                <a:latin typeface="Trebuchet MS" pitchFamily="34" charset="0"/>
-                <a:ea typeface="Trebuchet MS" pitchFamily="34" charset="-122"/>
-                <a:cs typeface="Trebuchet MS" pitchFamily="34" charset="-120"/>
-              </a:rPr>
-              <a:t>DRY elv</a:t>
-            </a:r>
-            <a:endParaRPr lang="en-US" dirty="0"/>
-          </a:p>
-        </p:txBody>
-      </p:sp>
-      <p:sp>
-        <p:nvSpPr>
-          <p:cNvPr id="12" name="Text 9"/>
-          <p:cNvSpPr/>
-          <p:nvPr/>
-        </p:nvSpPr>
-        <p:spPr>
-          <a:xfrm>
-            <a:off x="640080" y="1627632"/>
-            <a:ext cx="4069080" cy="237744"/>
-          </a:xfrm>
-          <a:prstGeom prst="rect">
-            <a:avLst/>
-          </a:prstGeom>
-          <a:noFill/>
-          <a:ln/>
-        </p:spPr>
-        <p:txBody>
-          <a:bodyPr wrap="square" lIns="0" tIns="0" rIns="0" bIns="0" rtlCol="0" anchor="ctr"/>
-          <a:lstStyle/>
-          <a:p>
-            <a:pPr marL="0" indent="0">
-              <a:buNone/>
-            </a:pPr>
-            <a:endParaRPr lang="en-US" sz="1400" dirty="0"/>
-          </a:p>
-        </p:txBody>
-      </p:sp>
-      <p:sp>
-        <p:nvSpPr>
-          <p:cNvPr id="13" name="Shape 10"/>
-          <p:cNvSpPr/>
-          <p:nvPr/>
-        </p:nvSpPr>
-        <p:spPr>
-          <a:xfrm>
-            <a:off x="457200" y="2029968"/>
-            <a:ext cx="4389120" cy="658368"/>
-          </a:xfrm>
-          <a:prstGeom prst="rect">
-            <a:avLst/>
-          </a:prstGeom>
-          <a:solidFill>
-            <a:srgbClr val="1A2B42"/>
-          </a:solidFill>
-          <a:ln w="9525">
-            <a:solidFill>
-              <a:srgbClr val="1F3050"/>
-            </a:solidFill>
-            <a:prstDash val="solid"/>
-          </a:ln>
-          <a:effectLst>
-            <a:outerShdw blurRad="101600" dist="25400" dir="8100000" algn="bl" rotWithShape="0">
-              <a:srgbClr val="000000">
-                <a:alpha val="30000"/>
-              </a:srgbClr>
-            </a:outerShdw>
-          </a:effectLst>
-        </p:spPr>
-        <p:txBody>
-          <a:bodyPr/>
-          <a:lstStyle/>
-          <a:p>
-            <a:endParaRPr lang="hu-HU"/>
-          </a:p>
-        </p:txBody>
-      </p:sp>
-      <p:sp>
-        <p:nvSpPr>
-          <p:cNvPr id="14" name="Shape 11"/>
-          <p:cNvSpPr/>
-          <p:nvPr/>
-        </p:nvSpPr>
-        <p:spPr>
-          <a:xfrm>
-            <a:off x="457200" y="2029968"/>
-            <a:ext cx="45720" cy="658368"/>
-          </a:xfrm>
-          <a:prstGeom prst="rect">
-            <a:avLst/>
-          </a:prstGeom>
-          <a:solidFill>
-            <a:srgbClr val="E9A227"/>
-          </a:solidFill>
-          <a:ln w="12700">
-            <a:solidFill>
-              <a:srgbClr val="E9A227"/>
-            </a:solidFill>
-            <a:prstDash val="solid"/>
-          </a:ln>
-        </p:spPr>
-        <p:txBody>
-          <a:bodyPr/>
-          <a:lstStyle/>
-          <a:p>
-            <a:endParaRPr lang="hu-HU"/>
-          </a:p>
-        </p:txBody>
-      </p:sp>
-      <p:sp>
-        <p:nvSpPr>
-          <p:cNvPr id="15" name="Text 12"/>
-          <p:cNvSpPr/>
-          <p:nvPr/>
-        </p:nvSpPr>
-        <p:spPr>
-          <a:xfrm>
-            <a:off x="640080" y="2093976"/>
-            <a:ext cx="4069080" cy="274320"/>
-          </a:xfrm>
-          <a:prstGeom prst="rect">
-            <a:avLst/>
-          </a:prstGeom>
-          <a:noFill/>
-          <a:ln/>
-        </p:spPr>
-        <p:txBody>
-          <a:bodyPr wrap="square" lIns="0" tIns="0" rIns="0" bIns="0" rtlCol="0" anchor="ctr"/>
-          <a:lstStyle/>
-          <a:p>
-            <a:pPr marL="0" indent="0">
-              <a:buNone/>
-            </a:pPr>
-            <a:r>
-              <a:rPr lang="en-US" b="1" dirty="0">
-                <a:solidFill>
-                  <a:srgbClr val="FFFFFF"/>
-                </a:solidFill>
-                <a:latin typeface="Trebuchet MS" pitchFamily="34" charset="0"/>
-                <a:ea typeface="Trebuchet MS" pitchFamily="34" charset="-122"/>
-                <a:cs typeface="Trebuchet MS" pitchFamily="34" charset="-120"/>
-              </a:rPr>
-              <a:t>Auto</a:t>
-            </a:r>
-            <a:r>
-              <a:rPr lang="hu-HU" b="1" dirty="0" err="1">
-                <a:solidFill>
-                  <a:srgbClr val="FFFFFF"/>
-                </a:solidFill>
-                <a:latin typeface="Trebuchet MS" pitchFamily="34" charset="0"/>
-                <a:ea typeface="Trebuchet MS" pitchFamily="34" charset="-122"/>
-                <a:cs typeface="Trebuchet MS" pitchFamily="34" charset="-120"/>
-              </a:rPr>
-              <a:t>matikus</a:t>
-            </a:r>
-            <a:r>
-              <a:rPr lang="en-US" b="1" dirty="0">
-                <a:solidFill>
-                  <a:srgbClr val="FFFFFF"/>
-                </a:solidFill>
-                <a:latin typeface="Trebuchet MS" pitchFamily="34" charset="0"/>
-                <a:ea typeface="Trebuchet MS" pitchFamily="34" charset="-122"/>
-                <a:cs typeface="Trebuchet MS" pitchFamily="34" charset="-120"/>
-              </a:rPr>
-              <a:t> token kezelés</a:t>
-            </a:r>
-            <a:endParaRPr lang="en-US" dirty="0"/>
-          </a:p>
-        </p:txBody>
-      </p:sp>
-      <p:sp>
-        <p:nvSpPr>
-          <p:cNvPr id="16" name="Text 13"/>
-          <p:cNvSpPr/>
-          <p:nvPr/>
-        </p:nvSpPr>
-        <p:spPr>
-          <a:xfrm>
-            <a:off x="640080" y="2395728"/>
-            <a:ext cx="4069080" cy="237744"/>
-          </a:xfrm>
-          <a:prstGeom prst="rect">
-            <a:avLst/>
-          </a:prstGeom>
-          <a:noFill/>
-          <a:ln/>
-        </p:spPr>
-        <p:txBody>
-          <a:bodyPr wrap="square" lIns="0" tIns="0" rIns="0" bIns="0" rtlCol="0" anchor="ctr"/>
-          <a:lstStyle/>
-          <a:p>
-            <a:pPr marL="0" indent="0">
-              <a:buNone/>
-            </a:pPr>
-            <a:endParaRPr lang="en-US" sz="1400" dirty="0"/>
-          </a:p>
-        </p:txBody>
-      </p:sp>
-      <p:sp>
-        <p:nvSpPr>
-          <p:cNvPr id="17" name="Shape 14"/>
-          <p:cNvSpPr/>
-          <p:nvPr/>
-        </p:nvSpPr>
-        <p:spPr>
-          <a:xfrm>
-            <a:off x="457200" y="2798064"/>
-            <a:ext cx="4389120" cy="658368"/>
-          </a:xfrm>
-          <a:prstGeom prst="rect">
-            <a:avLst/>
-          </a:prstGeom>
-          <a:solidFill>
-            <a:srgbClr val="1A2B42"/>
-          </a:solidFill>
-          <a:ln w="9525">
-            <a:solidFill>
-              <a:srgbClr val="1F3050"/>
-            </a:solidFill>
-            <a:prstDash val="solid"/>
-          </a:ln>
-          <a:effectLst>
-            <a:outerShdw blurRad="101600" dist="25400" dir="8100000" algn="bl" rotWithShape="0">
-              <a:srgbClr val="000000">
-                <a:alpha val="30000"/>
-              </a:srgbClr>
-            </a:outerShdw>
-          </a:effectLst>
-        </p:spPr>
-        <p:txBody>
-          <a:bodyPr/>
-          <a:lstStyle/>
-          <a:p>
-            <a:endParaRPr lang="hu-HU"/>
-          </a:p>
-        </p:txBody>
-      </p:sp>
-      <p:sp>
-        <p:nvSpPr>
-          <p:cNvPr id="18" name="Shape 15"/>
-          <p:cNvSpPr/>
-          <p:nvPr/>
-        </p:nvSpPr>
-        <p:spPr>
-          <a:xfrm>
-            <a:off x="457200" y="2798064"/>
-            <a:ext cx="45720" cy="658368"/>
-          </a:xfrm>
-          <a:prstGeom prst="rect">
-            <a:avLst/>
-          </a:prstGeom>
-          <a:solidFill>
-            <a:srgbClr val="E9A227"/>
-          </a:solidFill>
-          <a:ln w="12700">
-            <a:solidFill>
-              <a:srgbClr val="E9A227"/>
-            </a:solidFill>
-            <a:prstDash val="solid"/>
-          </a:ln>
-        </p:spPr>
-        <p:txBody>
-          <a:bodyPr/>
-          <a:lstStyle/>
-          <a:p>
-            <a:endParaRPr lang="hu-HU"/>
-          </a:p>
-        </p:txBody>
-      </p:sp>
-      <p:sp>
-        <p:nvSpPr>
-          <p:cNvPr id="19" name="Text 16"/>
-          <p:cNvSpPr/>
-          <p:nvPr/>
-        </p:nvSpPr>
-        <p:spPr>
-          <a:xfrm>
-            <a:off x="640080" y="2862072"/>
-            <a:ext cx="4069080" cy="274320"/>
-          </a:xfrm>
-          <a:prstGeom prst="rect">
-            <a:avLst/>
-          </a:prstGeom>
-          <a:noFill/>
-          <a:ln/>
-        </p:spPr>
-        <p:txBody>
-          <a:bodyPr wrap="square" lIns="0" tIns="0" rIns="0" bIns="0" rtlCol="0" anchor="ctr"/>
-          <a:lstStyle/>
-          <a:p>
-            <a:pPr marL="0" indent="0">
-              <a:buNone/>
-            </a:pPr>
-            <a:r>
-              <a:rPr lang="en-US" b="1" dirty="0">
-                <a:solidFill>
-                  <a:srgbClr val="FFFFFF"/>
-                </a:solidFill>
-                <a:latin typeface="Trebuchet MS" pitchFamily="34" charset="0"/>
-                <a:ea typeface="Trebuchet MS" pitchFamily="34" charset="-122"/>
-                <a:cs typeface="Trebuchet MS" pitchFamily="34" charset="-120"/>
-              </a:rPr>
-              <a:t>Content-Type</a:t>
-            </a:r>
-            <a:endParaRPr lang="en-US" dirty="0"/>
-          </a:p>
-        </p:txBody>
-      </p:sp>
-      <p:sp>
-        <p:nvSpPr>
-          <p:cNvPr id="20" name="Text 17"/>
-          <p:cNvSpPr/>
-          <p:nvPr/>
-        </p:nvSpPr>
-        <p:spPr>
-          <a:xfrm>
-            <a:off x="640080" y="3163824"/>
-            <a:ext cx="4069080" cy="237744"/>
-          </a:xfrm>
-          <a:prstGeom prst="rect">
-            <a:avLst/>
-          </a:prstGeom>
-          <a:noFill/>
-          <a:ln/>
-        </p:spPr>
-        <p:txBody>
-          <a:bodyPr wrap="square" lIns="0" tIns="0" rIns="0" bIns="0" rtlCol="0" anchor="ctr"/>
-          <a:lstStyle/>
-          <a:p>
-            <a:pPr marL="0" indent="0">
-              <a:buNone/>
-            </a:pPr>
-            <a:endParaRPr lang="en-US" sz="1400" dirty="0"/>
-          </a:p>
-        </p:txBody>
-      </p:sp>
-      <p:sp>
-        <p:nvSpPr>
-          <p:cNvPr id="21" name="Shape 18"/>
-          <p:cNvSpPr/>
-          <p:nvPr/>
-        </p:nvSpPr>
-        <p:spPr>
-          <a:xfrm>
-            <a:off x="457200" y="3566160"/>
-            <a:ext cx="4389120" cy="658368"/>
-          </a:xfrm>
-          <a:prstGeom prst="rect">
-            <a:avLst/>
-          </a:prstGeom>
-          <a:solidFill>
-            <a:srgbClr val="1A2B42"/>
-          </a:solidFill>
-          <a:ln w="9525">
-            <a:solidFill>
-              <a:srgbClr val="1F3050"/>
-            </a:solidFill>
-            <a:prstDash val="solid"/>
-          </a:ln>
-          <a:effectLst>
-            <a:outerShdw blurRad="101600" dist="25400" dir="8100000" algn="bl" rotWithShape="0">
-              <a:srgbClr val="000000">
-                <a:alpha val="30000"/>
-              </a:srgbClr>
-            </a:outerShdw>
-          </a:effectLst>
-        </p:spPr>
-        <p:txBody>
-          <a:bodyPr/>
-          <a:lstStyle/>
-          <a:p>
-            <a:endParaRPr lang="hu-HU"/>
-          </a:p>
-        </p:txBody>
-      </p:sp>
-      <p:sp>
-        <p:nvSpPr>
-          <p:cNvPr id="22" name="Shape 19"/>
-          <p:cNvSpPr/>
-          <p:nvPr/>
-        </p:nvSpPr>
-        <p:spPr>
-          <a:xfrm>
-            <a:off x="457200" y="3566160"/>
-            <a:ext cx="45720" cy="658368"/>
-          </a:xfrm>
-          <a:prstGeom prst="rect">
-            <a:avLst/>
-          </a:prstGeom>
-          <a:solidFill>
-            <a:srgbClr val="E9A227"/>
-          </a:solidFill>
-          <a:ln w="12700">
-            <a:solidFill>
-              <a:srgbClr val="E9A227"/>
-            </a:solidFill>
-            <a:prstDash val="solid"/>
-          </a:ln>
-        </p:spPr>
-        <p:txBody>
-          <a:bodyPr/>
-          <a:lstStyle/>
-          <a:p>
-            <a:endParaRPr lang="hu-HU"/>
-          </a:p>
-        </p:txBody>
-      </p:sp>
-      <p:sp>
-        <p:nvSpPr>
-          <p:cNvPr id="23" name="Text 20"/>
-          <p:cNvSpPr/>
-          <p:nvPr/>
-        </p:nvSpPr>
-        <p:spPr>
-          <a:xfrm>
-            <a:off x="640080" y="3630168"/>
-            <a:ext cx="4069080" cy="274320"/>
-          </a:xfrm>
-          <a:prstGeom prst="rect">
-            <a:avLst/>
-          </a:prstGeom>
-          <a:noFill/>
-          <a:ln/>
-        </p:spPr>
-        <p:txBody>
-          <a:bodyPr wrap="square" lIns="0" tIns="0" rIns="0" bIns="0" rtlCol="0" anchor="ctr"/>
-          <a:lstStyle/>
-          <a:p>
-            <a:pPr marL="0" indent="0">
-              <a:buNone/>
-            </a:pPr>
-            <a:r>
-              <a:rPr lang="en-US" b="1" dirty="0">
-                <a:solidFill>
-                  <a:srgbClr val="FFFFFF"/>
-                </a:solidFill>
-                <a:latin typeface="Trebuchet MS" pitchFamily="34" charset="0"/>
-                <a:ea typeface="Trebuchet MS" pitchFamily="34" charset="-122"/>
-                <a:cs typeface="Trebuchet MS" pitchFamily="34" charset="-120"/>
-              </a:rPr>
-              <a:t>Token lejárat</a:t>
-            </a:r>
-            <a:endParaRPr lang="en-US" dirty="0"/>
-          </a:p>
-        </p:txBody>
-      </p:sp>
-      <p:sp>
-        <p:nvSpPr>
-          <p:cNvPr id="24" name="Text 21"/>
-          <p:cNvSpPr/>
-          <p:nvPr/>
-        </p:nvSpPr>
-        <p:spPr>
-          <a:xfrm>
-            <a:off x="640080" y="3931920"/>
-            <a:ext cx="4069080" cy="237744"/>
-          </a:xfrm>
-          <a:prstGeom prst="rect">
-            <a:avLst/>
-          </a:prstGeom>
-          <a:noFill/>
-          <a:ln/>
-        </p:spPr>
-        <p:txBody>
-          <a:bodyPr wrap="square" lIns="0" tIns="0" rIns="0" bIns="0" rtlCol="0" anchor="ctr"/>
-          <a:lstStyle/>
-          <a:p>
-            <a:pPr marL="0" indent="0">
-              <a:buNone/>
-            </a:pPr>
-            <a:endParaRPr lang="en-US" sz="1400" dirty="0"/>
-          </a:p>
-        </p:txBody>
-      </p:sp>
-    </p:spTree>
   </p:cSld>
   <p:clrMapOvr>
     <a:masterClrMapping/>

</xml_diff>